<commit_message>
Add "Audit the AI" task to every worksheet + AI-literacy slide (anti AI-over-reliance)
Turn AI from a crutch into curriculum:
- Append a recurring "🤖 Audit the AI" task to all 13 teaching worksheets +
  worksheets/TEMPLATE.md — students make AI propose an exploit/fix, then critique
  what it gets wrong (insecure code, hallucinated APIs/CVEs, missed cases) and
  produce the verified version themselves. Graded on the critique.
- Add a "Using AI in this course" slide to Week 1 (disclose use; AI hallucinates +
  writes insecure code; graded on understanding via live re-demos, unique flags,
  audit-the-AI).
- Harden the pptx converter to strip single-* italics (no stray asterisks) and add
  a WEEK= filter to rebuild a single deck. Rebuilt the affected decks (1,2,3,4,13).

Co-Authored-By: Claude Opus 4.8 <noreply@anthropic.com>
</commit_message>
<xml_diff>
--- a/slides/pptx/week01.pptx
+++ b/slides/pptx/week01.pptx
@@ -20,9 +20,10 @@
     <p:sldId id="268" r:id="rId14"/>
     <p:sldId id="269" r:id="rId15"/>
     <p:sldId id="270" r:id="rId16"/>
+    <p:sldId id="271" r:id="rId17"/>
   </p:sldIdLst>
   <p:notesMasterIdLst>
-    <p:notesMasterId r:id="rId17"/>
+    <p:notesMasterId r:id="rId18"/>
   </p:notesMasterIdLst>
   <p:sldSz cx="9144000" cy="5143500"/>
   <p:notesSz cx="5143500" cy="9144000"/>
@@ -1068,6 +1069,94 @@
             <a:fld id="{F7021451-1387-4CA6-816F-3879F97B5CBC}" type="slidenum">
               <a:rPr lang="en-US"/>
               <a:t>15</a:t>
+            </a:fld>
+            <a:endParaRPr lang="en-US"/>
+          </a:p>
+        </p:txBody>
+      </p:sp>
+    </p:spTree>
+    <p:extLst>
+      <p:ext uri="{BB962C8B-B14F-4D97-AF65-F5344CB8AC3E}">
+        <p14:creationId xmlns:p14="http://schemas.microsoft.com/office/powerpoint/2010/main" val="1024086991"/>
+      </p:ext>
+    </p:extLst>
+  </p:cSld>
+  <p:clrMapOvr>
+    <a:masterClrMapping/>
+  </p:clrMapOvr>
+</p:notes>
+</file>
+
+<file path=ppt/notesSlides/notesSlide16.xml><?xml version="1.0" encoding="utf-8"?>
+<p:notes xmlns:a="http://schemas.openxmlformats.org/drawingml/2006/main" xmlns:r="http://schemas.openxmlformats.org/officeDocument/2006/relationships" xmlns:p="http://schemas.openxmlformats.org/presentationml/2006/main">
+  <p:cSld>
+    <p:spTree>
+      <p:nvGrpSpPr>
+        <p:cNvPr id="1" name=""/>
+        <p:cNvGrpSpPr/>
+        <p:nvPr/>
+      </p:nvGrpSpPr>
+      <p:grpSpPr>
+        <a:xfrm>
+          <a:off x="0" y="0"/>
+          <a:ext cx="0" cy="0"/>
+          <a:chOff x="0" y="0"/>
+          <a:chExt cx="0" cy="0"/>
+        </a:xfrm>
+      </p:grpSpPr>
+      <p:sp>
+        <p:nvSpPr>
+          <p:cNvPr id="2" name="Slide Image Placeholder 1"/>
+          <p:cNvSpPr>
+            <a:spLocks noGrp="1" noRot="1" noChangeAspect="1"/>
+          </p:cNvSpPr>
+          <p:nvPr>
+            <p:ph type="sldImg"/>
+          </p:nvPr>
+        </p:nvSpPr>
+        <p:spPr/>
+      </p:sp>
+      <p:sp>
+        <p:nvSpPr>
+          <p:cNvPr id="3" name="Notes Placeholder 2"/>
+          <p:cNvSpPr>
+            <a:spLocks noGrp="1"/>
+          </p:cNvSpPr>
+          <p:nvPr>
+            <p:ph type="body" idx="1"/>
+          </p:nvPr>
+        </p:nvSpPr>
+        <p:spPr/>
+        <p:txBody>
+          <a:bodyPr/>
+          <a:lstStyle/>
+          <a:p>
+            <a:r>
+              <a:rPr lang="en-US" dirty="0"/>
+              <a:t/>
+            </a:r>
+            <a:endParaRPr lang="en-US" dirty="0"/>
+          </a:p>
+        </p:txBody>
+      </p:sp>
+      <p:sp>
+        <p:nvSpPr>
+          <p:cNvPr id="4" name="Slide Number Placeholder 3"/>
+          <p:cNvSpPr>
+            <a:spLocks noGrp="1"/>
+          </p:cNvSpPr>
+          <p:nvPr>
+            <p:ph type="sldNum" sz="quarter" idx="10"/>
+          </p:nvPr>
+        </p:nvSpPr>
+        <p:spPr/>
+        <p:txBody>
+          <a:bodyPr/>
+          <a:lstStyle/>
+          <a:p>
+            <a:fld id="{F7021451-1387-4CA6-816F-3879F97B5CBC}" type="slidenum">
+              <a:rPr lang="en-US"/>
+              <a:t>16</a:t>
             </a:fld>
             <a:endParaRPr lang="en-US"/>
           </a:p>
@@ -2482,7 +2571,7 @@
                 <a:ea typeface="Calibri" pitchFamily="34" charset="-122"/>
                 <a:cs typeface="Calibri" pitchFamily="34" charset="-120"/>
               </a:rPr>
-              <a:t>Some bugs are *design* flaws, not coding slips</a:t>
+              <a:t>Some bugs are design flaws, not coding slips</a:t>
             </a:r>
             <a:endParaRPr lang="en-US" sz="1400" dirty="0"/>
           </a:p>
@@ -2524,7 +2613,7 @@
                 <a:ea typeface="Calibri" pitchFamily="34" charset="-122"/>
                 <a:cs typeface="Calibri" pitchFamily="34" charset="-120"/>
               </a:rPr>
-              <a:t>Threat modeling catches these *before* code exists</a:t>
+              <a:t>Threat modeling catches these before code exists</a:t>
             </a:r>
             <a:endParaRPr lang="en-US" sz="1400" dirty="0"/>
           </a:p>
@@ -4338,7 +4427,7 @@
                 <a:ea typeface="Arial" pitchFamily="34" charset="-122"/>
                 <a:cs typeface="Arial" pitchFamily="34" charset="-120"/>
               </a:rPr>
-              <a:t>Key takeaways</a:t>
+              <a:t>Using AI in this course</a:t>
             </a:r>
             <a:endParaRPr lang="en-US" sz="2600" dirty="0"/>
           </a:p>
@@ -4353,11 +4442,11 @@
         <p:spPr>
           <a:xfrm>
             <a:off x="457200" y="1325880"/>
-            <a:ext cx="8229600" cy="1207008"/>
+            <a:ext cx="8229600" cy="2450592"/>
           </a:xfrm>
           <a:prstGeom prst="roundRect">
             <a:avLst>
-              <a:gd name="adj" fmla="val 6061"/>
+              <a:gd name="adj" fmla="val 2985"/>
             </a:avLst>
           </a:prstGeom>
           <a:solidFill>
@@ -4382,7 +4471,7 @@
         <p:spPr>
           <a:xfrm>
             <a:off x="731520" y="1435608"/>
-            <a:ext cx="7680960" cy="987552"/>
+            <a:ext cx="7680960" cy="2231136"/>
           </a:xfrm>
           <a:prstGeom prst="rect">
             <a:avLst/>
@@ -4410,7 +4499,7 @@
                 <a:ea typeface="Calibri" pitchFamily="34" charset="-122"/>
                 <a:cs typeface="Calibri" pitchFamily="34" charset="-120"/>
               </a:rPr>
-              <a:t>Design for security; don't bolt it on</a:t>
+              <a:t>AI is allowed — and you must disclose how you used it</a:t>
             </a:r>
             <a:endParaRPr lang="en-US" sz="1400" dirty="0"/>
           </a:p>
@@ -4431,7 +4520,7 @@
                 <a:ea typeface="Calibri" pitchFamily="34" charset="-122"/>
                 <a:cs typeface="Calibri" pitchFamily="34" charset="-120"/>
               </a:rPr>
-              <a:t>Attackers need one gap — model the whole surface</a:t>
+              <a:t>But AI hallucinates APIs/CVEs and writes insecure code</a:t>
             </a:r>
             <a:endParaRPr lang="en-US" sz="1400" dirty="0"/>
           </a:p>
@@ -4452,7 +4541,91 @@
                 <a:ea typeface="Calibri" pitchFamily="34" charset="-122"/>
                 <a:cs typeface="Calibri" pitchFamily="34" charset="-120"/>
               </a:rPr>
-              <a:t>STRIDE + DFD = a repeatable way to find design flaws</a:t>
+              <a:t>You're graded on understanding, not on the answer:</a:t>
+            </a:r>
+            <a:endParaRPr lang="en-US" sz="1400" dirty="0"/>
+          </a:p>
+          <a:p>
+            <a:pPr lvl="1" marL="685800" indent="-342900">
+              <a:spcAft>
+                <a:spcPts val="600"/>
+              </a:spcAft>
+              <a:buSzPct val="100000"/>
+              <a:buChar char="•"/>
+            </a:pPr>
+            <a:r>
+              <a:rPr lang="en-US" sz="1400" dirty="0">
+                <a:solidFill>
+                  <a:srgbClr val="E6EDF3"/>
+                </a:solidFill>
+                <a:latin typeface="Calibri" pitchFamily="34" charset="0"/>
+                <a:ea typeface="Calibri" pitchFamily="34" charset="-122"/>
+                <a:cs typeface="Calibri" pitchFamily="34" charset="-120"/>
+              </a:rPr>
+              <a:t>random live re-demos — explain it or score zero</a:t>
+            </a:r>
+            <a:endParaRPr lang="en-US" sz="1400" dirty="0"/>
+          </a:p>
+          <a:p>
+            <a:pPr lvl="1" marL="685800" indent="-342900">
+              <a:spcAft>
+                <a:spcPts val="600"/>
+              </a:spcAft>
+              <a:buSzPct val="100000"/>
+              <a:buChar char="•"/>
+            </a:pPr>
+            <a:r>
+              <a:rPr lang="en-US" sz="1400" dirty="0">
+                <a:solidFill>
+                  <a:srgbClr val="E6EDF3"/>
+                </a:solidFill>
+                <a:latin typeface="Calibri" pitchFamily="34" charset="0"/>
+                <a:ea typeface="Calibri" pitchFamily="34" charset="-122"/>
+                <a:cs typeface="Calibri" pitchFamily="34" charset="-120"/>
+              </a:rPr>
+              <a:t>your flags are unique to you — copying is traceable</a:t>
+            </a:r>
+            <a:endParaRPr lang="en-US" sz="1400" dirty="0"/>
+          </a:p>
+          <a:p>
+            <a:pPr lvl="1" marL="685800" indent="-342900">
+              <a:spcAft>
+                <a:spcPts val="600"/>
+              </a:spcAft>
+              <a:buSzPct val="100000"/>
+              <a:buChar char="•"/>
+            </a:pPr>
+            <a:r>
+              <a:rPr lang="en-US" sz="1400" dirty="0">
+                <a:solidFill>
+                  <a:srgbClr val="E6EDF3"/>
+                </a:solidFill>
+                <a:latin typeface="Calibri" pitchFamily="34" charset="0"/>
+                <a:ea typeface="Calibri" pitchFamily="34" charset="-122"/>
+                <a:cs typeface="Calibri" pitchFamily="34" charset="-120"/>
+              </a:rPr>
+              <a:t>every lab has an “Audit the AI” task: find what its answer gets wrong</a:t>
+            </a:r>
+            <a:endParaRPr lang="en-US" sz="1400" dirty="0"/>
+          </a:p>
+          <a:p>
+            <a:pPr marL="342900" indent="-342900">
+              <a:spcAft>
+                <a:spcPts val="600"/>
+              </a:spcAft>
+              <a:buSzPct val="100000"/>
+              <a:buChar char="•"/>
+            </a:pPr>
+            <a:r>
+              <a:rPr lang="en-US" sz="1400" dirty="0">
+                <a:solidFill>
+                  <a:srgbClr val="E6EDF3"/>
+                </a:solidFill>
+                <a:latin typeface="Calibri" pitchFamily="34" charset="0"/>
+                <a:ea typeface="Calibri" pitchFamily="34" charset="-122"/>
+                <a:cs typeface="Calibri" pitchFamily="34" charset="-120"/>
+              </a:rPr>
+              <a:t>Use AI to learn faster — never to skip the thinking</a:t>
             </a:r>
             <a:endParaRPr lang="en-US" sz="1400" dirty="0"/>
           </a:p>
@@ -4584,6 +4757,334 @@
       </p:grpSpPr>
       <p:sp>
         <p:nvSpPr>
+          <p:cNvPr id="2" name="Shape 0"/>
+          <p:cNvSpPr/>
+          <p:nvPr/>
+        </p:nvSpPr>
+        <p:spPr>
+          <a:xfrm>
+            <a:off x="457200" y="384048"/>
+            <a:ext cx="530352" cy="530352"/>
+          </a:xfrm>
+          <a:prstGeom prst="ellipse">
+            <a:avLst/>
+          </a:prstGeom>
+          <a:solidFill>
+            <a:srgbClr val="E35205"/>
+          </a:solidFill>
+          <a:ln/>
+          <a:effectLst>
+            <a:outerShdw sx="100000" sy="100000" kx="0" ky="0" algn="bl" rotWithShape="0" blurRad="101600" dist="38100" dir="5400000">
+              <a:srgbClr val="000000">
+                <a:alpha val="35000"/>
+              </a:srgbClr>
+            </a:outerShdw>
+          </a:effectLst>
+        </p:spPr>
+      </p:sp>
+      <p:pic>
+        <p:nvPicPr>
+          <p:cNvPr id="3" name="Image 0" descr="preencoded.png">    </p:cNvPr>
+          <p:cNvPicPr>
+            <a:picLocks noChangeAspect="1"/>
+          </p:cNvPicPr>
+          <p:nvPr/>
+        </p:nvPicPr>
+        <p:blipFill>
+          <a:blip r:embed="rId1"/>
+          <a:stretch>
+            <a:fillRect/>
+          </a:stretch>
+        </p:blipFill>
+        <p:spPr>
+          <a:xfrm>
+            <a:off x="594360" y="521208"/>
+            <a:ext cx="256032" cy="256032"/>
+          </a:xfrm>
+          <a:prstGeom prst="rect">
+            <a:avLst/>
+          </a:prstGeom>
+        </p:spPr>
+      </p:pic>
+      <p:sp>
+        <p:nvSpPr>
+          <p:cNvPr id="4" name="Text 1"/>
+          <p:cNvSpPr/>
+          <p:nvPr/>
+        </p:nvSpPr>
+        <p:spPr>
+          <a:xfrm>
+            <a:off x="1143000" y="329184"/>
+            <a:ext cx="7498080" cy="603504"/>
+          </a:xfrm>
+          <a:prstGeom prst="rect">
+            <a:avLst/>
+          </a:prstGeom>
+          <a:noFill/>
+          <a:ln/>
+        </p:spPr>
+        <p:txBody>
+          <a:bodyPr wrap="square" lIns="0" tIns="0" rIns="0" bIns="0" rtlCol="0" anchor="ctr"/>
+          <a:lstStyle/>
+          <a:p>
+            <a:pPr indent="0" marL="0">
+              <a:buNone/>
+            </a:pPr>
+            <a:r>
+              <a:rPr lang="en-US" sz="2600" b="1" dirty="0">
+                <a:solidFill>
+                  <a:srgbClr val="E6EDF3"/>
+                </a:solidFill>
+                <a:latin typeface="Arial" pitchFamily="34" charset="0"/>
+                <a:ea typeface="Arial" pitchFamily="34" charset="-122"/>
+                <a:cs typeface="Arial" pitchFamily="34" charset="-120"/>
+              </a:rPr>
+              <a:t>Key takeaways</a:t>
+            </a:r>
+            <a:endParaRPr lang="en-US" sz="2600" dirty="0"/>
+          </a:p>
+        </p:txBody>
+      </p:sp>
+      <p:sp>
+        <p:nvSpPr>
+          <p:cNvPr id="5" name="Shape 2"/>
+          <p:cNvSpPr/>
+          <p:nvPr/>
+        </p:nvSpPr>
+        <p:spPr>
+          <a:xfrm>
+            <a:off x="457200" y="1325880"/>
+            <a:ext cx="8229600" cy="1207008"/>
+          </a:xfrm>
+          <a:prstGeom prst="roundRect">
+            <a:avLst>
+              <a:gd name="adj" fmla="val 6061"/>
+            </a:avLst>
+          </a:prstGeom>
+          <a:solidFill>
+            <a:srgbClr val="18243A"/>
+          </a:solidFill>
+          <a:ln/>
+          <a:effectLst>
+            <a:outerShdw sx="100000" sy="100000" kx="0" ky="0" algn="bl" rotWithShape="0" blurRad="101600" dist="38100" dir="5400000">
+              <a:srgbClr val="000000">
+                <a:alpha val="35000"/>
+              </a:srgbClr>
+            </a:outerShdw>
+          </a:effectLst>
+        </p:spPr>
+      </p:sp>
+      <p:sp>
+        <p:nvSpPr>
+          <p:cNvPr id="6" name="Text 3"/>
+          <p:cNvSpPr/>
+          <p:nvPr/>
+        </p:nvSpPr>
+        <p:spPr>
+          <a:xfrm>
+            <a:off x="731520" y="1435608"/>
+            <a:ext cx="7680960" cy="987552"/>
+          </a:xfrm>
+          <a:prstGeom prst="rect">
+            <a:avLst/>
+          </a:prstGeom>
+          <a:noFill/>
+          <a:ln/>
+        </p:spPr>
+        <p:txBody>
+          <a:bodyPr wrap="square" lIns="0" tIns="0" rIns="0" bIns="0" rtlCol="0" anchor="t"/>
+          <a:lstStyle/>
+          <a:p>
+            <a:pPr marL="342900" indent="-342900">
+              <a:spcAft>
+                <a:spcPts val="600"/>
+              </a:spcAft>
+              <a:buSzPct val="100000"/>
+              <a:buChar char="•"/>
+            </a:pPr>
+            <a:r>
+              <a:rPr lang="en-US" sz="1400" dirty="0">
+                <a:solidFill>
+                  <a:srgbClr val="E6EDF3"/>
+                </a:solidFill>
+                <a:latin typeface="Calibri" pitchFamily="34" charset="0"/>
+                <a:ea typeface="Calibri" pitchFamily="34" charset="-122"/>
+                <a:cs typeface="Calibri" pitchFamily="34" charset="-120"/>
+              </a:rPr>
+              <a:t>Design for security; don't bolt it on</a:t>
+            </a:r>
+            <a:endParaRPr lang="en-US" sz="1400" dirty="0"/>
+          </a:p>
+          <a:p>
+            <a:pPr marL="342900" indent="-342900">
+              <a:spcAft>
+                <a:spcPts val="600"/>
+              </a:spcAft>
+              <a:buSzPct val="100000"/>
+              <a:buChar char="•"/>
+            </a:pPr>
+            <a:r>
+              <a:rPr lang="en-US" sz="1400" dirty="0">
+                <a:solidFill>
+                  <a:srgbClr val="E6EDF3"/>
+                </a:solidFill>
+                <a:latin typeface="Calibri" pitchFamily="34" charset="0"/>
+                <a:ea typeface="Calibri" pitchFamily="34" charset="-122"/>
+                <a:cs typeface="Calibri" pitchFamily="34" charset="-120"/>
+              </a:rPr>
+              <a:t>Attackers need one gap — model the whole surface</a:t>
+            </a:r>
+            <a:endParaRPr lang="en-US" sz="1400" dirty="0"/>
+          </a:p>
+          <a:p>
+            <a:pPr marL="342900" indent="-342900">
+              <a:spcAft>
+                <a:spcPts val="600"/>
+              </a:spcAft>
+              <a:buSzPct val="100000"/>
+              <a:buChar char="•"/>
+            </a:pPr>
+            <a:r>
+              <a:rPr lang="en-US" sz="1400" dirty="0">
+                <a:solidFill>
+                  <a:srgbClr val="E6EDF3"/>
+                </a:solidFill>
+                <a:latin typeface="Calibri" pitchFamily="34" charset="0"/>
+                <a:ea typeface="Calibri" pitchFamily="34" charset="-122"/>
+                <a:cs typeface="Calibri" pitchFamily="34" charset="-120"/>
+              </a:rPr>
+              <a:t>STRIDE + DFD = a repeatable way to find design flaws</a:t>
+            </a:r>
+            <a:endParaRPr lang="en-US" sz="1400" dirty="0"/>
+          </a:p>
+        </p:txBody>
+      </p:sp>
+      <p:sp>
+        <p:nvSpPr>
+          <p:cNvPr id="7" name="Text 4"/>
+          <p:cNvSpPr/>
+          <p:nvPr/>
+        </p:nvSpPr>
+        <p:spPr>
+          <a:xfrm>
+            <a:off x="457200" y="4800600"/>
+            <a:ext cx="6949440" cy="274320"/>
+          </a:xfrm>
+          <a:prstGeom prst="rect">
+            <a:avLst/>
+          </a:prstGeom>
+          <a:noFill/>
+          <a:ln/>
+        </p:spPr>
+        <p:txBody>
+          <a:bodyPr wrap="square" lIns="0" tIns="0" rIns="0" bIns="0" rtlCol="0" anchor="ctr"/>
+          <a:lstStyle/>
+          <a:p>
+            <a:pPr indent="0" marL="0">
+              <a:buNone/>
+            </a:pPr>
+            <a:r>
+              <a:rPr lang="en-US" sz="900" dirty="0">
+                <a:solidFill>
+                  <a:srgbClr val="94A3B8"/>
+                </a:solidFill>
+                <a:latin typeface="Calibri" pitchFamily="34" charset="0"/>
+                <a:ea typeface="Calibri" pitchFamily="34" charset="-122"/>
+                <a:cs typeface="Calibri" pitchFamily="34" charset="-120"/>
+              </a:rPr>
+              <a:t>Software Security · Week 1</a:t>
+            </a:r>
+            <a:endParaRPr lang="en-US" sz="900" dirty="0"/>
+          </a:p>
+        </p:txBody>
+      </p:sp>
+      <p:sp>
+        <p:nvSpPr>
+          <p:cNvPr id="8" name="Shape 5"/>
+          <p:cNvSpPr/>
+          <p:nvPr/>
+        </p:nvSpPr>
+        <p:spPr>
+          <a:xfrm>
+            <a:off x="7772400" y="4590288"/>
+            <a:ext cx="969264" cy="475488"/>
+          </a:xfrm>
+          <a:prstGeom prst="roundRect">
+            <a:avLst>
+              <a:gd name="adj" fmla="val 11538"/>
+            </a:avLst>
+          </a:prstGeom>
+          <a:solidFill>
+            <a:srgbClr val="FFFFFF"/>
+          </a:solidFill>
+          <a:ln/>
+          <a:effectLst>
+            <a:outerShdw sx="100000" sy="100000" kx="0" ky="0" algn="bl" rotWithShape="0" blurRad="101600" dist="38100" dir="5400000">
+              <a:srgbClr val="000000">
+                <a:alpha val="35000"/>
+              </a:srgbClr>
+            </a:outerShdw>
+          </a:effectLst>
+        </p:spPr>
+      </p:sp>
+      <p:pic>
+        <p:nvPicPr>
+          <p:cNvPr id="9" name="Image 1" descr="/Users/pop7/Library/CloudStorage/OneDrive-MonsterConnectCo.,Ltd/Lecture/KOSEN69 - software-security/slides/pptx/assets/logo-small.png">    </p:cNvPr>
+          <p:cNvPicPr>
+            <a:picLocks noChangeAspect="1"/>
+          </p:cNvPicPr>
+          <p:nvPr/>
+        </p:nvPicPr>
+        <p:blipFill>
+          <a:blip r:embed="rId2"/>
+          <a:stretch>
+            <a:fillRect/>
+          </a:stretch>
+        </p:blipFill>
+        <p:spPr>
+          <a:xfrm>
+            <a:off x="7872984" y="4681728"/>
+            <a:ext cx="768096" cy="356616"/>
+          </a:xfrm>
+          <a:prstGeom prst="rect">
+            <a:avLst/>
+          </a:prstGeom>
+        </p:spPr>
+      </p:pic>
+    </p:spTree>
+  </p:cSld>
+  <p:clrMapOvr>
+    <a:masterClrMapping/>
+  </p:clrMapOvr>
+</p:sld>
+</file>
+
+<file path=ppt/slides/slide16.xml><?xml version="1.0" encoding="utf-8"?>
+<p:sld xmlns:a="http://schemas.openxmlformats.org/drawingml/2006/main" xmlns:r="http://schemas.openxmlformats.org/officeDocument/2006/relationships" xmlns:p="http://schemas.openxmlformats.org/presentationml/2006/main">
+  <p:cSld name="Slide 16">
+    <p:bg>
+      <p:bgPr>
+        <a:solidFill>
+          <a:srgbClr val="0E1726"/>
+        </a:solidFill>
+      </p:bgPr>
+    </p:bg>
+    <p:spTree>
+      <p:nvGrpSpPr>
+        <p:cNvPr id="1" name=""/>
+        <p:cNvGrpSpPr/>
+        <p:nvPr/>
+      </p:nvGrpSpPr>
+      <p:grpSpPr>
+        <a:xfrm>
+          <a:off x="0" y="0"/>
+          <a:ext cx="0" cy="0"/>
+          <a:chOff x="0" y="0"/>
+          <a:chExt cx="0" cy="0"/>
+        </a:xfrm>
+      </p:grpSpPr>
+      <p:sp>
+        <p:nvSpPr>
           <p:cNvPr id="2" name="Text 0"/>
           <p:cNvSpPr/>
           <p:nvPr/>
@@ -5313,7 +5814,7 @@
                 <a:ea typeface="Calibri" pitchFamily="34" charset="-122"/>
                 <a:cs typeface="Calibri" pitchFamily="34" charset="-120"/>
               </a:rPr>
-              <a:t>You'll *break* sandbox targets and *defend* your own code</a:t>
+              <a:t>You'll break sandbox targets and defend your own code</a:t>
             </a:r>
             <a:endParaRPr lang="en-US" sz="1400" dirty="0"/>
           </a:p>

</xml_diff>

<commit_message>
Deepen Week 1 into a full lecture + speaker notes (exemplar)
- slides/week01.md: richer content (How-the-course-works, a worked /upload example,
  a full "STRIDE applied to /upload" pass) + per-slide speaker notes as HTML comments
  (delivery script, timing, questions to ask, misconceptions) — 17 slides.
- slides/pptx/build_all.js: converter now parses <!-- ... --> comments and emits them
  as PowerPoint speaker notes (slide.addNotes); applies to title, content, and
  big-statement slides.
- Rebuilt slides/pptx/week01.pptx: 17 notesSlide parts embedded; notes do not render
  on the visible slides. Visual QA on the new content slides: clean, no overflow.

This is the template for deepening the remaining weeks (content + notes) when desired.

Co-Authored-By: Claude Opus 4.8 <noreply@anthropic.com>
</commit_message>
<xml_diff>
--- a/slides/pptx/week01.pptx
+++ b/slides/pptx/week01.pptx
@@ -21,9 +21,10 @@
     <p:sldId id="269" r:id="rId15"/>
     <p:sldId id="270" r:id="rId16"/>
     <p:sldId id="271" r:id="rId17"/>
+    <p:sldId id="272" r:id="rId18"/>
   </p:sldIdLst>
   <p:notesMasterIdLst>
-    <p:notesMasterId r:id="rId18"/>
+    <p:notesMasterId r:id="rId19"/>
   </p:notesMasterIdLst>
   <p:sldSz cx="9144000" cy="5143500"/>
   <p:notesSz cx="5143500" cy="9144000"/>
@@ -517,7 +518,7 @@
           <a:p>
             <a:r>
               <a:rPr lang="en-US" dirty="0"/>
-              <a:t/>
+              <a:t>Welcome the class. One line: "By the end of today you'll be able to look at any system and ask the right 'what could go wrong' questions — and write them down in a way engineers can act on." Set the tone: this course is hands-on; we break things in a sandbox to learn to defend them. ~2 min.</a:t>
             </a:r>
             <a:endParaRPr lang="en-US" dirty="0"/>
           </a:p>
@@ -605,7 +606,7 @@
           <a:p>
             <a:r>
               <a:rPr lang="en-US" dirty="0"/>
-              <a:t/>
+              <a:t>Orient them to the references we'll cite weekly. OWASP = what to prevent; CWE = the precise weakness id (e.g., CWE-22 path traversal); ATT&amp;CK = how real adversaries operate. They'll map every finding to a CWE/OWASP id all term. ~3 min.</a:t>
             </a:r>
             <a:endParaRPr lang="en-US" dirty="0"/>
           </a:p>
@@ -693,7 +694,7 @@
           <a:p>
             <a:r>
               <a:rPr lang="en-US" dirty="0"/>
-              <a:t/>
+              <a:t>Tie the mindset to the current policy moment (CISA, memory-safety roadmaps). Key idea: threat modeling catches design flaws *before* code exists — cheapest place to fix. Contrast cost of fixing at design vs in production (orders of magnitude). ~4 min.</a:t>
             </a:r>
             <a:endParaRPr lang="en-US" dirty="0"/>
           </a:p>
@@ -781,7 +782,7 @@
           <a:p>
             <a:r>
               <a:rPr lang="en-US" dirty="0"/>
-              <a:t/>
+              <a:t>Explain the game before the lab: it gamifies the STRIDE pass we just did. Each suit = a STRIDE category; you play a card by naming a concrete threat on the DFD. Make it competitive (leaderboard). It lowers the barrier for students who freeze on a blank page. ~3 min.</a:t>
             </a:r>
             <a:endParaRPr lang="en-US" dirty="0"/>
           </a:p>
@@ -869,7 +870,7 @@
           <a:p>
             <a:r>
               <a:rPr lang="en-US" dirty="0"/>
-              <a:t/>
+              <a:t>Logistics — get everyone's environment working today; setup pain derails later weeks. Have TAs circulate. Tell them to fork the course repo now. This is graded only on "it runs." ~ start of lab.</a:t>
             </a:r>
             <a:endParaRPr lang="en-US" dirty="0"/>
           </a:p>
@@ -957,7 +958,7 @@
           <a:p>
             <a:r>
               <a:rPr lang="en-US" dirty="0"/>
-              <a:t/>
+              <a:t>The main lab. They repeat today's /upload worked example across the whole sample app. Remind: rank by likelihood × impact (not everything is critical), and propose a concrete mitigation each. Point them to THREAT-MODEL-TEMPLATE.md. Also: kick off the term project by threat-modeling NoteVault (see worksheet).</a:t>
             </a:r>
             <a:endParaRPr lang="en-US" dirty="0"/>
           </a:p>
@@ -1045,7 +1046,7 @@
           <a:p>
             <a:r>
               <a:rPr lang="en-US" dirty="0"/>
-              <a:t/>
+              <a:t>Address AI head-on, week 1. Frame it as a professional skill: future engineers use AI but must verify it. The Audit-the-AI task turns its weakness into the lesson. Be explicit about the integrity controls so expectations are set early. ~4 min.</a:t>
             </a:r>
             <a:endParaRPr lang="en-US" dirty="0"/>
           </a:p>
@@ -1133,7 +1134,7 @@
           <a:p>
             <a:r>
               <a:rPr lang="en-US" dirty="0"/>
-              <a:t/>
+              <a:t>Recap in 3 lines. Cold-call 2 students: "give me one STRIDE threat for a login page." Confirm they can do the lab. ~2 min.</a:t>
             </a:r>
             <a:endParaRPr lang="en-US" dirty="0"/>
           </a:p>
@@ -1157,6 +1158,94 @@
             <a:fld id="{F7021451-1387-4CA6-816F-3879F97B5CBC}" type="slidenum">
               <a:rPr lang="en-US"/>
               <a:t>16</a:t>
+            </a:fld>
+            <a:endParaRPr lang="en-US"/>
+          </a:p>
+        </p:txBody>
+      </p:sp>
+    </p:spTree>
+    <p:extLst>
+      <p:ext uri="{BB962C8B-B14F-4D97-AF65-F5344CB8AC3E}">
+        <p14:creationId xmlns:p14="http://schemas.microsoft.com/office/powerpoint/2010/main" val="1024086991"/>
+      </p:ext>
+    </p:extLst>
+  </p:cSld>
+  <p:clrMapOvr>
+    <a:masterClrMapping/>
+  </p:clrMapOvr>
+</p:notes>
+</file>
+
+<file path=ppt/notesSlides/notesSlide17.xml><?xml version="1.0" encoding="utf-8"?>
+<p:notes xmlns:a="http://schemas.openxmlformats.org/drawingml/2006/main" xmlns:r="http://schemas.openxmlformats.org/officeDocument/2006/relationships" xmlns:p="http://schemas.openxmlformats.org/presentationml/2006/main">
+  <p:cSld>
+    <p:spTree>
+      <p:nvGrpSpPr>
+        <p:cNvPr id="1" name=""/>
+        <p:cNvGrpSpPr/>
+        <p:nvPr/>
+      </p:nvGrpSpPr>
+      <p:grpSpPr>
+        <a:xfrm>
+          <a:off x="0" y="0"/>
+          <a:ext cx="0" cy="0"/>
+          <a:chOff x="0" y="0"/>
+          <a:chExt cx="0" cy="0"/>
+        </a:xfrm>
+      </p:grpSpPr>
+      <p:sp>
+        <p:nvSpPr>
+          <p:cNvPr id="2" name="Slide Image Placeholder 1"/>
+          <p:cNvSpPr>
+            <a:spLocks noGrp="1" noRot="1" noChangeAspect="1"/>
+          </p:cNvSpPr>
+          <p:nvPr>
+            <p:ph type="sldImg"/>
+          </p:nvPr>
+        </p:nvSpPr>
+        <p:spPr/>
+      </p:sp>
+      <p:sp>
+        <p:nvSpPr>
+          <p:cNvPr id="3" name="Notes Placeholder 2"/>
+          <p:cNvSpPr>
+            <a:spLocks noGrp="1"/>
+          </p:cNvSpPr>
+          <p:nvPr>
+            <p:ph type="body" idx="1"/>
+          </p:nvPr>
+        </p:nvSpPr>
+        <p:spPr/>
+        <p:txBody>
+          <a:bodyPr/>
+          <a:lstStyle/>
+          <a:p>
+            <a:r>
+              <a:rPr lang="en-US" dirty="0"/>
+              <a:t>Cliffhanger: "Next week we automate finding these bugs — and race to triage them. Get your VM working before then." Take questions; remind about the ethics acknowledgment + Lab 0.</a:t>
+            </a:r>
+            <a:endParaRPr lang="en-US" dirty="0"/>
+          </a:p>
+        </p:txBody>
+      </p:sp>
+      <p:sp>
+        <p:nvSpPr>
+          <p:cNvPr id="4" name="Slide Number Placeholder 3"/>
+          <p:cNvSpPr>
+            <a:spLocks noGrp="1"/>
+          </p:cNvSpPr>
+          <p:nvPr>
+            <p:ph type="sldNum" sz="quarter" idx="10"/>
+          </p:nvPr>
+        </p:nvSpPr>
+        <p:spPr/>
+        <p:txBody>
+          <a:bodyPr/>
+          <a:lstStyle/>
+          <a:p>
+            <a:fld id="{F7021451-1387-4CA6-816F-3879F97B5CBC}" type="slidenum">
+              <a:rPr lang="en-US"/>
+              <a:t>17</a:t>
             </a:fld>
             <a:endParaRPr lang="en-US"/>
           </a:p>
@@ -1221,7 +1310,7 @@
           <a:p>
             <a:r>
               <a:rPr lang="en-US" dirty="0"/>
-              <a:t/>
+              <a:t>Roadmap slide — 1 min. Tell them the lecture is ~2 h, then a 3 h lab where they threat-model a real app and play the card game. Flag the deliverable early: a 2–3 page threat model. Ask: "Who has heard the word 'threat model' before?" gauge the room.</a:t>
             </a:r>
             <a:endParaRPr lang="en-US" dirty="0"/>
           </a:p>
@@ -1309,7 +1398,7 @@
           <a:p>
             <a:r>
               <a:rPr lang="en-US" dirty="0"/>
-              <a:t/>
+              <a:t>Set expectations + ethics (legally important). Emphasize: every flag is unique to you; copying is traceable; you may be asked to explain your work live. Say plainly: "Attacking systems you don't own is a crime — everything here is in a sandbox you're authorized to attack." Have them read/sign the ethics acknowledgment this week. ~2 min.</a:t>
             </a:r>
             <a:endParaRPr lang="en-US" dirty="0"/>
           </a:p>
@@ -1397,7 +1486,7 @@
           <a:p>
             <a:r>
               <a:rPr lang="en-US" dirty="0"/>
-              <a:t/>
+              <a:t>Core model. Give one concrete example each: C — your medical records; I — your bank balance not silently changed; A — the hospital system up during an emergency. Ask the class to classify a breach you name (e.g., "ransomware encrypts files" → hits A and often C). Stress the tagline; it recurs all term. ~6 min.</a:t>
             </a:r>
             <a:endParaRPr lang="en-US" dirty="0"/>
           </a:p>
@@ -1485,7 +1574,7 @@
           <a:p>
             <a:r>
               <a:rPr lang="en-US" dirty="0"/>
-              <a:t/>
+              <a:t>The asymmetry is the whole reason security is hard. Contrast a "use case" (user logs in) with a "misuse case" (attacker logs in as someone else). Exercise: pick the classroom projector login and ask "how would you abuse this?" Get 3 answers. ~5 min.</a:t>
             </a:r>
             <a:endParaRPr lang="en-US" dirty="0"/>
           </a:p>
@@ -1573,7 +1662,7 @@
           <a:p>
             <a:r>
               <a:rPr lang="en-US" dirty="0"/>
-              <a:t/>
+              <a:t>Define both precisely — these terms drive the whole DFD/STRIDE method. Draw on the board: browser | (boundary) | server | (boundary) | database. Anything crossing a boundary is where you scrutinize. Ask the class to list inputs of a login page → that's its attack surface. ~6 min.</a:t>
             </a:r>
             <a:endParaRPr lang="en-US" dirty="0"/>
           </a:p>
@@ -1661,7 +1750,7 @@
           <a:p>
             <a:r>
               <a:rPr lang="en-US" dirty="0"/>
-              <a:t/>
+              <a:t>This is the "make it concrete" moment — walk the data flow on the board. Ask: "what does the app trust here?" (it trusts the filename). Show how a crafted filename escapes the folder. We'll STRIDE this exact element next slide. This worked example is what makes the abstract method click. ~7 min.</a:t>
             </a:r>
             <a:endParaRPr lang="en-US" dirty="0"/>
           </a:p>
@@ -1749,7 +1838,7 @@
           <a:p>
             <a:r>
               <a:rPr lang="en-US" dirty="0"/>
-              <a:t/>
+              <a:t>STRIDE is a checklist so you don't forget a category. Go letter by letter, 1 example each, ideally tied to /upload: T = swap a file; I = read another user's upload; D = upload a 10 GB file; E = upload a .php and execute it. Tell them: apply STRIDE to every element of the DFD. ~8 min.</a:t>
             </a:r>
             <a:endParaRPr lang="en-US" dirty="0"/>
           </a:p>
@@ -1837,7 +1926,7 @@
           <a:p>
             <a:r>
               <a:rPr lang="en-US" dirty="0"/>
-              <a:t/>
+              <a:t>Pay-off slide: the full STRIDE pass on one element. Let the class call out threats before revealing each line. This models exactly what they'll do in the lab. End with: "6 threats from ONE endpoint — now imagine the whole app." ~6 min.</a:t>
             </a:r>
             <a:endParaRPr lang="en-US" dirty="0"/>
           </a:p>
@@ -2499,7 +2588,7 @@
                 <a:ea typeface="Arial" pitchFamily="34" charset="-122"/>
                 <a:cs typeface="Arial" pitchFamily="34" charset="-120"/>
               </a:rPr>
-              <a:t>Insecure Design (A06:2025)</a:t>
+              <a:t>The landscape you'll use all term</a:t>
             </a:r>
             <a:endParaRPr lang="en-US" sz="2600" dirty="0"/>
           </a:p>
@@ -2514,11 +2603,11 @@
         <p:spPr>
           <a:xfrm>
             <a:off x="457200" y="1325880"/>
-            <a:ext cx="8229600" cy="1207008"/>
+            <a:ext cx="8229600" cy="1517904"/>
           </a:xfrm>
           <a:prstGeom prst="roundRect">
             <a:avLst>
-              <a:gd name="adj" fmla="val 6061"/>
+              <a:gd name="adj" fmla="val 4819"/>
             </a:avLst>
           </a:prstGeom>
           <a:solidFill>
@@ -2543,7 +2632,7 @@
         <p:spPr>
           <a:xfrm>
             <a:off x="731520" y="1435608"/>
-            <a:ext cx="7680960" cy="987552"/>
+            <a:ext cx="7680960" cy="1298448"/>
           </a:xfrm>
           <a:prstGeom prst="rect">
             <a:avLst/>
@@ -2571,7 +2660,7 @@
                 <a:ea typeface="Calibri" pitchFamily="34" charset="-122"/>
                 <a:cs typeface="Calibri" pitchFamily="34" charset="-120"/>
               </a:rPr>
-              <a:t>Some bugs are design flaws, not coding slips</a:t>
+              <a:t>OWASP Top 10 (2025) — most critical web risks</a:t>
             </a:r>
             <a:endParaRPr lang="en-US" sz="1400" dirty="0"/>
           </a:p>
@@ -2592,7 +2681,7 @@
                 <a:ea typeface="Calibri" pitchFamily="34" charset="-122"/>
                 <a:cs typeface="Calibri" pitchFamily="34" charset="-120"/>
               </a:rPr>
-              <a:t>Missing trust boundary, no rate limiting, dangerous defaults</a:t>
+              <a:t>OWASP LLM Top 10 (2025) — AI app risks</a:t>
             </a:r>
             <a:endParaRPr lang="en-US" sz="1400" dirty="0"/>
           </a:p>
@@ -2613,7 +2702,28 @@
                 <a:ea typeface="Calibri" pitchFamily="34" charset="-122"/>
                 <a:cs typeface="Calibri" pitchFamily="34" charset="-120"/>
               </a:rPr>
-              <a:t>Threat modeling catches these before code exists</a:t>
+              <a:t>MITRE CWE — catalogue of weaknesses</a:t>
+            </a:r>
+            <a:endParaRPr lang="en-US" sz="1400" dirty="0"/>
+          </a:p>
+          <a:p>
+            <a:pPr marL="342900" indent="-342900">
+              <a:spcAft>
+                <a:spcPts val="600"/>
+              </a:spcAft>
+              <a:buSzPct val="100000"/>
+              <a:buChar char="•"/>
+            </a:pPr>
+            <a:r>
+              <a:rPr lang="en-US" sz="1400" dirty="0">
+                <a:solidFill>
+                  <a:srgbClr val="E6EDF3"/>
+                </a:solidFill>
+                <a:latin typeface="Calibri" pitchFamily="34" charset="0"/>
+                <a:ea typeface="Calibri" pitchFamily="34" charset="-122"/>
+                <a:cs typeface="Calibri" pitchFamily="34" charset="-120"/>
+              </a:rPr>
+              <a:t>MITRE ATT&amp;CK — adversary tactics &amp; techniques</a:t>
             </a:r>
             <a:endParaRPr lang="en-US" sz="1400" dirty="0"/>
           </a:p>
@@ -2827,7 +2937,7 @@
                 <a:ea typeface="Arial" pitchFamily="34" charset="-122"/>
                 <a:cs typeface="Arial" pitchFamily="34" charset="-120"/>
               </a:rPr>
-              <a:t>🎲 Game — Elevation of Privilege</a:t>
+              <a:t>Secure by Design</a:t>
             </a:r>
             <a:endParaRPr lang="en-US" sz="2600" dirty="0"/>
           </a:p>
@@ -2899,7 +3009,7 @@
                 <a:ea typeface="Calibri" pitchFamily="34" charset="-122"/>
                 <a:cs typeface="Calibri" pitchFamily="34" charset="-120"/>
               </a:rPr>
-              <a:t>Microsoft's free STRIDE card deck</a:t>
+              <a:t>CISA "Secure by Design": safety is the vendor's job, on by default</a:t>
             </a:r>
             <a:endParaRPr lang="en-US" sz="1400" dirty="0"/>
           </a:p>
@@ -2920,7 +3030,7 @@
                 <a:ea typeface="Calibri" pitchFamily="34" charset="-122"/>
                 <a:cs typeface="Calibri" pitchFamily="34" charset="-120"/>
               </a:rPr>
-              <a:t>Play cards against the sample app's data-flow diagram</a:t>
+              <a:t>Shift from "patch later" to design out the bug class</a:t>
             </a:r>
             <a:endParaRPr lang="en-US" sz="1400" dirty="0"/>
           </a:p>
@@ -2941,7 +3051,7 @@
                 <a:ea typeface="Calibri" pitchFamily="34" charset="-122"/>
                 <a:cs typeface="Calibri" pitchFamily="34" charset="-120"/>
               </a:rPr>
-              <a:t>Each valid threat = a point</a:t>
+              <a:t>Industry &amp; government push toward memory-safe languages (more in Wk 11)</a:t>
             </a:r>
             <a:endParaRPr lang="en-US" sz="1400" dirty="0"/>
           </a:p>
@@ -2962,7 +3072,7 @@
                 <a:ea typeface="Calibri" pitchFamily="34" charset="-122"/>
                 <a:cs typeface="Calibri" pitchFamily="34" charset="-120"/>
               </a:rPr>
-              <a:t>Outcome: a team-built STRIDE model</a:t>
+              <a:t>Some bugs are design flaws, not coding slips → A06: Insecure Design</a:t>
             </a:r>
             <a:endParaRPr lang="en-US" sz="1400" dirty="0"/>
           </a:p>
@@ -3176,7 +3286,7 @@
                 <a:ea typeface="Arial" pitchFamily="34" charset="-122"/>
                 <a:cs typeface="Arial" pitchFamily="34" charset="-120"/>
               </a:rPr>
-              <a:t>Lab 0 — Environment setup (once)</a:t>
+              <a:t>🎲 Game — Elevation of Privilege</a:t>
             </a:r>
             <a:endParaRPr lang="en-US" sz="2600" dirty="0"/>
           </a:p>
@@ -3190,447 +3300,16 @@
         </p:nvSpPr>
         <p:spPr>
           <a:xfrm>
-            <a:off x="502920" y="1325880"/>
-            <a:ext cx="384048" cy="384048"/>
-          </a:xfrm>
-          <a:prstGeom prst="ellipse">
-            <a:avLst/>
-          </a:prstGeom>
-          <a:solidFill>
-            <a:srgbClr val="E35205"/>
-          </a:solidFill>
-          <a:ln/>
-        </p:spPr>
-      </p:sp>
-      <p:sp>
-        <p:nvSpPr>
-          <p:cNvPr id="6" name="Text 3"/>
-          <p:cNvSpPr/>
-          <p:nvPr/>
-        </p:nvSpPr>
-        <p:spPr>
-          <a:xfrm>
-            <a:off x="502920" y="1325880"/>
-            <a:ext cx="384048" cy="384048"/>
-          </a:xfrm>
-          <a:prstGeom prst="rect">
-            <a:avLst/>
-          </a:prstGeom>
-          <a:noFill/>
-          <a:ln/>
-        </p:spPr>
-        <p:txBody>
-          <a:bodyPr wrap="square" lIns="0" tIns="0" rIns="0" bIns="0" rtlCol="0" anchor="ctr"/>
-          <a:lstStyle/>
-          <a:p>
-            <a:pPr algn="ctr" indent="0" marL="0">
-              <a:buNone/>
-            </a:pPr>
-            <a:r>
-              <a:rPr lang="en-US" sz="1500" b="1" dirty="0">
-                <a:solidFill>
-                  <a:srgbClr val="0E1726"/>
-                </a:solidFill>
-                <a:latin typeface="Arial" pitchFamily="34" charset="0"/>
-                <a:ea typeface="Arial" pitchFamily="34" charset="-122"/>
-                <a:cs typeface="Arial" pitchFamily="34" charset="-120"/>
-              </a:rPr>
-              <a:t>1</a:t>
-            </a:r>
-            <a:endParaRPr lang="en-US" sz="1500" dirty="0"/>
-          </a:p>
-        </p:txBody>
-      </p:sp>
-      <p:sp>
-        <p:nvSpPr>
-          <p:cNvPr id="7" name="Text 4"/>
-          <p:cNvSpPr/>
-          <p:nvPr/>
-        </p:nvSpPr>
-        <p:spPr>
-          <a:xfrm>
-            <a:off x="1051560" y="1325880"/>
-            <a:ext cx="7589520" cy="384048"/>
-          </a:xfrm>
-          <a:prstGeom prst="rect">
-            <a:avLst/>
-          </a:prstGeom>
-          <a:noFill/>
-          <a:ln/>
-        </p:spPr>
-        <p:txBody>
-          <a:bodyPr wrap="square" lIns="0" tIns="0" rIns="0" bIns="0" rtlCol="0" anchor="ctr"/>
-          <a:lstStyle/>
-          <a:p>
-            <a:pPr indent="0" marL="0">
-              <a:buNone/>
-            </a:pPr>
-            <a:r>
-              <a:rPr lang="en-US" sz="1350" dirty="0">
-                <a:solidFill>
-                  <a:srgbClr val="E6EDF3"/>
-                </a:solidFill>
-                <a:latin typeface="Calibri" pitchFamily="34" charset="0"/>
-                <a:ea typeface="Calibri" pitchFamily="34" charset="-122"/>
-                <a:cs typeface="Calibri" pitchFamily="34" charset="-120"/>
-              </a:rPr>
-              <a:t>VirtualBox/UTM + Kali or Ubuntu VM</a:t>
-            </a:r>
-            <a:endParaRPr lang="en-US" sz="1350" dirty="0"/>
-          </a:p>
-        </p:txBody>
-      </p:sp>
-      <p:sp>
-        <p:nvSpPr>
-          <p:cNvPr id="8" name="Shape 5"/>
-          <p:cNvSpPr/>
-          <p:nvPr/>
-        </p:nvSpPr>
-        <p:spPr>
-          <a:xfrm>
-            <a:off x="502920" y="1783080"/>
-            <a:ext cx="384048" cy="384048"/>
-          </a:xfrm>
-          <a:prstGeom prst="ellipse">
-            <a:avLst/>
-          </a:prstGeom>
-          <a:solidFill>
-            <a:srgbClr val="E35205"/>
-          </a:solidFill>
-          <a:ln/>
-        </p:spPr>
-      </p:sp>
-      <p:sp>
-        <p:nvSpPr>
-          <p:cNvPr id="9" name="Text 6"/>
-          <p:cNvSpPr/>
-          <p:nvPr/>
-        </p:nvSpPr>
-        <p:spPr>
-          <a:xfrm>
-            <a:off x="502920" y="1783080"/>
-            <a:ext cx="384048" cy="384048"/>
-          </a:xfrm>
-          <a:prstGeom prst="rect">
-            <a:avLst/>
-          </a:prstGeom>
-          <a:noFill/>
-          <a:ln/>
-        </p:spPr>
-        <p:txBody>
-          <a:bodyPr wrap="square" lIns="0" tIns="0" rIns="0" bIns="0" rtlCol="0" anchor="ctr"/>
-          <a:lstStyle/>
-          <a:p>
-            <a:pPr algn="ctr" indent="0" marL="0">
-              <a:buNone/>
-            </a:pPr>
-            <a:r>
-              <a:rPr lang="en-US" sz="1500" b="1" dirty="0">
-                <a:solidFill>
-                  <a:srgbClr val="0E1726"/>
-                </a:solidFill>
-                <a:latin typeface="Arial" pitchFamily="34" charset="0"/>
-                <a:ea typeface="Arial" pitchFamily="34" charset="-122"/>
-                <a:cs typeface="Arial" pitchFamily="34" charset="-120"/>
-              </a:rPr>
-              <a:t>2</a:t>
-            </a:r>
-            <a:endParaRPr lang="en-US" sz="1500" dirty="0"/>
-          </a:p>
-        </p:txBody>
-      </p:sp>
-      <p:sp>
-        <p:nvSpPr>
-          <p:cNvPr id="10" name="Text 7"/>
-          <p:cNvSpPr/>
-          <p:nvPr/>
-        </p:nvSpPr>
-        <p:spPr>
-          <a:xfrm>
-            <a:off x="1051560" y="1783080"/>
-            <a:ext cx="7589520" cy="384048"/>
-          </a:xfrm>
-          <a:prstGeom prst="rect">
-            <a:avLst/>
-          </a:prstGeom>
-          <a:noFill/>
-          <a:ln/>
-        </p:spPr>
-        <p:txBody>
-          <a:bodyPr wrap="square" lIns="0" tIns="0" rIns="0" bIns="0" rtlCol="0" anchor="ctr"/>
-          <a:lstStyle/>
-          <a:p>
-            <a:pPr indent="0" marL="0">
-              <a:buNone/>
-            </a:pPr>
-            <a:r>
-              <a:rPr lang="en-US" sz="1350" dirty="0">
-                <a:solidFill>
-                  <a:srgbClr val="E6EDF3"/>
-                </a:solidFill>
-                <a:latin typeface="Calibri" pitchFamily="34" charset="0"/>
-                <a:ea typeface="Calibri" pitchFamily="34" charset="-122"/>
-                <a:cs typeface="Calibri" pitchFamily="34" charset="-120"/>
-              </a:rPr>
-              <a:t>Docker + Docker Compose inside the VM</a:t>
-            </a:r>
-            <a:endParaRPr lang="en-US" sz="1350" dirty="0"/>
-          </a:p>
-        </p:txBody>
-      </p:sp>
-      <p:sp>
-        <p:nvSpPr>
-          <p:cNvPr id="11" name="Shape 8"/>
-          <p:cNvSpPr/>
-          <p:nvPr/>
-        </p:nvSpPr>
-        <p:spPr>
-          <a:xfrm>
-            <a:off x="502920" y="2240280"/>
-            <a:ext cx="384048" cy="384048"/>
-          </a:xfrm>
-          <a:prstGeom prst="ellipse">
-            <a:avLst/>
-          </a:prstGeom>
-          <a:solidFill>
-            <a:srgbClr val="E35205"/>
-          </a:solidFill>
-          <a:ln/>
-        </p:spPr>
-      </p:sp>
-      <p:sp>
-        <p:nvSpPr>
-          <p:cNvPr id="12" name="Text 9"/>
-          <p:cNvSpPr/>
-          <p:nvPr/>
-        </p:nvSpPr>
-        <p:spPr>
-          <a:xfrm>
-            <a:off x="502920" y="2240280"/>
-            <a:ext cx="384048" cy="384048"/>
-          </a:xfrm>
-          <a:prstGeom prst="rect">
-            <a:avLst/>
-          </a:prstGeom>
-          <a:noFill/>
-          <a:ln/>
-        </p:spPr>
-        <p:txBody>
-          <a:bodyPr wrap="square" lIns="0" tIns="0" rIns="0" bIns="0" rtlCol="0" anchor="ctr"/>
-          <a:lstStyle/>
-          <a:p>
-            <a:pPr algn="ctr" indent="0" marL="0">
-              <a:buNone/>
-            </a:pPr>
-            <a:r>
-              <a:rPr lang="en-US" sz="1500" b="1" dirty="0">
-                <a:solidFill>
-                  <a:srgbClr val="0E1726"/>
-                </a:solidFill>
-                <a:latin typeface="Arial" pitchFamily="34" charset="0"/>
-                <a:ea typeface="Arial" pitchFamily="34" charset="-122"/>
-                <a:cs typeface="Arial" pitchFamily="34" charset="-120"/>
-              </a:rPr>
-              <a:t>3</a:t>
-            </a:r>
-            <a:endParaRPr lang="en-US" sz="1500" dirty="0"/>
-          </a:p>
-        </p:txBody>
-      </p:sp>
-      <p:sp>
-        <p:nvSpPr>
-          <p:cNvPr id="13" name="Text 10"/>
-          <p:cNvSpPr/>
-          <p:nvPr/>
-        </p:nvSpPr>
-        <p:spPr>
-          <a:xfrm>
-            <a:off x="1051560" y="2240280"/>
-            <a:ext cx="7589520" cy="384048"/>
-          </a:xfrm>
-          <a:prstGeom prst="rect">
-            <a:avLst/>
-          </a:prstGeom>
-          <a:noFill/>
-          <a:ln/>
-        </p:spPr>
-        <p:txBody>
-          <a:bodyPr wrap="square" lIns="0" tIns="0" rIns="0" bIns="0" rtlCol="0" anchor="ctr"/>
-          <a:lstStyle/>
-          <a:p>
-            <a:pPr indent="0" marL="0">
-              <a:buNone/>
-            </a:pPr>
-            <a:r>
-              <a:rPr lang="en-US" sz="1350" dirty="0">
-                <a:solidFill>
-                  <a:srgbClr val="E6EDF3"/>
-                </a:solidFill>
-                <a:latin typeface="Calibri" pitchFamily="34" charset="0"/>
-                <a:ea typeface="Calibri" pitchFamily="34" charset="-122"/>
-                <a:cs typeface="Calibri" pitchFamily="34" charset="-120"/>
-              </a:rPr>
-              <a:t>Browser proxy: Burp Suite Community or OWASP ZAP</a:t>
-            </a:r>
-            <a:endParaRPr lang="en-US" sz="1350" dirty="0"/>
-          </a:p>
-        </p:txBody>
-      </p:sp>
-      <p:sp>
-        <p:nvSpPr>
-          <p:cNvPr id="14" name="Shape 11"/>
-          <p:cNvSpPr/>
-          <p:nvPr/>
-        </p:nvSpPr>
-        <p:spPr>
-          <a:xfrm>
-            <a:off x="502920" y="2697480"/>
-            <a:ext cx="384048" cy="384048"/>
-          </a:xfrm>
-          <a:prstGeom prst="ellipse">
-            <a:avLst/>
-          </a:prstGeom>
-          <a:solidFill>
-            <a:srgbClr val="E35205"/>
-          </a:solidFill>
-          <a:ln/>
-        </p:spPr>
-      </p:sp>
-      <p:sp>
-        <p:nvSpPr>
-          <p:cNvPr id="15" name="Text 12"/>
-          <p:cNvSpPr/>
-          <p:nvPr/>
-        </p:nvSpPr>
-        <p:spPr>
-          <a:xfrm>
-            <a:off x="502920" y="2697480"/>
-            <a:ext cx="384048" cy="384048"/>
-          </a:xfrm>
-          <a:prstGeom prst="rect">
-            <a:avLst/>
-          </a:prstGeom>
-          <a:noFill/>
-          <a:ln/>
-        </p:spPr>
-        <p:txBody>
-          <a:bodyPr wrap="square" lIns="0" tIns="0" rIns="0" bIns="0" rtlCol="0" anchor="ctr"/>
-          <a:lstStyle/>
-          <a:p>
-            <a:pPr algn="ctr" indent="0" marL="0">
-              <a:buNone/>
-            </a:pPr>
-            <a:r>
-              <a:rPr lang="en-US" sz="1500" b="1" dirty="0">
-                <a:solidFill>
-                  <a:srgbClr val="0E1726"/>
-                </a:solidFill>
-                <a:latin typeface="Arial" pitchFamily="34" charset="0"/>
-                <a:ea typeface="Arial" pitchFamily="34" charset="-122"/>
-                <a:cs typeface="Arial" pitchFamily="34" charset="-120"/>
-              </a:rPr>
-              <a:t>4</a:t>
-            </a:r>
-            <a:endParaRPr lang="en-US" sz="1500" dirty="0"/>
-          </a:p>
-        </p:txBody>
-      </p:sp>
-      <p:sp>
-        <p:nvSpPr>
-          <p:cNvPr id="16" name="Text 13"/>
-          <p:cNvSpPr/>
-          <p:nvPr/>
-        </p:nvSpPr>
-        <p:spPr>
-          <a:xfrm>
-            <a:off x="1051560" y="2697480"/>
-            <a:ext cx="7589520" cy="384048"/>
-          </a:xfrm>
-          <a:prstGeom prst="rect">
-            <a:avLst/>
-          </a:prstGeom>
-          <a:noFill/>
-          <a:ln/>
-        </p:spPr>
-        <p:txBody>
-          <a:bodyPr wrap="square" lIns="0" tIns="0" rIns="0" bIns="0" rtlCol="0" anchor="ctr"/>
-          <a:lstStyle/>
-          <a:p>
-            <a:pPr indent="0" marL="0">
-              <a:buNone/>
-            </a:pPr>
-            <a:r>
-              <a:rPr lang="en-US" sz="1350" dirty="0">
-                <a:solidFill>
-                  <a:srgbClr val="E6EDF3"/>
-                </a:solidFill>
-                <a:latin typeface="Calibri" pitchFamily="34" charset="0"/>
-                <a:ea typeface="Calibri" pitchFamily="34" charset="-122"/>
-                <a:cs typeface="Calibri" pitchFamily="34" charset="-120"/>
-              </a:rPr>
-              <a:t>Verify: docker run hello-world, git --version</a:t>
-            </a:r>
-            <a:endParaRPr lang="en-US" sz="1350" dirty="0"/>
-          </a:p>
-        </p:txBody>
-      </p:sp>
-      <p:sp>
-        <p:nvSpPr>
-          <p:cNvPr id="17" name="Text 14"/>
-          <p:cNvSpPr/>
-          <p:nvPr/>
-        </p:nvSpPr>
-        <p:spPr>
-          <a:xfrm>
-            <a:off x="457200" y="4800600"/>
-            <a:ext cx="6949440" cy="274320"/>
-          </a:xfrm>
-          <a:prstGeom prst="rect">
-            <a:avLst/>
-          </a:prstGeom>
-          <a:noFill/>
-          <a:ln/>
-        </p:spPr>
-        <p:txBody>
-          <a:bodyPr wrap="square" lIns="0" tIns="0" rIns="0" bIns="0" rtlCol="0" anchor="ctr"/>
-          <a:lstStyle/>
-          <a:p>
-            <a:pPr indent="0" marL="0">
-              <a:buNone/>
-            </a:pPr>
-            <a:r>
-              <a:rPr lang="en-US" sz="900" dirty="0">
-                <a:solidFill>
-                  <a:srgbClr val="94A3B8"/>
-                </a:solidFill>
-                <a:latin typeface="Calibri" pitchFamily="34" charset="0"/>
-                <a:ea typeface="Calibri" pitchFamily="34" charset="-122"/>
-                <a:cs typeface="Calibri" pitchFamily="34" charset="-120"/>
-              </a:rPr>
-              <a:t>Software Security · Week 1</a:t>
-            </a:r>
-            <a:endParaRPr lang="en-US" sz="900" dirty="0"/>
-          </a:p>
-        </p:txBody>
-      </p:sp>
-      <p:sp>
-        <p:nvSpPr>
-          <p:cNvPr id="18" name="Shape 15"/>
-          <p:cNvSpPr/>
-          <p:nvPr/>
-        </p:nvSpPr>
-        <p:spPr>
-          <a:xfrm>
-            <a:off x="7772400" y="4590288"/>
-            <a:ext cx="969264" cy="475488"/>
+            <a:off x="457200" y="1325880"/>
+            <a:ext cx="8229600" cy="1517904"/>
           </a:xfrm>
           <a:prstGeom prst="roundRect">
             <a:avLst>
-              <a:gd name="adj" fmla="val 11538"/>
+              <a:gd name="adj" fmla="val 4819"/>
             </a:avLst>
           </a:prstGeom>
           <a:solidFill>
-            <a:srgbClr val="FFFFFF"/>
+            <a:srgbClr val="18243A"/>
           </a:solidFill>
           <a:ln/>
           <a:effectLst>
@@ -3642,9 +3321,183 @@
           </a:effectLst>
         </p:spPr>
       </p:sp>
+      <p:sp>
+        <p:nvSpPr>
+          <p:cNvPr id="6" name="Text 3"/>
+          <p:cNvSpPr/>
+          <p:nvPr/>
+        </p:nvSpPr>
+        <p:spPr>
+          <a:xfrm>
+            <a:off x="731520" y="1435608"/>
+            <a:ext cx="7680960" cy="1298448"/>
+          </a:xfrm>
+          <a:prstGeom prst="rect">
+            <a:avLst/>
+          </a:prstGeom>
+          <a:noFill/>
+          <a:ln/>
+        </p:spPr>
+        <p:txBody>
+          <a:bodyPr wrap="square" lIns="0" tIns="0" rIns="0" bIns="0" rtlCol="0" anchor="t"/>
+          <a:lstStyle/>
+          <a:p>
+            <a:pPr marL="342900" indent="-342900">
+              <a:spcAft>
+                <a:spcPts val="600"/>
+              </a:spcAft>
+              <a:buSzPct val="100000"/>
+              <a:buChar char="•"/>
+            </a:pPr>
+            <a:r>
+              <a:rPr lang="en-US" sz="1400" dirty="0">
+                <a:solidFill>
+                  <a:srgbClr val="E6EDF3"/>
+                </a:solidFill>
+                <a:latin typeface="Calibri" pitchFamily="34" charset="0"/>
+                <a:ea typeface="Calibri" pitchFamily="34" charset="-122"/>
+                <a:cs typeface="Calibri" pitchFamily="34" charset="-120"/>
+              </a:rPr>
+              <a:t>Microsoft's free STRIDE card deck</a:t>
+            </a:r>
+            <a:endParaRPr lang="en-US" sz="1400" dirty="0"/>
+          </a:p>
+          <a:p>
+            <a:pPr marL="342900" indent="-342900">
+              <a:spcAft>
+                <a:spcPts val="600"/>
+              </a:spcAft>
+              <a:buSzPct val="100000"/>
+              <a:buChar char="•"/>
+            </a:pPr>
+            <a:r>
+              <a:rPr lang="en-US" sz="1400" dirty="0">
+                <a:solidFill>
+                  <a:srgbClr val="E6EDF3"/>
+                </a:solidFill>
+                <a:latin typeface="Calibri" pitchFamily="34" charset="0"/>
+                <a:ea typeface="Calibri" pitchFamily="34" charset="-122"/>
+                <a:cs typeface="Calibri" pitchFamily="34" charset="-120"/>
+              </a:rPr>
+              <a:t>Play cards against the sample app's data-flow diagram</a:t>
+            </a:r>
+            <a:endParaRPr lang="en-US" sz="1400" dirty="0"/>
+          </a:p>
+          <a:p>
+            <a:pPr marL="342900" indent="-342900">
+              <a:spcAft>
+                <a:spcPts val="600"/>
+              </a:spcAft>
+              <a:buSzPct val="100000"/>
+              <a:buChar char="•"/>
+            </a:pPr>
+            <a:r>
+              <a:rPr lang="en-US" sz="1400" dirty="0">
+                <a:solidFill>
+                  <a:srgbClr val="E6EDF3"/>
+                </a:solidFill>
+                <a:latin typeface="Calibri" pitchFamily="34" charset="0"/>
+                <a:ea typeface="Calibri" pitchFamily="34" charset="-122"/>
+                <a:cs typeface="Calibri" pitchFamily="34" charset="-120"/>
+              </a:rPr>
+              <a:t>Each valid threat tied to a real element = a point</a:t>
+            </a:r>
+            <a:endParaRPr lang="en-US" sz="1400" dirty="0"/>
+          </a:p>
+          <a:p>
+            <a:pPr marL="342900" indent="-342900">
+              <a:spcAft>
+                <a:spcPts val="600"/>
+              </a:spcAft>
+              <a:buSzPct val="100000"/>
+              <a:buChar char="•"/>
+            </a:pPr>
+            <a:r>
+              <a:rPr lang="en-US" sz="1400" dirty="0">
+                <a:solidFill>
+                  <a:srgbClr val="E6EDF3"/>
+                </a:solidFill>
+                <a:latin typeface="Calibri" pitchFamily="34" charset="0"/>
+                <a:ea typeface="Calibri" pitchFamily="34" charset="-122"/>
+                <a:cs typeface="Calibri" pitchFamily="34" charset="-120"/>
+              </a:rPr>
+              <a:t>Outcome: a team-built STRIDE model</a:t>
+            </a:r>
+            <a:endParaRPr lang="en-US" sz="1400" dirty="0"/>
+          </a:p>
+        </p:txBody>
+      </p:sp>
+      <p:sp>
+        <p:nvSpPr>
+          <p:cNvPr id="7" name="Text 4"/>
+          <p:cNvSpPr/>
+          <p:nvPr/>
+        </p:nvSpPr>
+        <p:spPr>
+          <a:xfrm>
+            <a:off x="457200" y="4800600"/>
+            <a:ext cx="6949440" cy="274320"/>
+          </a:xfrm>
+          <a:prstGeom prst="rect">
+            <a:avLst/>
+          </a:prstGeom>
+          <a:noFill/>
+          <a:ln/>
+        </p:spPr>
+        <p:txBody>
+          <a:bodyPr wrap="square" lIns="0" tIns="0" rIns="0" bIns="0" rtlCol="0" anchor="ctr"/>
+          <a:lstStyle/>
+          <a:p>
+            <a:pPr indent="0" marL="0">
+              <a:buNone/>
+            </a:pPr>
+            <a:r>
+              <a:rPr lang="en-US" sz="900" dirty="0">
+                <a:solidFill>
+                  <a:srgbClr val="94A3B8"/>
+                </a:solidFill>
+                <a:latin typeface="Calibri" pitchFamily="34" charset="0"/>
+                <a:ea typeface="Calibri" pitchFamily="34" charset="-122"/>
+                <a:cs typeface="Calibri" pitchFamily="34" charset="-120"/>
+              </a:rPr>
+              <a:t>Software Security · Week 1</a:t>
+            </a:r>
+            <a:endParaRPr lang="en-US" sz="900" dirty="0"/>
+          </a:p>
+        </p:txBody>
+      </p:sp>
+      <p:sp>
+        <p:nvSpPr>
+          <p:cNvPr id="8" name="Shape 5"/>
+          <p:cNvSpPr/>
+          <p:nvPr/>
+        </p:nvSpPr>
+        <p:spPr>
+          <a:xfrm>
+            <a:off x="7772400" y="4590288"/>
+            <a:ext cx="969264" cy="475488"/>
+          </a:xfrm>
+          <a:prstGeom prst="roundRect">
+            <a:avLst>
+              <a:gd name="adj" fmla="val 11538"/>
+            </a:avLst>
+          </a:prstGeom>
+          <a:solidFill>
+            <a:srgbClr val="FFFFFF"/>
+          </a:solidFill>
+          <a:ln/>
+          <a:effectLst>
+            <a:outerShdw sx="100000" sy="100000" kx="0" ky="0" algn="bl" rotWithShape="0" blurRad="101600" dist="38100" dir="5400000">
+              <a:srgbClr val="000000">
+                <a:alpha val="35000"/>
+              </a:srgbClr>
+            </a:outerShdw>
+          </a:effectLst>
+        </p:spPr>
+      </p:sp>
       <p:pic>
         <p:nvPicPr>
-          <p:cNvPr id="19" name="Image 1" descr="/Users/pop7/Library/CloudStorage/OneDrive-MonsterConnectCo.,Ltd/Lecture/KOSEN69 - software-security/slides/pptx/assets/logo-small.png">    </p:cNvPr>
+          <p:cNvPr id="9" name="Image 1" descr="/Users/pop7/Library/CloudStorage/OneDrive-MonsterConnectCo.,Ltd/Lecture/KOSEN69 - software-security/slides/pptx/assets/logo-small.png">    </p:cNvPr>
           <p:cNvPicPr>
             <a:picLocks noChangeAspect="1"/>
           </p:cNvPicPr>
@@ -3782,7 +3635,7 @@
                 <a:ea typeface="Arial" pitchFamily="34" charset="-122"/>
                 <a:cs typeface="Arial" pitchFamily="34" charset="-120"/>
               </a:rPr>
-              <a:t>Lab 1 — Threat-model a sample app</a:t>
+              <a:t>Lab 0 — Environment setup (once)</a:t>
             </a:r>
             <a:endParaRPr lang="en-US" sz="2600" dirty="0"/>
           </a:p>
@@ -3880,7 +3733,7 @@
                 <a:ea typeface="Calibri" pitchFamily="34" charset="-122"/>
                 <a:cs typeface="Calibri" pitchFamily="34" charset="-120"/>
               </a:rPr>
-              <a:t>Run the provided app (docker compose up)</a:t>
+              <a:t>VirtualBox/UTM + Kali or Ubuntu VM</a:t>
             </a:r>
             <a:endParaRPr lang="en-US" sz="1350" dirty="0"/>
           </a:p>
@@ -3978,7 +3831,7 @@
                 <a:ea typeface="Calibri" pitchFamily="34" charset="-122"/>
                 <a:cs typeface="Calibri" pitchFamily="34" charset="-120"/>
               </a:rPr>
-              <a:t>Draw a DFD: processes, stores, external entities, trust boundaries</a:t>
+              <a:t>Docker + Docker Compose inside the VM</a:t>
             </a:r>
             <a:endParaRPr lang="en-US" sz="1350" dirty="0"/>
           </a:p>
@@ -4076,7 +3929,7 @@
                 <a:ea typeface="Calibri" pitchFamily="34" charset="-122"/>
                 <a:cs typeface="Calibri" pitchFamily="34" charset="-120"/>
               </a:rPr>
-              <a:t>Apply STRIDE to each element</a:t>
+              <a:t>Browser proxy: Burp Suite Community or OWASP ZAP</a:t>
             </a:r>
             <a:endParaRPr lang="en-US" sz="1350" dirty="0"/>
           </a:p>
@@ -4174,7 +4027,7 @@
                 <a:ea typeface="Calibri" pitchFamily="34" charset="-122"/>
                 <a:cs typeface="Calibri" pitchFamily="34" charset="-120"/>
               </a:rPr>
-              <a:t>Rank top 5 risks (likelihood × impact) + one mitigation each</a:t>
+              <a:t>Verify: docker run hello-world, git --version</a:t>
             </a:r>
             <a:endParaRPr lang="en-US" sz="1350" dirty="0"/>
           </a:p>
@@ -4188,8 +4041,8 @@
         </p:nvSpPr>
         <p:spPr>
           <a:xfrm>
-            <a:off x="548640" y="3246120"/>
-            <a:ext cx="8046720" cy="548640"/>
+            <a:off x="457200" y="4800600"/>
+            <a:ext cx="6949440" cy="274320"/>
           </a:xfrm>
           <a:prstGeom prst="rect">
             <a:avLst/>
@@ -4198,60 +4051,21 @@
           <a:ln/>
         </p:spPr>
         <p:txBody>
-          <a:bodyPr wrap="square" lIns="0" tIns="0" rIns="0" bIns="0" rtlCol="0" anchor="t"/>
+          <a:bodyPr wrap="square" lIns="0" tIns="0" rIns="0" bIns="0" rtlCol="0" anchor="ctr"/>
           <a:lstStyle/>
           <a:p>
             <a:pPr indent="0" marL="0">
               <a:buNone/>
             </a:pPr>
             <a:r>
-              <a:rPr lang="en-US" sz="1400" dirty="0">
-                <a:solidFill>
-                  <a:srgbClr val="E6EDF3"/>
+              <a:rPr lang="en-US" sz="900" dirty="0">
+                <a:solidFill>
+                  <a:srgbClr val="94A3B8"/>
                 </a:solidFill>
                 <a:latin typeface="Calibri" pitchFamily="34" charset="0"/>
                 <a:ea typeface="Calibri" pitchFamily="34" charset="-122"/>
                 <a:cs typeface="Calibri" pitchFamily="34" charset="-120"/>
               </a:rPr>
-              <a:t>Deliverable: 2–3 page threat model</a:t>
-            </a:r>
-            <a:endParaRPr lang="en-US" sz="1400" dirty="0"/>
-          </a:p>
-        </p:txBody>
-      </p:sp>
-      <p:sp>
-        <p:nvSpPr>
-          <p:cNvPr id="18" name="Text 15"/>
-          <p:cNvSpPr/>
-          <p:nvPr/>
-        </p:nvSpPr>
-        <p:spPr>
-          <a:xfrm>
-            <a:off x="457200" y="4800600"/>
-            <a:ext cx="6949440" cy="274320"/>
-          </a:xfrm>
-          <a:prstGeom prst="rect">
-            <a:avLst/>
-          </a:prstGeom>
-          <a:noFill/>
-          <a:ln/>
-        </p:spPr>
-        <p:txBody>
-          <a:bodyPr wrap="square" lIns="0" tIns="0" rIns="0" bIns="0" rtlCol="0" anchor="ctr"/>
-          <a:lstStyle/>
-          <a:p>
-            <a:pPr indent="0" marL="0">
-              <a:buNone/>
-            </a:pPr>
-            <a:r>
-              <a:rPr lang="en-US" sz="900" dirty="0">
-                <a:solidFill>
-                  <a:srgbClr val="94A3B8"/>
-                </a:solidFill>
-                <a:latin typeface="Calibri" pitchFamily="34" charset="0"/>
-                <a:ea typeface="Calibri" pitchFamily="34" charset="-122"/>
-                <a:cs typeface="Calibri" pitchFamily="34" charset="-120"/>
-              </a:rPr>
               <a:t>Software Security · Week 1</a:t>
             </a:r>
             <a:endParaRPr lang="en-US" sz="900" dirty="0"/>
@@ -4260,7 +4074,7 @@
       </p:sp>
       <p:sp>
         <p:nvSpPr>
-          <p:cNvPr id="19" name="Shape 16"/>
+          <p:cNvPr id="18" name="Shape 15"/>
           <p:cNvSpPr/>
           <p:nvPr/>
         </p:nvSpPr>
@@ -4289,7 +4103,7 @@
       </p:sp>
       <p:pic>
         <p:nvPicPr>
-          <p:cNvPr id="20" name="Image 1" descr="/Users/pop7/Library/CloudStorage/OneDrive-MonsterConnectCo.,Ltd/Lecture/KOSEN69 - software-security/slides/pptx/assets/logo-small.png">    </p:cNvPr>
+          <p:cNvPr id="19" name="Image 1" descr="/Users/pop7/Library/CloudStorage/OneDrive-MonsterConnectCo.,Ltd/Lecture/KOSEN69 - software-security/slides/pptx/assets/logo-small.png">    </p:cNvPr>
           <p:cNvPicPr>
             <a:picLocks noChangeAspect="1"/>
           </p:cNvPicPr>
@@ -4427,7 +4241,7 @@
                 <a:ea typeface="Arial" pitchFamily="34" charset="-122"/>
                 <a:cs typeface="Arial" pitchFamily="34" charset="-120"/>
               </a:rPr>
-              <a:t>Using AI in this course</a:t>
+              <a:t>Lab 1 — Threat-model a sample app</a:t>
             </a:r>
             <a:endParaRPr lang="en-US" sz="2600" dirty="0"/>
           </a:p>
@@ -4441,16 +4255,486 @@
         </p:nvSpPr>
         <p:spPr>
           <a:xfrm>
-            <a:off x="457200" y="1325880"/>
-            <a:ext cx="8229600" cy="2450592"/>
+            <a:off x="502920" y="1325880"/>
+            <a:ext cx="384048" cy="384048"/>
+          </a:xfrm>
+          <a:prstGeom prst="ellipse">
+            <a:avLst/>
+          </a:prstGeom>
+          <a:solidFill>
+            <a:srgbClr val="E35205"/>
+          </a:solidFill>
+          <a:ln/>
+        </p:spPr>
+      </p:sp>
+      <p:sp>
+        <p:nvSpPr>
+          <p:cNvPr id="6" name="Text 3"/>
+          <p:cNvSpPr/>
+          <p:nvPr/>
+        </p:nvSpPr>
+        <p:spPr>
+          <a:xfrm>
+            <a:off x="502920" y="1325880"/>
+            <a:ext cx="384048" cy="384048"/>
+          </a:xfrm>
+          <a:prstGeom prst="rect">
+            <a:avLst/>
+          </a:prstGeom>
+          <a:noFill/>
+          <a:ln/>
+        </p:spPr>
+        <p:txBody>
+          <a:bodyPr wrap="square" lIns="0" tIns="0" rIns="0" bIns="0" rtlCol="0" anchor="ctr"/>
+          <a:lstStyle/>
+          <a:p>
+            <a:pPr algn="ctr" indent="0" marL="0">
+              <a:buNone/>
+            </a:pPr>
+            <a:r>
+              <a:rPr lang="en-US" sz="1500" b="1" dirty="0">
+                <a:solidFill>
+                  <a:srgbClr val="0E1726"/>
+                </a:solidFill>
+                <a:latin typeface="Arial" pitchFamily="34" charset="0"/>
+                <a:ea typeface="Arial" pitchFamily="34" charset="-122"/>
+                <a:cs typeface="Arial" pitchFamily="34" charset="-120"/>
+              </a:rPr>
+              <a:t>1</a:t>
+            </a:r>
+            <a:endParaRPr lang="en-US" sz="1500" dirty="0"/>
+          </a:p>
+        </p:txBody>
+      </p:sp>
+      <p:sp>
+        <p:nvSpPr>
+          <p:cNvPr id="7" name="Text 4"/>
+          <p:cNvSpPr/>
+          <p:nvPr/>
+        </p:nvSpPr>
+        <p:spPr>
+          <a:xfrm>
+            <a:off x="1051560" y="1325880"/>
+            <a:ext cx="7589520" cy="384048"/>
+          </a:xfrm>
+          <a:prstGeom prst="rect">
+            <a:avLst/>
+          </a:prstGeom>
+          <a:noFill/>
+          <a:ln/>
+        </p:spPr>
+        <p:txBody>
+          <a:bodyPr wrap="square" lIns="0" tIns="0" rIns="0" bIns="0" rtlCol="0" anchor="ctr"/>
+          <a:lstStyle/>
+          <a:p>
+            <a:pPr indent="0" marL="0">
+              <a:buNone/>
+            </a:pPr>
+            <a:r>
+              <a:rPr lang="en-US" sz="1350" dirty="0">
+                <a:solidFill>
+                  <a:srgbClr val="E6EDF3"/>
+                </a:solidFill>
+                <a:latin typeface="Calibri" pitchFamily="34" charset="0"/>
+                <a:ea typeface="Calibri" pitchFamily="34" charset="-122"/>
+                <a:cs typeface="Calibri" pitchFamily="34" charset="-120"/>
+              </a:rPr>
+              <a:t>Run the provided app (docker compose up)</a:t>
+            </a:r>
+            <a:endParaRPr lang="en-US" sz="1350" dirty="0"/>
+          </a:p>
+        </p:txBody>
+      </p:sp>
+      <p:sp>
+        <p:nvSpPr>
+          <p:cNvPr id="8" name="Shape 5"/>
+          <p:cNvSpPr/>
+          <p:nvPr/>
+        </p:nvSpPr>
+        <p:spPr>
+          <a:xfrm>
+            <a:off x="502920" y="1783080"/>
+            <a:ext cx="384048" cy="384048"/>
+          </a:xfrm>
+          <a:prstGeom prst="ellipse">
+            <a:avLst/>
+          </a:prstGeom>
+          <a:solidFill>
+            <a:srgbClr val="E35205"/>
+          </a:solidFill>
+          <a:ln/>
+        </p:spPr>
+      </p:sp>
+      <p:sp>
+        <p:nvSpPr>
+          <p:cNvPr id="9" name="Text 6"/>
+          <p:cNvSpPr/>
+          <p:nvPr/>
+        </p:nvSpPr>
+        <p:spPr>
+          <a:xfrm>
+            <a:off x="502920" y="1783080"/>
+            <a:ext cx="384048" cy="384048"/>
+          </a:xfrm>
+          <a:prstGeom prst="rect">
+            <a:avLst/>
+          </a:prstGeom>
+          <a:noFill/>
+          <a:ln/>
+        </p:spPr>
+        <p:txBody>
+          <a:bodyPr wrap="square" lIns="0" tIns="0" rIns="0" bIns="0" rtlCol="0" anchor="ctr"/>
+          <a:lstStyle/>
+          <a:p>
+            <a:pPr algn="ctr" indent="0" marL="0">
+              <a:buNone/>
+            </a:pPr>
+            <a:r>
+              <a:rPr lang="en-US" sz="1500" b="1" dirty="0">
+                <a:solidFill>
+                  <a:srgbClr val="0E1726"/>
+                </a:solidFill>
+                <a:latin typeface="Arial" pitchFamily="34" charset="0"/>
+                <a:ea typeface="Arial" pitchFamily="34" charset="-122"/>
+                <a:cs typeface="Arial" pitchFamily="34" charset="-120"/>
+              </a:rPr>
+              <a:t>2</a:t>
+            </a:r>
+            <a:endParaRPr lang="en-US" sz="1500" dirty="0"/>
+          </a:p>
+        </p:txBody>
+      </p:sp>
+      <p:sp>
+        <p:nvSpPr>
+          <p:cNvPr id="10" name="Text 7"/>
+          <p:cNvSpPr/>
+          <p:nvPr/>
+        </p:nvSpPr>
+        <p:spPr>
+          <a:xfrm>
+            <a:off x="1051560" y="1783080"/>
+            <a:ext cx="7589520" cy="384048"/>
+          </a:xfrm>
+          <a:prstGeom prst="rect">
+            <a:avLst/>
+          </a:prstGeom>
+          <a:noFill/>
+          <a:ln/>
+        </p:spPr>
+        <p:txBody>
+          <a:bodyPr wrap="square" lIns="0" tIns="0" rIns="0" bIns="0" rtlCol="0" anchor="ctr"/>
+          <a:lstStyle/>
+          <a:p>
+            <a:pPr indent="0" marL="0">
+              <a:buNone/>
+            </a:pPr>
+            <a:r>
+              <a:rPr lang="en-US" sz="1350" dirty="0">
+                <a:solidFill>
+                  <a:srgbClr val="E6EDF3"/>
+                </a:solidFill>
+                <a:latin typeface="Calibri" pitchFamily="34" charset="0"/>
+                <a:ea typeface="Calibri" pitchFamily="34" charset="-122"/>
+                <a:cs typeface="Calibri" pitchFamily="34" charset="-120"/>
+              </a:rPr>
+              <a:t>Draw a DFD: processes, stores, external entities, trust boundaries</a:t>
+            </a:r>
+            <a:endParaRPr lang="en-US" sz="1350" dirty="0"/>
+          </a:p>
+        </p:txBody>
+      </p:sp>
+      <p:sp>
+        <p:nvSpPr>
+          <p:cNvPr id="11" name="Shape 8"/>
+          <p:cNvSpPr/>
+          <p:nvPr/>
+        </p:nvSpPr>
+        <p:spPr>
+          <a:xfrm>
+            <a:off x="502920" y="2240280"/>
+            <a:ext cx="384048" cy="384048"/>
+          </a:xfrm>
+          <a:prstGeom prst="ellipse">
+            <a:avLst/>
+          </a:prstGeom>
+          <a:solidFill>
+            <a:srgbClr val="E35205"/>
+          </a:solidFill>
+          <a:ln/>
+        </p:spPr>
+      </p:sp>
+      <p:sp>
+        <p:nvSpPr>
+          <p:cNvPr id="12" name="Text 9"/>
+          <p:cNvSpPr/>
+          <p:nvPr/>
+        </p:nvSpPr>
+        <p:spPr>
+          <a:xfrm>
+            <a:off x="502920" y="2240280"/>
+            <a:ext cx="384048" cy="384048"/>
+          </a:xfrm>
+          <a:prstGeom prst="rect">
+            <a:avLst/>
+          </a:prstGeom>
+          <a:noFill/>
+          <a:ln/>
+        </p:spPr>
+        <p:txBody>
+          <a:bodyPr wrap="square" lIns="0" tIns="0" rIns="0" bIns="0" rtlCol="0" anchor="ctr"/>
+          <a:lstStyle/>
+          <a:p>
+            <a:pPr algn="ctr" indent="0" marL="0">
+              <a:buNone/>
+            </a:pPr>
+            <a:r>
+              <a:rPr lang="en-US" sz="1500" b="1" dirty="0">
+                <a:solidFill>
+                  <a:srgbClr val="0E1726"/>
+                </a:solidFill>
+                <a:latin typeface="Arial" pitchFamily="34" charset="0"/>
+                <a:ea typeface="Arial" pitchFamily="34" charset="-122"/>
+                <a:cs typeface="Arial" pitchFamily="34" charset="-120"/>
+              </a:rPr>
+              <a:t>3</a:t>
+            </a:r>
+            <a:endParaRPr lang="en-US" sz="1500" dirty="0"/>
+          </a:p>
+        </p:txBody>
+      </p:sp>
+      <p:sp>
+        <p:nvSpPr>
+          <p:cNvPr id="13" name="Text 10"/>
+          <p:cNvSpPr/>
+          <p:nvPr/>
+        </p:nvSpPr>
+        <p:spPr>
+          <a:xfrm>
+            <a:off x="1051560" y="2240280"/>
+            <a:ext cx="7589520" cy="384048"/>
+          </a:xfrm>
+          <a:prstGeom prst="rect">
+            <a:avLst/>
+          </a:prstGeom>
+          <a:noFill/>
+          <a:ln/>
+        </p:spPr>
+        <p:txBody>
+          <a:bodyPr wrap="square" lIns="0" tIns="0" rIns="0" bIns="0" rtlCol="0" anchor="ctr"/>
+          <a:lstStyle/>
+          <a:p>
+            <a:pPr indent="0" marL="0">
+              <a:buNone/>
+            </a:pPr>
+            <a:r>
+              <a:rPr lang="en-US" sz="1350" dirty="0">
+                <a:solidFill>
+                  <a:srgbClr val="E6EDF3"/>
+                </a:solidFill>
+                <a:latin typeface="Calibri" pitchFamily="34" charset="0"/>
+                <a:ea typeface="Calibri" pitchFamily="34" charset="-122"/>
+                <a:cs typeface="Calibri" pitchFamily="34" charset="-120"/>
+              </a:rPr>
+              <a:t>Apply STRIDE to each element</a:t>
+            </a:r>
+            <a:endParaRPr lang="en-US" sz="1350" dirty="0"/>
+          </a:p>
+        </p:txBody>
+      </p:sp>
+      <p:sp>
+        <p:nvSpPr>
+          <p:cNvPr id="14" name="Shape 11"/>
+          <p:cNvSpPr/>
+          <p:nvPr/>
+        </p:nvSpPr>
+        <p:spPr>
+          <a:xfrm>
+            <a:off x="502920" y="2697480"/>
+            <a:ext cx="384048" cy="384048"/>
+          </a:xfrm>
+          <a:prstGeom prst="ellipse">
+            <a:avLst/>
+          </a:prstGeom>
+          <a:solidFill>
+            <a:srgbClr val="E35205"/>
+          </a:solidFill>
+          <a:ln/>
+        </p:spPr>
+      </p:sp>
+      <p:sp>
+        <p:nvSpPr>
+          <p:cNvPr id="15" name="Text 12"/>
+          <p:cNvSpPr/>
+          <p:nvPr/>
+        </p:nvSpPr>
+        <p:spPr>
+          <a:xfrm>
+            <a:off x="502920" y="2697480"/>
+            <a:ext cx="384048" cy="384048"/>
+          </a:xfrm>
+          <a:prstGeom prst="rect">
+            <a:avLst/>
+          </a:prstGeom>
+          <a:noFill/>
+          <a:ln/>
+        </p:spPr>
+        <p:txBody>
+          <a:bodyPr wrap="square" lIns="0" tIns="0" rIns="0" bIns="0" rtlCol="0" anchor="ctr"/>
+          <a:lstStyle/>
+          <a:p>
+            <a:pPr algn="ctr" indent="0" marL="0">
+              <a:buNone/>
+            </a:pPr>
+            <a:r>
+              <a:rPr lang="en-US" sz="1500" b="1" dirty="0">
+                <a:solidFill>
+                  <a:srgbClr val="0E1726"/>
+                </a:solidFill>
+                <a:latin typeface="Arial" pitchFamily="34" charset="0"/>
+                <a:ea typeface="Arial" pitchFamily="34" charset="-122"/>
+                <a:cs typeface="Arial" pitchFamily="34" charset="-120"/>
+              </a:rPr>
+              <a:t>4</a:t>
+            </a:r>
+            <a:endParaRPr lang="en-US" sz="1500" dirty="0"/>
+          </a:p>
+        </p:txBody>
+      </p:sp>
+      <p:sp>
+        <p:nvSpPr>
+          <p:cNvPr id="16" name="Text 13"/>
+          <p:cNvSpPr/>
+          <p:nvPr/>
+        </p:nvSpPr>
+        <p:spPr>
+          <a:xfrm>
+            <a:off x="1051560" y="2697480"/>
+            <a:ext cx="7589520" cy="384048"/>
+          </a:xfrm>
+          <a:prstGeom prst="rect">
+            <a:avLst/>
+          </a:prstGeom>
+          <a:noFill/>
+          <a:ln/>
+        </p:spPr>
+        <p:txBody>
+          <a:bodyPr wrap="square" lIns="0" tIns="0" rIns="0" bIns="0" rtlCol="0" anchor="ctr"/>
+          <a:lstStyle/>
+          <a:p>
+            <a:pPr indent="0" marL="0">
+              <a:buNone/>
+            </a:pPr>
+            <a:r>
+              <a:rPr lang="en-US" sz="1350" dirty="0">
+                <a:solidFill>
+                  <a:srgbClr val="E6EDF3"/>
+                </a:solidFill>
+                <a:latin typeface="Calibri" pitchFamily="34" charset="0"/>
+                <a:ea typeface="Calibri" pitchFamily="34" charset="-122"/>
+                <a:cs typeface="Calibri" pitchFamily="34" charset="-120"/>
+              </a:rPr>
+              <a:t>Rank top 5 risks (likelihood × impact) + one mitigation each</a:t>
+            </a:r>
+            <a:endParaRPr lang="en-US" sz="1350" dirty="0"/>
+          </a:p>
+        </p:txBody>
+      </p:sp>
+      <p:sp>
+        <p:nvSpPr>
+          <p:cNvPr id="17" name="Text 14"/>
+          <p:cNvSpPr/>
+          <p:nvPr/>
+        </p:nvSpPr>
+        <p:spPr>
+          <a:xfrm>
+            <a:off x="548640" y="3246120"/>
+            <a:ext cx="8046720" cy="548640"/>
+          </a:xfrm>
+          <a:prstGeom prst="rect">
+            <a:avLst/>
+          </a:prstGeom>
+          <a:noFill/>
+          <a:ln/>
+        </p:spPr>
+        <p:txBody>
+          <a:bodyPr wrap="square" lIns="0" tIns="0" rIns="0" bIns="0" rtlCol="0" anchor="t"/>
+          <a:lstStyle/>
+          <a:p>
+            <a:pPr indent="0" marL="0">
+              <a:buNone/>
+            </a:pPr>
+            <a:r>
+              <a:rPr lang="en-US" sz="1400" dirty="0">
+                <a:solidFill>
+                  <a:srgbClr val="E6EDF3"/>
+                </a:solidFill>
+                <a:latin typeface="Calibri" pitchFamily="34" charset="0"/>
+                <a:ea typeface="Calibri" pitchFamily="34" charset="-122"/>
+                <a:cs typeface="Calibri" pitchFamily="34" charset="-120"/>
+              </a:rPr>
+              <a:t>Deliverable: 2–3 page threat model</a:t>
+            </a:r>
+            <a:endParaRPr lang="en-US" sz="1400" dirty="0"/>
+          </a:p>
+        </p:txBody>
+      </p:sp>
+      <p:sp>
+        <p:nvSpPr>
+          <p:cNvPr id="18" name="Text 15"/>
+          <p:cNvSpPr/>
+          <p:nvPr/>
+        </p:nvSpPr>
+        <p:spPr>
+          <a:xfrm>
+            <a:off x="457200" y="4800600"/>
+            <a:ext cx="6949440" cy="274320"/>
+          </a:xfrm>
+          <a:prstGeom prst="rect">
+            <a:avLst/>
+          </a:prstGeom>
+          <a:noFill/>
+          <a:ln/>
+        </p:spPr>
+        <p:txBody>
+          <a:bodyPr wrap="square" lIns="0" tIns="0" rIns="0" bIns="0" rtlCol="0" anchor="ctr"/>
+          <a:lstStyle/>
+          <a:p>
+            <a:pPr indent="0" marL="0">
+              <a:buNone/>
+            </a:pPr>
+            <a:r>
+              <a:rPr lang="en-US" sz="900" dirty="0">
+                <a:solidFill>
+                  <a:srgbClr val="94A3B8"/>
+                </a:solidFill>
+                <a:latin typeface="Calibri" pitchFamily="34" charset="0"/>
+                <a:ea typeface="Calibri" pitchFamily="34" charset="-122"/>
+                <a:cs typeface="Calibri" pitchFamily="34" charset="-120"/>
+              </a:rPr>
+              <a:t>Software Security · Week 1</a:t>
+            </a:r>
+            <a:endParaRPr lang="en-US" sz="900" dirty="0"/>
+          </a:p>
+        </p:txBody>
+      </p:sp>
+      <p:sp>
+        <p:nvSpPr>
+          <p:cNvPr id="19" name="Shape 16"/>
+          <p:cNvSpPr/>
+          <p:nvPr/>
+        </p:nvSpPr>
+        <p:spPr>
+          <a:xfrm>
+            <a:off x="7772400" y="4590288"/>
+            <a:ext cx="969264" cy="475488"/>
           </a:xfrm>
           <a:prstGeom prst="roundRect">
             <a:avLst>
-              <a:gd name="adj" fmla="val 2985"/>
+              <a:gd name="adj" fmla="val 11538"/>
             </a:avLst>
           </a:prstGeom>
           <a:solidFill>
-            <a:srgbClr val="18243A"/>
+            <a:srgbClr val="FFFFFF"/>
           </a:solidFill>
           <a:ln/>
           <a:effectLst>
@@ -4462,246 +4746,9 @@
           </a:effectLst>
         </p:spPr>
       </p:sp>
-      <p:sp>
-        <p:nvSpPr>
-          <p:cNvPr id="6" name="Text 3"/>
-          <p:cNvSpPr/>
-          <p:nvPr/>
-        </p:nvSpPr>
-        <p:spPr>
-          <a:xfrm>
-            <a:off x="731520" y="1435608"/>
-            <a:ext cx="7680960" cy="2231136"/>
-          </a:xfrm>
-          <a:prstGeom prst="rect">
-            <a:avLst/>
-          </a:prstGeom>
-          <a:noFill/>
-          <a:ln/>
-        </p:spPr>
-        <p:txBody>
-          <a:bodyPr wrap="square" lIns="0" tIns="0" rIns="0" bIns="0" rtlCol="0" anchor="t"/>
-          <a:lstStyle/>
-          <a:p>
-            <a:pPr marL="342900" indent="-342900">
-              <a:spcAft>
-                <a:spcPts val="600"/>
-              </a:spcAft>
-              <a:buSzPct val="100000"/>
-              <a:buChar char="•"/>
-            </a:pPr>
-            <a:r>
-              <a:rPr lang="en-US" sz="1400" dirty="0">
-                <a:solidFill>
-                  <a:srgbClr val="E6EDF3"/>
-                </a:solidFill>
-                <a:latin typeface="Calibri" pitchFamily="34" charset="0"/>
-                <a:ea typeface="Calibri" pitchFamily="34" charset="-122"/>
-                <a:cs typeface="Calibri" pitchFamily="34" charset="-120"/>
-              </a:rPr>
-              <a:t>AI is allowed — and you must disclose how you used it</a:t>
-            </a:r>
-            <a:endParaRPr lang="en-US" sz="1400" dirty="0"/>
-          </a:p>
-          <a:p>
-            <a:pPr marL="342900" indent="-342900">
-              <a:spcAft>
-                <a:spcPts val="600"/>
-              </a:spcAft>
-              <a:buSzPct val="100000"/>
-              <a:buChar char="•"/>
-            </a:pPr>
-            <a:r>
-              <a:rPr lang="en-US" sz="1400" dirty="0">
-                <a:solidFill>
-                  <a:srgbClr val="E6EDF3"/>
-                </a:solidFill>
-                <a:latin typeface="Calibri" pitchFamily="34" charset="0"/>
-                <a:ea typeface="Calibri" pitchFamily="34" charset="-122"/>
-                <a:cs typeface="Calibri" pitchFamily="34" charset="-120"/>
-              </a:rPr>
-              <a:t>But AI hallucinates APIs/CVEs and writes insecure code</a:t>
-            </a:r>
-            <a:endParaRPr lang="en-US" sz="1400" dirty="0"/>
-          </a:p>
-          <a:p>
-            <a:pPr marL="342900" indent="-342900">
-              <a:spcAft>
-                <a:spcPts val="600"/>
-              </a:spcAft>
-              <a:buSzPct val="100000"/>
-              <a:buChar char="•"/>
-            </a:pPr>
-            <a:r>
-              <a:rPr lang="en-US" sz="1400" dirty="0">
-                <a:solidFill>
-                  <a:srgbClr val="E6EDF3"/>
-                </a:solidFill>
-                <a:latin typeface="Calibri" pitchFamily="34" charset="0"/>
-                <a:ea typeface="Calibri" pitchFamily="34" charset="-122"/>
-                <a:cs typeface="Calibri" pitchFamily="34" charset="-120"/>
-              </a:rPr>
-              <a:t>You're graded on understanding, not on the answer:</a:t>
-            </a:r>
-            <a:endParaRPr lang="en-US" sz="1400" dirty="0"/>
-          </a:p>
-          <a:p>
-            <a:pPr lvl="1" marL="685800" indent="-342900">
-              <a:spcAft>
-                <a:spcPts val="600"/>
-              </a:spcAft>
-              <a:buSzPct val="100000"/>
-              <a:buChar char="•"/>
-            </a:pPr>
-            <a:r>
-              <a:rPr lang="en-US" sz="1400" dirty="0">
-                <a:solidFill>
-                  <a:srgbClr val="E6EDF3"/>
-                </a:solidFill>
-                <a:latin typeface="Calibri" pitchFamily="34" charset="0"/>
-                <a:ea typeface="Calibri" pitchFamily="34" charset="-122"/>
-                <a:cs typeface="Calibri" pitchFamily="34" charset="-120"/>
-              </a:rPr>
-              <a:t>random live re-demos — explain it or score zero</a:t>
-            </a:r>
-            <a:endParaRPr lang="en-US" sz="1400" dirty="0"/>
-          </a:p>
-          <a:p>
-            <a:pPr lvl="1" marL="685800" indent="-342900">
-              <a:spcAft>
-                <a:spcPts val="600"/>
-              </a:spcAft>
-              <a:buSzPct val="100000"/>
-              <a:buChar char="•"/>
-            </a:pPr>
-            <a:r>
-              <a:rPr lang="en-US" sz="1400" dirty="0">
-                <a:solidFill>
-                  <a:srgbClr val="E6EDF3"/>
-                </a:solidFill>
-                <a:latin typeface="Calibri" pitchFamily="34" charset="0"/>
-                <a:ea typeface="Calibri" pitchFamily="34" charset="-122"/>
-                <a:cs typeface="Calibri" pitchFamily="34" charset="-120"/>
-              </a:rPr>
-              <a:t>your flags are unique to you — copying is traceable</a:t>
-            </a:r>
-            <a:endParaRPr lang="en-US" sz="1400" dirty="0"/>
-          </a:p>
-          <a:p>
-            <a:pPr lvl="1" marL="685800" indent="-342900">
-              <a:spcAft>
-                <a:spcPts val="600"/>
-              </a:spcAft>
-              <a:buSzPct val="100000"/>
-              <a:buChar char="•"/>
-            </a:pPr>
-            <a:r>
-              <a:rPr lang="en-US" sz="1400" dirty="0">
-                <a:solidFill>
-                  <a:srgbClr val="E6EDF3"/>
-                </a:solidFill>
-                <a:latin typeface="Calibri" pitchFamily="34" charset="0"/>
-                <a:ea typeface="Calibri" pitchFamily="34" charset="-122"/>
-                <a:cs typeface="Calibri" pitchFamily="34" charset="-120"/>
-              </a:rPr>
-              <a:t>every lab has an “Audit the AI” task: find what its answer gets wrong</a:t>
-            </a:r>
-            <a:endParaRPr lang="en-US" sz="1400" dirty="0"/>
-          </a:p>
-          <a:p>
-            <a:pPr marL="342900" indent="-342900">
-              <a:spcAft>
-                <a:spcPts val="600"/>
-              </a:spcAft>
-              <a:buSzPct val="100000"/>
-              <a:buChar char="•"/>
-            </a:pPr>
-            <a:r>
-              <a:rPr lang="en-US" sz="1400" dirty="0">
-                <a:solidFill>
-                  <a:srgbClr val="E6EDF3"/>
-                </a:solidFill>
-                <a:latin typeface="Calibri" pitchFamily="34" charset="0"/>
-                <a:ea typeface="Calibri" pitchFamily="34" charset="-122"/>
-                <a:cs typeface="Calibri" pitchFamily="34" charset="-120"/>
-              </a:rPr>
-              <a:t>Use AI to learn faster — never to skip the thinking</a:t>
-            </a:r>
-            <a:endParaRPr lang="en-US" sz="1400" dirty="0"/>
-          </a:p>
-        </p:txBody>
-      </p:sp>
-      <p:sp>
-        <p:nvSpPr>
-          <p:cNvPr id="7" name="Text 4"/>
-          <p:cNvSpPr/>
-          <p:nvPr/>
-        </p:nvSpPr>
-        <p:spPr>
-          <a:xfrm>
-            <a:off x="457200" y="4800600"/>
-            <a:ext cx="6949440" cy="274320"/>
-          </a:xfrm>
-          <a:prstGeom prst="rect">
-            <a:avLst/>
-          </a:prstGeom>
-          <a:noFill/>
-          <a:ln/>
-        </p:spPr>
-        <p:txBody>
-          <a:bodyPr wrap="square" lIns="0" tIns="0" rIns="0" bIns="0" rtlCol="0" anchor="ctr"/>
-          <a:lstStyle/>
-          <a:p>
-            <a:pPr indent="0" marL="0">
-              <a:buNone/>
-            </a:pPr>
-            <a:r>
-              <a:rPr lang="en-US" sz="900" dirty="0">
-                <a:solidFill>
-                  <a:srgbClr val="94A3B8"/>
-                </a:solidFill>
-                <a:latin typeface="Calibri" pitchFamily="34" charset="0"/>
-                <a:ea typeface="Calibri" pitchFamily="34" charset="-122"/>
-                <a:cs typeface="Calibri" pitchFamily="34" charset="-120"/>
-              </a:rPr>
-              <a:t>Software Security · Week 1</a:t>
-            </a:r>
-            <a:endParaRPr lang="en-US" sz="900" dirty="0"/>
-          </a:p>
-        </p:txBody>
-      </p:sp>
-      <p:sp>
-        <p:nvSpPr>
-          <p:cNvPr id="8" name="Shape 5"/>
-          <p:cNvSpPr/>
-          <p:nvPr/>
-        </p:nvSpPr>
-        <p:spPr>
-          <a:xfrm>
-            <a:off x="7772400" y="4590288"/>
-            <a:ext cx="969264" cy="475488"/>
-          </a:xfrm>
-          <a:prstGeom prst="roundRect">
-            <a:avLst>
-              <a:gd name="adj" fmla="val 11538"/>
-            </a:avLst>
-          </a:prstGeom>
-          <a:solidFill>
-            <a:srgbClr val="FFFFFF"/>
-          </a:solidFill>
-          <a:ln/>
-          <a:effectLst>
-            <a:outerShdw sx="100000" sy="100000" kx="0" ky="0" algn="bl" rotWithShape="0" blurRad="101600" dist="38100" dir="5400000">
-              <a:srgbClr val="000000">
-                <a:alpha val="35000"/>
-              </a:srgbClr>
-            </a:outerShdw>
-          </a:effectLst>
-        </p:spPr>
-      </p:sp>
       <p:pic>
         <p:nvPicPr>
-          <p:cNvPr id="9" name="Image 1" descr="/Users/pop7/Library/CloudStorage/OneDrive-MonsterConnectCo.,Ltd/Lecture/KOSEN69 - software-security/slides/pptx/assets/logo-small.png">    </p:cNvPr>
+          <p:cNvPr id="20" name="Image 1" descr="/Users/pop7/Library/CloudStorage/OneDrive-MonsterConnectCo.,Ltd/Lecture/KOSEN69 - software-security/slides/pptx/assets/logo-small.png">    </p:cNvPr>
           <p:cNvPicPr>
             <a:picLocks noChangeAspect="1"/>
           </p:cNvPicPr>
@@ -4839,7 +4886,7 @@
                 <a:ea typeface="Arial" pitchFamily="34" charset="-122"/>
                 <a:cs typeface="Arial" pitchFamily="34" charset="-120"/>
               </a:rPr>
-              <a:t>Key takeaways</a:t>
+              <a:t>Using AI in this course</a:t>
             </a:r>
             <a:endParaRPr lang="en-US" sz="2600" dirty="0"/>
           </a:p>
@@ -4854,11 +4901,11 @@
         <p:spPr>
           <a:xfrm>
             <a:off x="457200" y="1325880"/>
-            <a:ext cx="8229600" cy="1207008"/>
+            <a:ext cx="8229600" cy="2450592"/>
           </a:xfrm>
           <a:prstGeom prst="roundRect">
             <a:avLst>
-              <a:gd name="adj" fmla="val 6061"/>
+              <a:gd name="adj" fmla="val 2985"/>
             </a:avLst>
           </a:prstGeom>
           <a:solidFill>
@@ -4883,7 +4930,7 @@
         <p:spPr>
           <a:xfrm>
             <a:off x="731520" y="1435608"/>
-            <a:ext cx="7680960" cy="987552"/>
+            <a:ext cx="7680960" cy="2231136"/>
           </a:xfrm>
           <a:prstGeom prst="rect">
             <a:avLst/>
@@ -4911,7 +4958,7 @@
                 <a:ea typeface="Calibri" pitchFamily="34" charset="-122"/>
                 <a:cs typeface="Calibri" pitchFamily="34" charset="-120"/>
               </a:rPr>
-              <a:t>Design for security; don't bolt it on</a:t>
+              <a:t>AI is allowed — and you must disclose how you used it</a:t>
             </a:r>
             <a:endParaRPr lang="en-US" sz="1400" dirty="0"/>
           </a:p>
@@ -4932,7 +4979,7 @@
                 <a:ea typeface="Calibri" pitchFamily="34" charset="-122"/>
                 <a:cs typeface="Calibri" pitchFamily="34" charset="-120"/>
               </a:rPr>
-              <a:t>Attackers need one gap — model the whole surface</a:t>
+              <a:t>But AI hallucinates APIs/CVEs and writes insecure code</a:t>
             </a:r>
             <a:endParaRPr lang="en-US" sz="1400" dirty="0"/>
           </a:p>
@@ -4953,7 +5000,91 @@
                 <a:ea typeface="Calibri" pitchFamily="34" charset="-122"/>
                 <a:cs typeface="Calibri" pitchFamily="34" charset="-120"/>
               </a:rPr>
-              <a:t>STRIDE + DFD = a repeatable way to find design flaws</a:t>
+              <a:t>You're graded on understanding, not the answer:</a:t>
+            </a:r>
+            <a:endParaRPr lang="en-US" sz="1400" dirty="0"/>
+          </a:p>
+          <a:p>
+            <a:pPr lvl="1" marL="685800" indent="-342900">
+              <a:spcAft>
+                <a:spcPts val="600"/>
+              </a:spcAft>
+              <a:buSzPct val="100000"/>
+              <a:buChar char="•"/>
+            </a:pPr>
+            <a:r>
+              <a:rPr lang="en-US" sz="1400" dirty="0">
+                <a:solidFill>
+                  <a:srgbClr val="E6EDF3"/>
+                </a:solidFill>
+                <a:latin typeface="Calibri" pitchFamily="34" charset="0"/>
+                <a:ea typeface="Calibri" pitchFamily="34" charset="-122"/>
+                <a:cs typeface="Calibri" pitchFamily="34" charset="-120"/>
+              </a:rPr>
+              <a:t>random live re-demos — explain it or score zero</a:t>
+            </a:r>
+            <a:endParaRPr lang="en-US" sz="1400" dirty="0"/>
+          </a:p>
+          <a:p>
+            <a:pPr lvl="1" marL="685800" indent="-342900">
+              <a:spcAft>
+                <a:spcPts val="600"/>
+              </a:spcAft>
+              <a:buSzPct val="100000"/>
+              <a:buChar char="•"/>
+            </a:pPr>
+            <a:r>
+              <a:rPr lang="en-US" sz="1400" dirty="0">
+                <a:solidFill>
+                  <a:srgbClr val="E6EDF3"/>
+                </a:solidFill>
+                <a:latin typeface="Calibri" pitchFamily="34" charset="0"/>
+                <a:ea typeface="Calibri" pitchFamily="34" charset="-122"/>
+                <a:cs typeface="Calibri" pitchFamily="34" charset="-120"/>
+              </a:rPr>
+              <a:t>your flags are unique to you — copying is traceable</a:t>
+            </a:r>
+            <a:endParaRPr lang="en-US" sz="1400" dirty="0"/>
+          </a:p>
+          <a:p>
+            <a:pPr lvl="1" marL="685800" indent="-342900">
+              <a:spcAft>
+                <a:spcPts val="600"/>
+              </a:spcAft>
+              <a:buSzPct val="100000"/>
+              <a:buChar char="•"/>
+            </a:pPr>
+            <a:r>
+              <a:rPr lang="en-US" sz="1400" dirty="0">
+                <a:solidFill>
+                  <a:srgbClr val="E6EDF3"/>
+                </a:solidFill>
+                <a:latin typeface="Calibri" pitchFamily="34" charset="0"/>
+                <a:ea typeface="Calibri" pitchFamily="34" charset="-122"/>
+                <a:cs typeface="Calibri" pitchFamily="34" charset="-120"/>
+              </a:rPr>
+              <a:t>every lab has an "Audit the AI" task: find what its answer gets wrong</a:t>
+            </a:r>
+            <a:endParaRPr lang="en-US" sz="1400" dirty="0"/>
+          </a:p>
+          <a:p>
+            <a:pPr marL="342900" indent="-342900">
+              <a:spcAft>
+                <a:spcPts val="600"/>
+              </a:spcAft>
+              <a:buSzPct val="100000"/>
+              <a:buChar char="•"/>
+            </a:pPr>
+            <a:r>
+              <a:rPr lang="en-US" sz="1400" dirty="0">
+                <a:solidFill>
+                  <a:srgbClr val="E6EDF3"/>
+                </a:solidFill>
+                <a:latin typeface="Calibri" pitchFamily="34" charset="0"/>
+                <a:ea typeface="Calibri" pitchFamily="34" charset="-122"/>
+                <a:cs typeface="Calibri" pitchFamily="34" charset="-120"/>
+              </a:rPr>
+              <a:t>Use AI to learn faster — never to skip the thinking</a:t>
             </a:r>
             <a:endParaRPr lang="en-US" sz="1400" dirty="0"/>
           </a:p>
@@ -5085,6 +5216,334 @@
       </p:grpSpPr>
       <p:sp>
         <p:nvSpPr>
+          <p:cNvPr id="2" name="Shape 0"/>
+          <p:cNvSpPr/>
+          <p:nvPr/>
+        </p:nvSpPr>
+        <p:spPr>
+          <a:xfrm>
+            <a:off x="457200" y="384048"/>
+            <a:ext cx="530352" cy="530352"/>
+          </a:xfrm>
+          <a:prstGeom prst="ellipse">
+            <a:avLst/>
+          </a:prstGeom>
+          <a:solidFill>
+            <a:srgbClr val="E35205"/>
+          </a:solidFill>
+          <a:ln/>
+          <a:effectLst>
+            <a:outerShdw sx="100000" sy="100000" kx="0" ky="0" algn="bl" rotWithShape="0" blurRad="101600" dist="38100" dir="5400000">
+              <a:srgbClr val="000000">
+                <a:alpha val="35000"/>
+              </a:srgbClr>
+            </a:outerShdw>
+          </a:effectLst>
+        </p:spPr>
+      </p:sp>
+      <p:pic>
+        <p:nvPicPr>
+          <p:cNvPr id="3" name="Image 0" descr="preencoded.png">    </p:cNvPr>
+          <p:cNvPicPr>
+            <a:picLocks noChangeAspect="1"/>
+          </p:cNvPicPr>
+          <p:nvPr/>
+        </p:nvPicPr>
+        <p:blipFill>
+          <a:blip r:embed="rId1"/>
+          <a:stretch>
+            <a:fillRect/>
+          </a:stretch>
+        </p:blipFill>
+        <p:spPr>
+          <a:xfrm>
+            <a:off x="594360" y="521208"/>
+            <a:ext cx="256032" cy="256032"/>
+          </a:xfrm>
+          <a:prstGeom prst="rect">
+            <a:avLst/>
+          </a:prstGeom>
+        </p:spPr>
+      </p:pic>
+      <p:sp>
+        <p:nvSpPr>
+          <p:cNvPr id="4" name="Text 1"/>
+          <p:cNvSpPr/>
+          <p:nvPr/>
+        </p:nvSpPr>
+        <p:spPr>
+          <a:xfrm>
+            <a:off x="1143000" y="329184"/>
+            <a:ext cx="7498080" cy="603504"/>
+          </a:xfrm>
+          <a:prstGeom prst="rect">
+            <a:avLst/>
+          </a:prstGeom>
+          <a:noFill/>
+          <a:ln/>
+        </p:spPr>
+        <p:txBody>
+          <a:bodyPr wrap="square" lIns="0" tIns="0" rIns="0" bIns="0" rtlCol="0" anchor="ctr"/>
+          <a:lstStyle/>
+          <a:p>
+            <a:pPr indent="0" marL="0">
+              <a:buNone/>
+            </a:pPr>
+            <a:r>
+              <a:rPr lang="en-US" sz="2600" b="1" dirty="0">
+                <a:solidFill>
+                  <a:srgbClr val="E6EDF3"/>
+                </a:solidFill>
+                <a:latin typeface="Arial" pitchFamily="34" charset="0"/>
+                <a:ea typeface="Arial" pitchFamily="34" charset="-122"/>
+                <a:cs typeface="Arial" pitchFamily="34" charset="-120"/>
+              </a:rPr>
+              <a:t>Key takeaways</a:t>
+            </a:r>
+            <a:endParaRPr lang="en-US" sz="2600" dirty="0"/>
+          </a:p>
+        </p:txBody>
+      </p:sp>
+      <p:sp>
+        <p:nvSpPr>
+          <p:cNvPr id="5" name="Shape 2"/>
+          <p:cNvSpPr/>
+          <p:nvPr/>
+        </p:nvSpPr>
+        <p:spPr>
+          <a:xfrm>
+            <a:off x="457200" y="1325880"/>
+            <a:ext cx="8229600" cy="1207008"/>
+          </a:xfrm>
+          <a:prstGeom prst="roundRect">
+            <a:avLst>
+              <a:gd name="adj" fmla="val 6061"/>
+            </a:avLst>
+          </a:prstGeom>
+          <a:solidFill>
+            <a:srgbClr val="18243A"/>
+          </a:solidFill>
+          <a:ln/>
+          <a:effectLst>
+            <a:outerShdw sx="100000" sy="100000" kx="0" ky="0" algn="bl" rotWithShape="0" blurRad="101600" dist="38100" dir="5400000">
+              <a:srgbClr val="000000">
+                <a:alpha val="35000"/>
+              </a:srgbClr>
+            </a:outerShdw>
+          </a:effectLst>
+        </p:spPr>
+      </p:sp>
+      <p:sp>
+        <p:nvSpPr>
+          <p:cNvPr id="6" name="Text 3"/>
+          <p:cNvSpPr/>
+          <p:nvPr/>
+        </p:nvSpPr>
+        <p:spPr>
+          <a:xfrm>
+            <a:off x="731520" y="1435608"/>
+            <a:ext cx="7680960" cy="987552"/>
+          </a:xfrm>
+          <a:prstGeom prst="rect">
+            <a:avLst/>
+          </a:prstGeom>
+          <a:noFill/>
+          <a:ln/>
+        </p:spPr>
+        <p:txBody>
+          <a:bodyPr wrap="square" lIns="0" tIns="0" rIns="0" bIns="0" rtlCol="0" anchor="t"/>
+          <a:lstStyle/>
+          <a:p>
+            <a:pPr marL="342900" indent="-342900">
+              <a:spcAft>
+                <a:spcPts val="600"/>
+              </a:spcAft>
+              <a:buSzPct val="100000"/>
+              <a:buChar char="•"/>
+            </a:pPr>
+            <a:r>
+              <a:rPr lang="en-US" sz="1400" dirty="0">
+                <a:solidFill>
+                  <a:srgbClr val="E6EDF3"/>
+                </a:solidFill>
+                <a:latin typeface="Calibri" pitchFamily="34" charset="0"/>
+                <a:ea typeface="Calibri" pitchFamily="34" charset="-122"/>
+                <a:cs typeface="Calibri" pitchFamily="34" charset="-120"/>
+              </a:rPr>
+              <a:t>Design for security; don't bolt it on</a:t>
+            </a:r>
+            <a:endParaRPr lang="en-US" sz="1400" dirty="0"/>
+          </a:p>
+          <a:p>
+            <a:pPr marL="342900" indent="-342900">
+              <a:spcAft>
+                <a:spcPts val="600"/>
+              </a:spcAft>
+              <a:buSzPct val="100000"/>
+              <a:buChar char="•"/>
+            </a:pPr>
+            <a:r>
+              <a:rPr lang="en-US" sz="1400" dirty="0">
+                <a:solidFill>
+                  <a:srgbClr val="E6EDF3"/>
+                </a:solidFill>
+                <a:latin typeface="Calibri" pitchFamily="34" charset="0"/>
+                <a:ea typeface="Calibri" pitchFamily="34" charset="-122"/>
+                <a:cs typeface="Calibri" pitchFamily="34" charset="-120"/>
+              </a:rPr>
+              <a:t>Attackers need one gap — model the whole surface</a:t>
+            </a:r>
+            <a:endParaRPr lang="en-US" sz="1400" dirty="0"/>
+          </a:p>
+          <a:p>
+            <a:pPr marL="342900" indent="-342900">
+              <a:spcAft>
+                <a:spcPts val="600"/>
+              </a:spcAft>
+              <a:buSzPct val="100000"/>
+              <a:buChar char="•"/>
+            </a:pPr>
+            <a:r>
+              <a:rPr lang="en-US" sz="1400" dirty="0">
+                <a:solidFill>
+                  <a:srgbClr val="E6EDF3"/>
+                </a:solidFill>
+                <a:latin typeface="Calibri" pitchFamily="34" charset="0"/>
+                <a:ea typeface="Calibri" pitchFamily="34" charset="-122"/>
+                <a:cs typeface="Calibri" pitchFamily="34" charset="-120"/>
+              </a:rPr>
+              <a:t>STRIDE + DFD = a repeatable way to find design flaws</a:t>
+            </a:r>
+            <a:endParaRPr lang="en-US" sz="1400" dirty="0"/>
+          </a:p>
+        </p:txBody>
+      </p:sp>
+      <p:sp>
+        <p:nvSpPr>
+          <p:cNvPr id="7" name="Text 4"/>
+          <p:cNvSpPr/>
+          <p:nvPr/>
+        </p:nvSpPr>
+        <p:spPr>
+          <a:xfrm>
+            <a:off x="457200" y="4800600"/>
+            <a:ext cx="6949440" cy="274320"/>
+          </a:xfrm>
+          <a:prstGeom prst="rect">
+            <a:avLst/>
+          </a:prstGeom>
+          <a:noFill/>
+          <a:ln/>
+        </p:spPr>
+        <p:txBody>
+          <a:bodyPr wrap="square" lIns="0" tIns="0" rIns="0" bIns="0" rtlCol="0" anchor="ctr"/>
+          <a:lstStyle/>
+          <a:p>
+            <a:pPr indent="0" marL="0">
+              <a:buNone/>
+            </a:pPr>
+            <a:r>
+              <a:rPr lang="en-US" sz="900" dirty="0">
+                <a:solidFill>
+                  <a:srgbClr val="94A3B8"/>
+                </a:solidFill>
+                <a:latin typeface="Calibri" pitchFamily="34" charset="0"/>
+                <a:ea typeface="Calibri" pitchFamily="34" charset="-122"/>
+                <a:cs typeface="Calibri" pitchFamily="34" charset="-120"/>
+              </a:rPr>
+              <a:t>Software Security · Week 1</a:t>
+            </a:r>
+            <a:endParaRPr lang="en-US" sz="900" dirty="0"/>
+          </a:p>
+        </p:txBody>
+      </p:sp>
+      <p:sp>
+        <p:nvSpPr>
+          <p:cNvPr id="8" name="Shape 5"/>
+          <p:cNvSpPr/>
+          <p:nvPr/>
+        </p:nvSpPr>
+        <p:spPr>
+          <a:xfrm>
+            <a:off x="7772400" y="4590288"/>
+            <a:ext cx="969264" cy="475488"/>
+          </a:xfrm>
+          <a:prstGeom prst="roundRect">
+            <a:avLst>
+              <a:gd name="adj" fmla="val 11538"/>
+            </a:avLst>
+          </a:prstGeom>
+          <a:solidFill>
+            <a:srgbClr val="FFFFFF"/>
+          </a:solidFill>
+          <a:ln/>
+          <a:effectLst>
+            <a:outerShdw sx="100000" sy="100000" kx="0" ky="0" algn="bl" rotWithShape="0" blurRad="101600" dist="38100" dir="5400000">
+              <a:srgbClr val="000000">
+                <a:alpha val="35000"/>
+              </a:srgbClr>
+            </a:outerShdw>
+          </a:effectLst>
+        </p:spPr>
+      </p:sp>
+      <p:pic>
+        <p:nvPicPr>
+          <p:cNvPr id="9" name="Image 1" descr="/Users/pop7/Library/CloudStorage/OneDrive-MonsterConnectCo.,Ltd/Lecture/KOSEN69 - software-security/slides/pptx/assets/logo-small.png">    </p:cNvPr>
+          <p:cNvPicPr>
+            <a:picLocks noChangeAspect="1"/>
+          </p:cNvPicPr>
+          <p:nvPr/>
+        </p:nvPicPr>
+        <p:blipFill>
+          <a:blip r:embed="rId2"/>
+          <a:stretch>
+            <a:fillRect/>
+          </a:stretch>
+        </p:blipFill>
+        <p:spPr>
+          <a:xfrm>
+            <a:off x="7872984" y="4681728"/>
+            <a:ext cx="768096" cy="356616"/>
+          </a:xfrm>
+          <a:prstGeom prst="rect">
+            <a:avLst/>
+          </a:prstGeom>
+        </p:spPr>
+      </p:pic>
+    </p:spTree>
+  </p:cSld>
+  <p:clrMapOvr>
+    <a:masterClrMapping/>
+  </p:clrMapOvr>
+</p:sld>
+</file>
+
+<file path=ppt/slides/slide17.xml><?xml version="1.0" encoding="utf-8"?>
+<p:sld xmlns:a="http://schemas.openxmlformats.org/drawingml/2006/main" xmlns:r="http://schemas.openxmlformats.org/officeDocument/2006/relationships" xmlns:p="http://schemas.openxmlformats.org/presentationml/2006/main">
+  <p:cSld name="Slide 17">
+    <p:bg>
+      <p:bgPr>
+        <a:solidFill>
+          <a:srgbClr val="0E1726"/>
+        </a:solidFill>
+      </p:bgPr>
+    </p:bg>
+    <p:spTree>
+      <p:nvGrpSpPr>
+        <p:cNvPr id="1" name=""/>
+        <p:cNvGrpSpPr/>
+        <p:nvPr/>
+      </p:nvGrpSpPr>
+      <p:grpSpPr>
+        <a:xfrm>
+          <a:off x="0" y="0"/>
+          <a:ext cx="0" cy="0"/>
+          <a:chOff x="0" y="0"/>
+          <a:chExt cx="0" cy="0"/>
+        </a:xfrm>
+      </p:grpSpPr>
+      <p:sp>
+        <p:nvSpPr>
           <p:cNvPr id="2" name="Text 0"/>
           <p:cNvSpPr/>
           <p:nvPr/>
@@ -5721,7 +6180,7 @@
                 <a:ea typeface="Arial" pitchFamily="34" charset="-122"/>
                 <a:cs typeface="Arial" pitchFamily="34" charset="-120"/>
               </a:rPr>
-              <a:t>Welcome — how this course works</a:t>
+              <a:t>How this course works</a:t>
             </a:r>
             <a:endParaRPr lang="en-US" sz="2600" dirty="0"/>
           </a:p>
@@ -5736,11 +6195,11 @@
         <p:spPr>
           <a:xfrm>
             <a:off x="457200" y="1325880"/>
-            <a:ext cx="8229600" cy="1207008"/>
+            <a:ext cx="8229600" cy="1517904"/>
           </a:xfrm>
           <a:prstGeom prst="roundRect">
             <a:avLst>
-              <a:gd name="adj" fmla="val 6061"/>
+              <a:gd name="adj" fmla="val 4819"/>
             </a:avLst>
           </a:prstGeom>
           <a:solidFill>
@@ -5765,7 +6224,7 @@
         <p:spPr>
           <a:xfrm>
             <a:off x="731520" y="1435608"/>
-            <a:ext cx="7680960" cy="987552"/>
+            <a:ext cx="7680960" cy="1298448"/>
           </a:xfrm>
           <a:prstGeom prst="rect">
             <a:avLst/>
@@ -5815,6 +6274,27 @@
                 <a:cs typeface="Calibri" pitchFamily="34" charset="-120"/>
               </a:rPr>
               <a:t>You'll break sandbox targets and defend your own code</a:t>
+            </a:r>
+            <a:endParaRPr lang="en-US" sz="1400" dirty="0"/>
+          </a:p>
+          <a:p>
+            <a:pPr marL="342900" indent="-342900">
+              <a:spcAft>
+                <a:spcPts val="600"/>
+              </a:spcAft>
+              <a:buSzPct val="100000"/>
+              <a:buChar char="•"/>
+            </a:pPr>
+            <a:r>
+              <a:rPr lang="en-US" sz="1400" dirty="0">
+                <a:solidFill>
+                  <a:srgbClr val="E6EDF3"/>
+                </a:solidFill>
+                <a:latin typeface="Calibri" pitchFamily="34" charset="0"/>
+                <a:ea typeface="Calibri" pitchFamily="34" charset="-122"/>
+                <a:cs typeface="Calibri" pitchFamily="34" charset="-120"/>
+              </a:rPr>
+              <a:t>Per-student flags · live scoreboard · weekly "Audit the AI"</a:t>
             </a:r>
             <a:endParaRPr lang="en-US" sz="1400" dirty="0"/>
           </a:p>
@@ -7115,6 +7595,434 @@
                 <a:ea typeface="Arial" pitchFamily="34" charset="-122"/>
                 <a:cs typeface="Arial" pitchFamily="34" charset="-120"/>
               </a:rPr>
+              <a:t>Worked example: the /upload endpoint</a:t>
+            </a:r>
+            <a:endParaRPr lang="en-US" sz="2600" dirty="0"/>
+          </a:p>
+        </p:txBody>
+      </p:sp>
+      <p:sp>
+        <p:nvSpPr>
+          <p:cNvPr id="5" name="Shape 2"/>
+          <p:cNvSpPr/>
+          <p:nvPr/>
+        </p:nvSpPr>
+        <p:spPr>
+          <a:xfrm>
+            <a:off x="457200" y="1325880"/>
+            <a:ext cx="8229600" cy="1042416"/>
+          </a:xfrm>
+          <a:prstGeom prst="roundRect">
+            <a:avLst>
+              <a:gd name="adj" fmla="val 5263"/>
+            </a:avLst>
+          </a:prstGeom>
+          <a:solidFill>
+            <a:srgbClr val="0A1020"/>
+          </a:solidFill>
+          <a:ln w="12700">
+            <a:solidFill>
+              <a:srgbClr val="1E2B45"/>
+            </a:solidFill>
+            <a:prstDash val="solid"/>
+          </a:ln>
+        </p:spPr>
+      </p:sp>
+      <p:sp>
+        <p:nvSpPr>
+          <p:cNvPr id="6" name="Text 3"/>
+          <p:cNvSpPr/>
+          <p:nvPr/>
+        </p:nvSpPr>
+        <p:spPr>
+          <a:xfrm>
+            <a:off x="640080" y="1399032"/>
+            <a:ext cx="7863840" cy="896112"/>
+          </a:xfrm>
+          <a:prstGeom prst="rect">
+            <a:avLst/>
+          </a:prstGeom>
+          <a:noFill/>
+          <a:ln/>
+        </p:spPr>
+        <p:txBody>
+          <a:bodyPr wrap="square" lIns="0" tIns="0" rIns="0" bIns="0" rtlCol="0" anchor="t"/>
+          <a:lstStyle/>
+          <a:p>
+            <a:pPr indent="0" marL="0">
+              <a:buNone/>
+            </a:pPr>
+            <a:r>
+              <a:rPr lang="en-US" sz="1150" dirty="0">
+                <a:solidFill>
+                  <a:srgbClr val="9FE7D6"/>
+                </a:solidFill>
+                <a:latin typeface="Courier New" pitchFamily="34" charset="0"/>
+                <a:ea typeface="Courier New" pitchFamily="34" charset="-122"/>
+                <a:cs typeface="Courier New" pitchFamily="34" charset="-120"/>
+              </a:rPr>
+              <a:t>Browser  --(file)--&gt;  [Flask app]  --save f.filename--&gt;  uploads/</a:t>
+            </a:r>
+            <a:endParaRPr lang="en-US" sz="1150" dirty="0"/>
+          </a:p>
+          <a:p>
+            <a:pPr indent="0" marL="0">
+              <a:buNone/>
+            </a:pPr>
+            <a:r>
+              <a:rPr lang="en-US" sz="1150" dirty="0">
+                <a:solidFill>
+                  <a:srgbClr val="9FE7D6"/>
+                </a:solidFill>
+                <a:latin typeface="Courier New" pitchFamily="34" charset="0"/>
+                <a:ea typeface="Courier New" pitchFamily="34" charset="-122"/>
+                <a:cs typeface="Courier New" pitchFamily="34" charset="-120"/>
+              </a:rPr>
+              <a:t>                            |                               ^</a:t>
+            </a:r>
+            <a:endParaRPr lang="en-US" sz="1150" dirty="0"/>
+          </a:p>
+          <a:p>
+            <a:pPr indent="0" marL="0">
+              <a:buNone/>
+            </a:pPr>
+            <a:r>
+              <a:rPr lang="en-US" sz="1150" dirty="0">
+                <a:solidFill>
+                  <a:srgbClr val="9FE7D6"/>
+                </a:solidFill>
+                <a:latin typeface="Courier New" pitchFamily="34" charset="0"/>
+                <a:ea typeface="Courier New" pitchFamily="34" charset="-122"/>
+                <a:cs typeface="Courier New" pitchFamily="34" charset="-120"/>
+              </a:rPr>
+              <a:t>                       /files/&lt;name&gt;  --------serves back---</a:t>
+            </a:r>
+            <a:endParaRPr lang="en-US" sz="1150" dirty="0"/>
+          </a:p>
+        </p:txBody>
+      </p:sp>
+      <p:sp>
+        <p:nvSpPr>
+          <p:cNvPr id="7" name="Shape 4"/>
+          <p:cNvSpPr/>
+          <p:nvPr/>
+        </p:nvSpPr>
+        <p:spPr>
+          <a:xfrm>
+            <a:off x="457200" y="2532888"/>
+            <a:ext cx="8229600" cy="1207008"/>
+          </a:xfrm>
+          <a:prstGeom prst="roundRect">
+            <a:avLst>
+              <a:gd name="adj" fmla="val 6061"/>
+            </a:avLst>
+          </a:prstGeom>
+          <a:solidFill>
+            <a:srgbClr val="18243A"/>
+          </a:solidFill>
+          <a:ln/>
+          <a:effectLst>
+            <a:outerShdw sx="100000" sy="100000" kx="0" ky="0" algn="bl" rotWithShape="0" blurRad="101600" dist="38100" dir="5400000">
+              <a:srgbClr val="000000">
+                <a:alpha val="35000"/>
+              </a:srgbClr>
+            </a:outerShdw>
+          </a:effectLst>
+        </p:spPr>
+      </p:sp>
+      <p:sp>
+        <p:nvSpPr>
+          <p:cNvPr id="8" name="Text 5"/>
+          <p:cNvSpPr/>
+          <p:nvPr/>
+        </p:nvSpPr>
+        <p:spPr>
+          <a:xfrm>
+            <a:off x="731520" y="2642616"/>
+            <a:ext cx="7680960" cy="987552"/>
+          </a:xfrm>
+          <a:prstGeom prst="rect">
+            <a:avLst/>
+          </a:prstGeom>
+          <a:noFill/>
+          <a:ln/>
+        </p:spPr>
+        <p:txBody>
+          <a:bodyPr wrap="square" lIns="0" tIns="0" rIns="0" bIns="0" rtlCol="0" anchor="t"/>
+          <a:lstStyle/>
+          <a:p>
+            <a:pPr marL="342900" indent="-342900">
+              <a:spcAft>
+                <a:spcPts val="600"/>
+              </a:spcAft>
+              <a:buSzPct val="100000"/>
+              <a:buChar char="•"/>
+            </a:pPr>
+            <a:r>
+              <a:rPr lang="en-US" sz="1400" dirty="0">
+                <a:solidFill>
+                  <a:srgbClr val="E6EDF3"/>
+                </a:solidFill>
+                <a:latin typeface="Calibri" pitchFamily="34" charset="0"/>
+                <a:ea typeface="Calibri" pitchFamily="34" charset="-122"/>
+                <a:cs typeface="Calibri" pitchFamily="34" charset="-120"/>
+              </a:rPr>
+              <a:t>Crosses the Internet → app trust boundary</a:t>
+            </a:r>
+            <a:endParaRPr lang="en-US" sz="1400" dirty="0"/>
+          </a:p>
+          <a:p>
+            <a:pPr marL="342900" indent="-342900">
+              <a:spcAft>
+                <a:spcPts val="600"/>
+              </a:spcAft>
+              <a:buSzPct val="100000"/>
+              <a:buChar char="•"/>
+            </a:pPr>
+            <a:r>
+              <a:rPr lang="en-US" sz="1400" dirty="0">
+                <a:solidFill>
+                  <a:srgbClr val="E6EDF3"/>
+                </a:solidFill>
+                <a:latin typeface="Calibri" pitchFamily="34" charset="0"/>
+                <a:ea typeface="Calibri" pitchFamily="34" charset="-122"/>
+                <a:cs typeface="Calibri" pitchFamily="34" charset="-120"/>
+              </a:rPr>
+              <a:t>Inputs: the file bytes and the filename (attacker-controlled)</a:t>
+            </a:r>
+            <a:endParaRPr lang="en-US" sz="1400" dirty="0"/>
+          </a:p>
+          <a:p>
+            <a:pPr marL="342900" indent="-342900">
+              <a:spcAft>
+                <a:spcPts val="600"/>
+              </a:spcAft>
+              <a:buSzPct val="100000"/>
+              <a:buChar char="•"/>
+            </a:pPr>
+            <a:r>
+              <a:rPr lang="en-US" sz="1400" dirty="0">
+                <a:solidFill>
+                  <a:srgbClr val="E6EDF3"/>
+                </a:solidFill>
+                <a:latin typeface="Calibri" pitchFamily="34" charset="0"/>
+                <a:ea typeface="Calibri" pitchFamily="34" charset="-122"/>
+                <a:cs typeface="Calibri" pitchFamily="34" charset="-120"/>
+              </a:rPr>
+              <a:t>../../etc/passwd as a filename → path traversal (read outside uploads/)</a:t>
+            </a:r>
+            <a:endParaRPr lang="en-US" sz="1400" dirty="0"/>
+          </a:p>
+        </p:txBody>
+      </p:sp>
+      <p:sp>
+        <p:nvSpPr>
+          <p:cNvPr id="9" name="Text 6"/>
+          <p:cNvSpPr/>
+          <p:nvPr/>
+        </p:nvSpPr>
+        <p:spPr>
+          <a:xfrm>
+            <a:off x="457200" y="4800600"/>
+            <a:ext cx="6949440" cy="274320"/>
+          </a:xfrm>
+          <a:prstGeom prst="rect">
+            <a:avLst/>
+          </a:prstGeom>
+          <a:noFill/>
+          <a:ln/>
+        </p:spPr>
+        <p:txBody>
+          <a:bodyPr wrap="square" lIns="0" tIns="0" rIns="0" bIns="0" rtlCol="0" anchor="ctr"/>
+          <a:lstStyle/>
+          <a:p>
+            <a:pPr indent="0" marL="0">
+              <a:buNone/>
+            </a:pPr>
+            <a:r>
+              <a:rPr lang="en-US" sz="900" dirty="0">
+                <a:solidFill>
+                  <a:srgbClr val="94A3B8"/>
+                </a:solidFill>
+                <a:latin typeface="Calibri" pitchFamily="34" charset="0"/>
+                <a:ea typeface="Calibri" pitchFamily="34" charset="-122"/>
+                <a:cs typeface="Calibri" pitchFamily="34" charset="-120"/>
+              </a:rPr>
+              <a:t>Software Security · Week 1</a:t>
+            </a:r>
+            <a:endParaRPr lang="en-US" sz="900" dirty="0"/>
+          </a:p>
+        </p:txBody>
+      </p:sp>
+      <p:sp>
+        <p:nvSpPr>
+          <p:cNvPr id="10" name="Shape 7"/>
+          <p:cNvSpPr/>
+          <p:nvPr/>
+        </p:nvSpPr>
+        <p:spPr>
+          <a:xfrm>
+            <a:off x="7772400" y="4590288"/>
+            <a:ext cx="969264" cy="475488"/>
+          </a:xfrm>
+          <a:prstGeom prst="roundRect">
+            <a:avLst>
+              <a:gd name="adj" fmla="val 11538"/>
+            </a:avLst>
+          </a:prstGeom>
+          <a:solidFill>
+            <a:srgbClr val="FFFFFF"/>
+          </a:solidFill>
+          <a:ln/>
+          <a:effectLst>
+            <a:outerShdw sx="100000" sy="100000" kx="0" ky="0" algn="bl" rotWithShape="0" blurRad="101600" dist="38100" dir="5400000">
+              <a:srgbClr val="000000">
+                <a:alpha val="35000"/>
+              </a:srgbClr>
+            </a:outerShdw>
+          </a:effectLst>
+        </p:spPr>
+      </p:sp>
+      <p:pic>
+        <p:nvPicPr>
+          <p:cNvPr id="11" name="Image 1" descr="/Users/pop7/Library/CloudStorage/OneDrive-MonsterConnectCo.,Ltd/Lecture/KOSEN69 - software-security/slides/pptx/assets/logo-small.png">    </p:cNvPr>
+          <p:cNvPicPr>
+            <a:picLocks noChangeAspect="1"/>
+          </p:cNvPicPr>
+          <p:nvPr/>
+        </p:nvPicPr>
+        <p:blipFill>
+          <a:blip r:embed="rId2"/>
+          <a:stretch>
+            <a:fillRect/>
+          </a:stretch>
+        </p:blipFill>
+        <p:spPr>
+          <a:xfrm>
+            <a:off x="7872984" y="4681728"/>
+            <a:ext cx="768096" cy="356616"/>
+          </a:xfrm>
+          <a:prstGeom prst="rect">
+            <a:avLst/>
+          </a:prstGeom>
+        </p:spPr>
+      </p:pic>
+    </p:spTree>
+  </p:cSld>
+  <p:clrMapOvr>
+    <a:masterClrMapping/>
+  </p:clrMapOvr>
+</p:sld>
+</file>
+
+<file path=ppt/slides/slide8.xml><?xml version="1.0" encoding="utf-8"?>
+<p:sld xmlns:a="http://schemas.openxmlformats.org/drawingml/2006/main" xmlns:r="http://schemas.openxmlformats.org/officeDocument/2006/relationships" xmlns:p="http://schemas.openxmlformats.org/presentationml/2006/main">
+  <p:cSld name="Slide 8">
+    <p:bg>
+      <p:bgPr>
+        <a:solidFill>
+          <a:srgbClr val="0E1726"/>
+        </a:solidFill>
+      </p:bgPr>
+    </p:bg>
+    <p:spTree>
+      <p:nvGrpSpPr>
+        <p:cNvPr id="1" name=""/>
+        <p:cNvGrpSpPr/>
+        <p:nvPr/>
+      </p:nvGrpSpPr>
+      <p:grpSpPr>
+        <a:xfrm>
+          <a:off x="0" y="0"/>
+          <a:ext cx="0" cy="0"/>
+          <a:chOff x="0" y="0"/>
+          <a:chExt cx="0" cy="0"/>
+        </a:xfrm>
+      </p:grpSpPr>
+      <p:sp>
+        <p:nvSpPr>
+          <p:cNvPr id="2" name="Shape 0"/>
+          <p:cNvSpPr/>
+          <p:nvPr/>
+        </p:nvSpPr>
+        <p:spPr>
+          <a:xfrm>
+            <a:off x="457200" y="384048"/>
+            <a:ext cx="530352" cy="530352"/>
+          </a:xfrm>
+          <a:prstGeom prst="ellipse">
+            <a:avLst/>
+          </a:prstGeom>
+          <a:solidFill>
+            <a:srgbClr val="E35205"/>
+          </a:solidFill>
+          <a:ln/>
+          <a:effectLst>
+            <a:outerShdw sx="100000" sy="100000" kx="0" ky="0" algn="bl" rotWithShape="0" blurRad="101600" dist="38100" dir="5400000">
+              <a:srgbClr val="000000">
+                <a:alpha val="35000"/>
+              </a:srgbClr>
+            </a:outerShdw>
+          </a:effectLst>
+        </p:spPr>
+      </p:sp>
+      <p:pic>
+        <p:nvPicPr>
+          <p:cNvPr id="3" name="Image 0" descr="preencoded.png">    </p:cNvPr>
+          <p:cNvPicPr>
+            <a:picLocks noChangeAspect="1"/>
+          </p:cNvPicPr>
+          <p:nvPr/>
+        </p:nvPicPr>
+        <p:blipFill>
+          <a:blip r:embed="rId1"/>
+          <a:stretch>
+            <a:fillRect/>
+          </a:stretch>
+        </p:blipFill>
+        <p:spPr>
+          <a:xfrm>
+            <a:off x="594360" y="521208"/>
+            <a:ext cx="256032" cy="256032"/>
+          </a:xfrm>
+          <a:prstGeom prst="rect">
+            <a:avLst/>
+          </a:prstGeom>
+        </p:spPr>
+      </p:pic>
+      <p:sp>
+        <p:nvSpPr>
+          <p:cNvPr id="4" name="Text 1"/>
+          <p:cNvSpPr/>
+          <p:nvPr/>
+        </p:nvSpPr>
+        <p:spPr>
+          <a:xfrm>
+            <a:off x="1143000" y="329184"/>
+            <a:ext cx="7498080" cy="603504"/>
+          </a:xfrm>
+          <a:prstGeom prst="rect">
+            <a:avLst/>
+          </a:prstGeom>
+          <a:noFill/>
+          <a:ln/>
+        </p:spPr>
+        <p:txBody>
+          <a:bodyPr wrap="square" lIns="0" tIns="0" rIns="0" bIns="0" rtlCol="0" anchor="ctr"/>
+          <a:lstStyle/>
+          <a:p>
+            <a:pPr indent="0" marL="0">
+              <a:buNone/>
+            </a:pPr>
+            <a:r>
+              <a:rPr lang="en-US" sz="2600" b="1" dirty="0">
+                <a:solidFill>
+                  <a:srgbClr val="E6EDF3"/>
+                </a:solidFill>
+                <a:latin typeface="Arial" pitchFamily="34" charset="0"/>
+                <a:ea typeface="Arial" pitchFamily="34" charset="-122"/>
+                <a:cs typeface="Arial" pitchFamily="34" charset="-120"/>
+              </a:rPr>
               <a:t>STRIDE</a:t>
             </a:r>
             <a:endParaRPr lang="en-US" sz="2600" dirty="0"/>
@@ -7123,7 +8031,7 @@
       </p:sp>
       <p:graphicFrame>
         <p:nvGraphicFramePr>
-          <p:cNvPr id="8" name="Table 0"/>
+          <p:cNvPr id="9" name="Table 0"/>
           <p:cNvGraphicFramePr>
             <a:graphicFrameLocks noGrp="1"/>
           </p:cNvGraphicFramePr>
@@ -8547,355 +9455,6 @@
 </p:sld>
 </file>
 
-<file path=ppt/slides/slide8.xml><?xml version="1.0" encoding="utf-8"?>
-<p:sld xmlns:a="http://schemas.openxmlformats.org/drawingml/2006/main" xmlns:r="http://schemas.openxmlformats.org/officeDocument/2006/relationships" xmlns:p="http://schemas.openxmlformats.org/presentationml/2006/main">
-  <p:cSld name="Slide 8">
-    <p:bg>
-      <p:bgPr>
-        <a:solidFill>
-          <a:srgbClr val="0E1726"/>
-        </a:solidFill>
-      </p:bgPr>
-    </p:bg>
-    <p:spTree>
-      <p:nvGrpSpPr>
-        <p:cNvPr id="1" name=""/>
-        <p:cNvGrpSpPr/>
-        <p:nvPr/>
-      </p:nvGrpSpPr>
-      <p:grpSpPr>
-        <a:xfrm>
-          <a:off x="0" y="0"/>
-          <a:ext cx="0" cy="0"/>
-          <a:chOff x="0" y="0"/>
-          <a:chExt cx="0" cy="0"/>
-        </a:xfrm>
-      </p:grpSpPr>
-      <p:sp>
-        <p:nvSpPr>
-          <p:cNvPr id="2" name="Shape 0"/>
-          <p:cNvSpPr/>
-          <p:nvPr/>
-        </p:nvSpPr>
-        <p:spPr>
-          <a:xfrm>
-            <a:off x="457200" y="384048"/>
-            <a:ext cx="530352" cy="530352"/>
-          </a:xfrm>
-          <a:prstGeom prst="ellipse">
-            <a:avLst/>
-          </a:prstGeom>
-          <a:solidFill>
-            <a:srgbClr val="E35205"/>
-          </a:solidFill>
-          <a:ln/>
-          <a:effectLst>
-            <a:outerShdw sx="100000" sy="100000" kx="0" ky="0" algn="bl" rotWithShape="0" blurRad="101600" dist="38100" dir="5400000">
-              <a:srgbClr val="000000">
-                <a:alpha val="35000"/>
-              </a:srgbClr>
-            </a:outerShdw>
-          </a:effectLst>
-        </p:spPr>
-      </p:sp>
-      <p:pic>
-        <p:nvPicPr>
-          <p:cNvPr id="3" name="Image 0" descr="preencoded.png">    </p:cNvPr>
-          <p:cNvPicPr>
-            <a:picLocks noChangeAspect="1"/>
-          </p:cNvPicPr>
-          <p:nvPr/>
-        </p:nvPicPr>
-        <p:blipFill>
-          <a:blip r:embed="rId1"/>
-          <a:stretch>
-            <a:fillRect/>
-          </a:stretch>
-        </p:blipFill>
-        <p:spPr>
-          <a:xfrm>
-            <a:off x="594360" y="521208"/>
-            <a:ext cx="256032" cy="256032"/>
-          </a:xfrm>
-          <a:prstGeom prst="rect">
-            <a:avLst/>
-          </a:prstGeom>
-        </p:spPr>
-      </p:pic>
-      <p:sp>
-        <p:nvSpPr>
-          <p:cNvPr id="4" name="Text 1"/>
-          <p:cNvSpPr/>
-          <p:nvPr/>
-        </p:nvSpPr>
-        <p:spPr>
-          <a:xfrm>
-            <a:off x="1143000" y="329184"/>
-            <a:ext cx="7498080" cy="603504"/>
-          </a:xfrm>
-          <a:prstGeom prst="rect">
-            <a:avLst/>
-          </a:prstGeom>
-          <a:noFill/>
-          <a:ln/>
-        </p:spPr>
-        <p:txBody>
-          <a:bodyPr wrap="square" lIns="0" tIns="0" rIns="0" bIns="0" rtlCol="0" anchor="ctr"/>
-          <a:lstStyle/>
-          <a:p>
-            <a:pPr indent="0" marL="0">
-              <a:buNone/>
-            </a:pPr>
-            <a:r>
-              <a:rPr lang="en-US" sz="2600" b="1" dirty="0">
-                <a:solidFill>
-                  <a:srgbClr val="E6EDF3"/>
-                </a:solidFill>
-                <a:latin typeface="Arial" pitchFamily="34" charset="0"/>
-                <a:ea typeface="Arial" pitchFamily="34" charset="-122"/>
-                <a:cs typeface="Arial" pitchFamily="34" charset="-120"/>
-              </a:rPr>
-              <a:t>The landscape you'll use all term</a:t>
-            </a:r>
-            <a:endParaRPr lang="en-US" sz="2600" dirty="0"/>
-          </a:p>
-        </p:txBody>
-      </p:sp>
-      <p:sp>
-        <p:nvSpPr>
-          <p:cNvPr id="5" name="Shape 2"/>
-          <p:cNvSpPr/>
-          <p:nvPr/>
-        </p:nvSpPr>
-        <p:spPr>
-          <a:xfrm>
-            <a:off x="457200" y="1325880"/>
-            <a:ext cx="8229600" cy="1517904"/>
-          </a:xfrm>
-          <a:prstGeom prst="roundRect">
-            <a:avLst>
-              <a:gd name="adj" fmla="val 4819"/>
-            </a:avLst>
-          </a:prstGeom>
-          <a:solidFill>
-            <a:srgbClr val="18243A"/>
-          </a:solidFill>
-          <a:ln/>
-          <a:effectLst>
-            <a:outerShdw sx="100000" sy="100000" kx="0" ky="0" algn="bl" rotWithShape="0" blurRad="101600" dist="38100" dir="5400000">
-              <a:srgbClr val="000000">
-                <a:alpha val="35000"/>
-              </a:srgbClr>
-            </a:outerShdw>
-          </a:effectLst>
-        </p:spPr>
-      </p:sp>
-      <p:sp>
-        <p:nvSpPr>
-          <p:cNvPr id="6" name="Text 3"/>
-          <p:cNvSpPr/>
-          <p:nvPr/>
-        </p:nvSpPr>
-        <p:spPr>
-          <a:xfrm>
-            <a:off x="731520" y="1435608"/>
-            <a:ext cx="7680960" cy="1298448"/>
-          </a:xfrm>
-          <a:prstGeom prst="rect">
-            <a:avLst/>
-          </a:prstGeom>
-          <a:noFill/>
-          <a:ln/>
-        </p:spPr>
-        <p:txBody>
-          <a:bodyPr wrap="square" lIns="0" tIns="0" rIns="0" bIns="0" rtlCol="0" anchor="t"/>
-          <a:lstStyle/>
-          <a:p>
-            <a:pPr marL="342900" indent="-342900">
-              <a:spcAft>
-                <a:spcPts val="600"/>
-              </a:spcAft>
-              <a:buSzPct val="100000"/>
-              <a:buChar char="•"/>
-            </a:pPr>
-            <a:r>
-              <a:rPr lang="en-US" sz="1400" dirty="0">
-                <a:solidFill>
-                  <a:srgbClr val="E6EDF3"/>
-                </a:solidFill>
-                <a:latin typeface="Calibri" pitchFamily="34" charset="0"/>
-                <a:ea typeface="Calibri" pitchFamily="34" charset="-122"/>
-                <a:cs typeface="Calibri" pitchFamily="34" charset="-120"/>
-              </a:rPr>
-              <a:t>OWASP Top 10 (2025) — most critical web risks</a:t>
-            </a:r>
-            <a:endParaRPr lang="en-US" sz="1400" dirty="0"/>
-          </a:p>
-          <a:p>
-            <a:pPr marL="342900" indent="-342900">
-              <a:spcAft>
-                <a:spcPts val="600"/>
-              </a:spcAft>
-              <a:buSzPct val="100000"/>
-              <a:buChar char="•"/>
-            </a:pPr>
-            <a:r>
-              <a:rPr lang="en-US" sz="1400" dirty="0">
-                <a:solidFill>
-                  <a:srgbClr val="E6EDF3"/>
-                </a:solidFill>
-                <a:latin typeface="Calibri" pitchFamily="34" charset="0"/>
-                <a:ea typeface="Calibri" pitchFamily="34" charset="-122"/>
-                <a:cs typeface="Calibri" pitchFamily="34" charset="-120"/>
-              </a:rPr>
-              <a:t>OWASP LLM Top 10 (2025) — AI app risks</a:t>
-            </a:r>
-            <a:endParaRPr lang="en-US" sz="1400" dirty="0"/>
-          </a:p>
-          <a:p>
-            <a:pPr marL="342900" indent="-342900">
-              <a:spcAft>
-                <a:spcPts val="600"/>
-              </a:spcAft>
-              <a:buSzPct val="100000"/>
-              <a:buChar char="•"/>
-            </a:pPr>
-            <a:r>
-              <a:rPr lang="en-US" sz="1400" dirty="0">
-                <a:solidFill>
-                  <a:srgbClr val="E6EDF3"/>
-                </a:solidFill>
-                <a:latin typeface="Calibri" pitchFamily="34" charset="0"/>
-                <a:ea typeface="Calibri" pitchFamily="34" charset="-122"/>
-                <a:cs typeface="Calibri" pitchFamily="34" charset="-120"/>
-              </a:rPr>
-              <a:t>MITRE CWE — weakness catalog</a:t>
-            </a:r>
-            <a:endParaRPr lang="en-US" sz="1400" dirty="0"/>
-          </a:p>
-          <a:p>
-            <a:pPr marL="342900" indent="-342900">
-              <a:spcAft>
-                <a:spcPts val="600"/>
-              </a:spcAft>
-              <a:buSzPct val="100000"/>
-              <a:buChar char="•"/>
-            </a:pPr>
-            <a:r>
-              <a:rPr lang="en-US" sz="1400" dirty="0">
-                <a:solidFill>
-                  <a:srgbClr val="E6EDF3"/>
-                </a:solidFill>
-                <a:latin typeface="Calibri" pitchFamily="34" charset="0"/>
-                <a:ea typeface="Calibri" pitchFamily="34" charset="-122"/>
-                <a:cs typeface="Calibri" pitchFamily="34" charset="-120"/>
-              </a:rPr>
-              <a:t>MITRE ATT&amp;CK — adversary tactics &amp; techniques</a:t>
-            </a:r>
-            <a:endParaRPr lang="en-US" sz="1400" dirty="0"/>
-          </a:p>
-        </p:txBody>
-      </p:sp>
-      <p:sp>
-        <p:nvSpPr>
-          <p:cNvPr id="7" name="Text 4"/>
-          <p:cNvSpPr/>
-          <p:nvPr/>
-        </p:nvSpPr>
-        <p:spPr>
-          <a:xfrm>
-            <a:off x="457200" y="4800600"/>
-            <a:ext cx="6949440" cy="274320"/>
-          </a:xfrm>
-          <a:prstGeom prst="rect">
-            <a:avLst/>
-          </a:prstGeom>
-          <a:noFill/>
-          <a:ln/>
-        </p:spPr>
-        <p:txBody>
-          <a:bodyPr wrap="square" lIns="0" tIns="0" rIns="0" bIns="0" rtlCol="0" anchor="ctr"/>
-          <a:lstStyle/>
-          <a:p>
-            <a:pPr indent="0" marL="0">
-              <a:buNone/>
-            </a:pPr>
-            <a:r>
-              <a:rPr lang="en-US" sz="900" dirty="0">
-                <a:solidFill>
-                  <a:srgbClr val="94A3B8"/>
-                </a:solidFill>
-                <a:latin typeface="Calibri" pitchFamily="34" charset="0"/>
-                <a:ea typeface="Calibri" pitchFamily="34" charset="-122"/>
-                <a:cs typeface="Calibri" pitchFamily="34" charset="-120"/>
-              </a:rPr>
-              <a:t>Software Security · Week 1</a:t>
-            </a:r>
-            <a:endParaRPr lang="en-US" sz="900" dirty="0"/>
-          </a:p>
-        </p:txBody>
-      </p:sp>
-      <p:sp>
-        <p:nvSpPr>
-          <p:cNvPr id="8" name="Shape 5"/>
-          <p:cNvSpPr/>
-          <p:nvPr/>
-        </p:nvSpPr>
-        <p:spPr>
-          <a:xfrm>
-            <a:off x="7772400" y="4590288"/>
-            <a:ext cx="969264" cy="475488"/>
-          </a:xfrm>
-          <a:prstGeom prst="roundRect">
-            <a:avLst>
-              <a:gd name="adj" fmla="val 11538"/>
-            </a:avLst>
-          </a:prstGeom>
-          <a:solidFill>
-            <a:srgbClr val="FFFFFF"/>
-          </a:solidFill>
-          <a:ln/>
-          <a:effectLst>
-            <a:outerShdw sx="100000" sy="100000" kx="0" ky="0" algn="bl" rotWithShape="0" blurRad="101600" dist="38100" dir="5400000">
-              <a:srgbClr val="000000">
-                <a:alpha val="35000"/>
-              </a:srgbClr>
-            </a:outerShdw>
-          </a:effectLst>
-        </p:spPr>
-      </p:sp>
-      <p:pic>
-        <p:nvPicPr>
-          <p:cNvPr id="9" name="Image 1" descr="/Users/pop7/Library/CloudStorage/OneDrive-MonsterConnectCo.,Ltd/Lecture/KOSEN69 - software-security/slides/pptx/assets/logo-small.png">    </p:cNvPr>
-          <p:cNvPicPr>
-            <a:picLocks noChangeAspect="1"/>
-          </p:cNvPicPr>
-          <p:nvPr/>
-        </p:nvPicPr>
-        <p:blipFill>
-          <a:blip r:embed="rId2"/>
-          <a:stretch>
-            <a:fillRect/>
-          </a:stretch>
-        </p:blipFill>
-        <p:spPr>
-          <a:xfrm>
-            <a:off x="7872984" y="4681728"/>
-            <a:ext cx="768096" cy="356616"/>
-          </a:xfrm>
-          <a:prstGeom prst="rect">
-            <a:avLst/>
-          </a:prstGeom>
-        </p:spPr>
-      </p:pic>
-    </p:spTree>
-  </p:cSld>
-  <p:clrMapOvr>
-    <a:masterClrMapping/>
-  </p:clrMapOvr>
-</p:sld>
-</file>
-
 <file path=ppt/slides/slide9.xml><?xml version="1.0" encoding="utf-8"?>
 <p:sld xmlns:a="http://schemas.openxmlformats.org/drawingml/2006/main" xmlns:r="http://schemas.openxmlformats.org/officeDocument/2006/relationships" xmlns:p="http://schemas.openxmlformats.org/presentationml/2006/main">
   <p:cSld name="Slide 9">
@@ -9004,7 +9563,7 @@
                 <a:ea typeface="Arial" pitchFamily="34" charset="-122"/>
                 <a:cs typeface="Arial" pitchFamily="34" charset="-120"/>
               </a:rPr>
-              <a:t>Secure by Design</a:t>
+              <a:t>STRIDE applied to /upload</a:t>
             </a:r>
             <a:endParaRPr lang="en-US" sz="2600" dirty="0"/>
           </a:p>
@@ -9019,11 +9578,11 @@
         <p:spPr>
           <a:xfrm>
             <a:off x="457200" y="1325880"/>
-            <a:ext cx="8229600" cy="1207008"/>
+            <a:ext cx="8229600" cy="2139696"/>
           </a:xfrm>
           <a:prstGeom prst="roundRect">
             <a:avLst>
-              <a:gd name="adj" fmla="val 6061"/>
+              <a:gd name="adj" fmla="val 3419"/>
             </a:avLst>
           </a:prstGeom>
           <a:solidFill>
@@ -9048,7 +9607,7 @@
         <p:spPr>
           <a:xfrm>
             <a:off x="731520" y="1435608"/>
-            <a:ext cx="7680960" cy="987552"/>
+            <a:ext cx="7680960" cy="1920240"/>
           </a:xfrm>
           <a:prstGeom prst="rect">
             <a:avLst/>
@@ -9076,7 +9635,7 @@
                 <a:ea typeface="Calibri" pitchFamily="34" charset="-122"/>
                 <a:cs typeface="Calibri" pitchFamily="34" charset="-120"/>
               </a:rPr>
-              <a:t>CISA "Secure by Design": safety is the vendor's job, on by default</a:t>
+              <a:t>S — no auth: anyone can upload as "anyone"</a:t>
             </a:r>
             <a:endParaRPr lang="en-US" sz="1400" dirty="0"/>
           </a:p>
@@ -9097,7 +9656,7 @@
                 <a:ea typeface="Calibri" pitchFamily="34" charset="-122"/>
                 <a:cs typeface="Calibri" pitchFamily="34" charset="-120"/>
               </a:rPr>
-              <a:t>Shift from "patch later" to "design out the bug class"</a:t>
+              <a:t>T — overwrite another user's file (same name)</a:t>
             </a:r>
             <a:endParaRPr lang="en-US" sz="1400" dirty="0"/>
           </a:p>
@@ -9118,7 +9677,70 @@
                 <a:ea typeface="Calibri" pitchFamily="34" charset="-122"/>
                 <a:cs typeface="Calibri" pitchFamily="34" charset="-120"/>
               </a:rPr>
-              <a:t>Industry/government push toward memory-safe languages (more in Wk 11)</a:t>
+              <a:t>R — no logs → can't prove who uploaded the malware</a:t>
+            </a:r>
+            <a:endParaRPr lang="en-US" sz="1400" dirty="0"/>
+          </a:p>
+          <a:p>
+            <a:pPr marL="342900" indent="-342900">
+              <a:spcAft>
+                <a:spcPts val="600"/>
+              </a:spcAft>
+              <a:buSzPct val="100000"/>
+              <a:buChar char="•"/>
+            </a:pPr>
+            <a:r>
+              <a:rPr lang="en-US" sz="1400" dirty="0">
+                <a:solidFill>
+                  <a:srgbClr val="E6EDF3"/>
+                </a:solidFill>
+                <a:latin typeface="Calibri" pitchFamily="34" charset="0"/>
+                <a:ea typeface="Calibri" pitchFamily="34" charset="-122"/>
+                <a:cs typeface="Calibri" pitchFamily="34" charset="-120"/>
+              </a:rPr>
+              <a:t>I — ../ filename reads files outside the folder</a:t>
+            </a:r>
+            <a:endParaRPr lang="en-US" sz="1400" dirty="0"/>
+          </a:p>
+          <a:p>
+            <a:pPr marL="342900" indent="-342900">
+              <a:spcAft>
+                <a:spcPts val="600"/>
+              </a:spcAft>
+              <a:buSzPct val="100000"/>
+              <a:buChar char="•"/>
+            </a:pPr>
+            <a:r>
+              <a:rPr lang="en-US" sz="1400" dirty="0">
+                <a:solidFill>
+                  <a:srgbClr val="E6EDF3"/>
+                </a:solidFill>
+                <a:latin typeface="Calibri" pitchFamily="34" charset="0"/>
+                <a:ea typeface="Calibri" pitchFamily="34" charset="-122"/>
+                <a:cs typeface="Calibri" pitchFamily="34" charset="-120"/>
+              </a:rPr>
+              <a:t>D — no size limit → fill the disk</a:t>
+            </a:r>
+            <a:endParaRPr lang="en-US" sz="1400" dirty="0"/>
+          </a:p>
+          <a:p>
+            <a:pPr marL="342900" indent="-342900">
+              <a:spcAft>
+                <a:spcPts val="600"/>
+              </a:spcAft>
+              <a:buSzPct val="100000"/>
+              <a:buChar char="•"/>
+            </a:pPr>
+            <a:r>
+              <a:rPr lang="en-US" sz="1400" dirty="0">
+                <a:solidFill>
+                  <a:srgbClr val="E6EDF3"/>
+                </a:solidFill>
+                <a:latin typeface="Calibri" pitchFamily="34" charset="0"/>
+                <a:ea typeface="Calibri" pitchFamily="34" charset="-122"/>
+                <a:cs typeface="Calibri" pitchFamily="34" charset="-120"/>
+              </a:rPr>
+              <a:t>E — upload shell.php, then request it → code execution</a:t>
             </a:r>
             <a:endParaRPr lang="en-US" sz="1400" dirty="0"/>
           </a:p>

</xml_diff>

<commit_message>
Switch slide decks to a white (light) theme
Recolor the pptx converter to a clean white background: white BG, dark slate text,
light-grey cards, KMITL orange + KOSEN blue accents (stronger red for contrast),
softer shadows. Logo now sits directly on white (removed the white backing chips).
Code blocks stay dark for readability. Rebuilt all 19 decks (~3 MB total). QA:
title, content cards, and tables read cleanly; logo crisp on white.

Co-Authored-By: Claude Opus 4.8 <noreply@anthropic.com>
</commit_message>
<xml_diff>
--- a/slides/pptx/week01.pptx
+++ b/slides/pptx/week01.pptx
@@ -2281,7 +2281,7 @@
     <p:bg>
       <p:bgPr>
         <a:solidFill>
-          <a:srgbClr val="0E1726"/>
+          <a:srgbClr val="FFFFFF"/>
         </a:solidFill>
       </p:bgPr>
     </p:bg>
@@ -2299,38 +2299,9 @@
           <a:chExt cx="0" cy="0"/>
         </a:xfrm>
       </p:grpSpPr>
-      <p:sp>
-        <p:nvSpPr>
-          <p:cNvPr id="2" name="Shape 0"/>
-          <p:cNvSpPr/>
-          <p:nvPr/>
-        </p:nvSpPr>
-        <p:spPr>
-          <a:xfrm>
-            <a:off x="603504" y="411480"/>
-            <a:ext cx="1874520" cy="932688"/>
-          </a:xfrm>
-          <a:prstGeom prst="roundRect">
-            <a:avLst>
-              <a:gd name="adj" fmla="val 7843"/>
-            </a:avLst>
-          </a:prstGeom>
-          <a:solidFill>
-            <a:srgbClr val="FFFFFF"/>
-          </a:solidFill>
-          <a:ln/>
-          <a:effectLst>
-            <a:outerShdw sx="100000" sy="100000" kx="0" ky="0" algn="bl" rotWithShape="0" blurRad="101600" dist="38100" dir="5400000">
-              <a:srgbClr val="000000">
-                <a:alpha val="35000"/>
-              </a:srgbClr>
-            </a:outerShdw>
-          </a:effectLst>
-        </p:spPr>
-      </p:sp>
       <p:pic>
         <p:nvPicPr>
-          <p:cNvPr id="3" name="Image 0" descr="/Users/pop7/Library/CloudStorage/OneDrive-MonsterConnectCo.,Ltd/Lecture/KOSEN69 - software-security/slides/pptx/assets/logo-small.png">    </p:cNvPr>
+          <p:cNvPr id="2" name="Image 0" descr="/Users/pop7/Library/CloudStorage/OneDrive-MonsterConnectCo.,Ltd/Lecture/KOSEN69 - software-security/slides/pptx/assets/logo-small.png">    </p:cNvPr>
           <p:cNvPicPr>
             <a:picLocks noChangeAspect="1"/>
           </p:cNvPicPr>
@@ -2344,8 +2315,8 @@
         </p:blipFill>
         <p:spPr>
           <a:xfrm>
-            <a:off x="758952" y="566928"/>
-            <a:ext cx="1563624" cy="621792"/>
+            <a:off x="640080" y="502920"/>
+            <a:ext cx="1691640" cy="676656"/>
           </a:xfrm>
           <a:prstGeom prst="rect">
             <a:avLst/>
@@ -2354,7 +2325,7 @@
       </p:pic>
       <p:sp>
         <p:nvSpPr>
-          <p:cNvPr id="4" name="Text 1"/>
+          <p:cNvPr id="3" name="Text 0"/>
           <p:cNvSpPr/>
           <p:nvPr/>
         </p:nvSpPr>
@@ -2393,7 +2364,7 @@
       </p:sp>
       <p:sp>
         <p:nvSpPr>
-          <p:cNvPr id="5" name="Text 2"/>
+          <p:cNvPr id="4" name="Text 1"/>
           <p:cNvSpPr/>
           <p:nvPr/>
         </p:nvSpPr>
@@ -2421,7 +2392,7 @@
             <a:r>
               <a:rPr lang="en-US" sz="4000" b="1" dirty="0">
                 <a:solidFill>
-                  <a:srgbClr val="E6EDF3"/>
+                  <a:srgbClr val="1F2937"/>
                 </a:solidFill>
                 <a:latin typeface="Arial" pitchFamily="34" charset="0"/>
                 <a:ea typeface="Arial" pitchFamily="34" charset="-122"/>
@@ -2435,7 +2406,7 @@
       </p:sp>
       <p:sp>
         <p:nvSpPr>
-          <p:cNvPr id="6" name="Text 3"/>
+          <p:cNvPr id="5" name="Text 2"/>
           <p:cNvSpPr/>
           <p:nvPr/>
         </p:nvSpPr>
@@ -2460,7 +2431,7 @@
             <a:r>
               <a:rPr lang="en-US" sz="1400" dirty="0">
                 <a:solidFill>
-                  <a:srgbClr val="94A3B8"/>
+                  <a:srgbClr val="64748B"/>
                 </a:solidFill>
                 <a:latin typeface="Calibri" pitchFamily="34" charset="0"/>
                 <a:ea typeface="Calibri" pitchFamily="34" charset="-122"/>
@@ -2486,7 +2457,7 @@
     <p:bg>
       <p:bgPr>
         <a:solidFill>
-          <a:srgbClr val="0E1726"/>
+          <a:srgbClr val="FFFFFF"/>
         </a:solidFill>
       </p:bgPr>
     </p:bg>
@@ -2523,9 +2494,9 @@
           </a:solidFill>
           <a:ln/>
           <a:effectLst>
-            <a:outerShdw sx="100000" sy="100000" kx="0" ky="0" algn="bl" rotWithShape="0" blurRad="101600" dist="38100" dir="5400000">
+            <a:outerShdw sx="100000" sy="100000" kx="0" ky="0" algn="bl" rotWithShape="0" blurRad="76200" dist="25400" dir="5400000">
               <a:srgbClr val="000000">
-                <a:alpha val="35000"/>
+                <a:alpha val="12000"/>
               </a:srgbClr>
             </a:outerShdw>
           </a:effectLst>
@@ -2582,7 +2553,7 @@
             <a:r>
               <a:rPr lang="en-US" sz="2600" b="1" dirty="0">
                 <a:solidFill>
-                  <a:srgbClr val="E6EDF3"/>
+                  <a:srgbClr val="1F2937"/>
                 </a:solidFill>
                 <a:latin typeface="Arial" pitchFamily="34" charset="0"/>
                 <a:ea typeface="Arial" pitchFamily="34" charset="-122"/>
@@ -2611,13 +2582,13 @@
             </a:avLst>
           </a:prstGeom>
           <a:solidFill>
-            <a:srgbClr val="18243A"/>
+            <a:srgbClr val="F1F5F9"/>
           </a:solidFill>
           <a:ln/>
           <a:effectLst>
-            <a:outerShdw sx="100000" sy="100000" kx="0" ky="0" algn="bl" rotWithShape="0" blurRad="101600" dist="38100" dir="5400000">
+            <a:outerShdw sx="100000" sy="100000" kx="0" ky="0" algn="bl" rotWithShape="0" blurRad="76200" dist="25400" dir="5400000">
               <a:srgbClr val="000000">
-                <a:alpha val="35000"/>
+                <a:alpha val="12000"/>
               </a:srgbClr>
             </a:outerShdw>
           </a:effectLst>
@@ -2654,7 +2625,7 @@
             <a:r>
               <a:rPr lang="en-US" sz="1400" dirty="0">
                 <a:solidFill>
-                  <a:srgbClr val="E6EDF3"/>
+                  <a:srgbClr val="1F2937"/>
                 </a:solidFill>
                 <a:latin typeface="Calibri" pitchFamily="34" charset="0"/>
                 <a:ea typeface="Calibri" pitchFamily="34" charset="-122"/>
@@ -2675,7 +2646,7 @@
             <a:r>
               <a:rPr lang="en-US" sz="1400" dirty="0">
                 <a:solidFill>
-                  <a:srgbClr val="E6EDF3"/>
+                  <a:srgbClr val="1F2937"/>
                 </a:solidFill>
                 <a:latin typeface="Calibri" pitchFamily="34" charset="0"/>
                 <a:ea typeface="Calibri" pitchFamily="34" charset="-122"/>
@@ -2696,7 +2667,7 @@
             <a:r>
               <a:rPr lang="en-US" sz="1400" dirty="0">
                 <a:solidFill>
-                  <a:srgbClr val="E6EDF3"/>
+                  <a:srgbClr val="1F2937"/>
                 </a:solidFill>
                 <a:latin typeface="Calibri" pitchFamily="34" charset="0"/>
                 <a:ea typeface="Calibri" pitchFamily="34" charset="-122"/>
@@ -2717,7 +2688,7 @@
             <a:r>
               <a:rPr lang="en-US" sz="1400" dirty="0">
                 <a:solidFill>
-                  <a:srgbClr val="E6EDF3"/>
+                  <a:srgbClr val="1F2937"/>
                 </a:solidFill>
                 <a:latin typeface="Calibri" pitchFamily="34" charset="0"/>
                 <a:ea typeface="Calibri" pitchFamily="34" charset="-122"/>
@@ -2756,7 +2727,7 @@
             <a:r>
               <a:rPr lang="en-US" sz="900" dirty="0">
                 <a:solidFill>
-                  <a:srgbClr val="94A3B8"/>
+                  <a:srgbClr val="64748B"/>
                 </a:solidFill>
                 <a:latin typeface="Calibri" pitchFamily="34" charset="0"/>
                 <a:ea typeface="Calibri" pitchFamily="34" charset="-122"/>
@@ -2768,38 +2739,9 @@
           </a:p>
         </p:txBody>
       </p:sp>
-      <p:sp>
-        <p:nvSpPr>
-          <p:cNvPr id="8" name="Shape 5"/>
-          <p:cNvSpPr/>
-          <p:nvPr/>
-        </p:nvSpPr>
-        <p:spPr>
-          <a:xfrm>
-            <a:off x="7772400" y="4590288"/>
-            <a:ext cx="969264" cy="475488"/>
-          </a:xfrm>
-          <a:prstGeom prst="roundRect">
-            <a:avLst>
-              <a:gd name="adj" fmla="val 11538"/>
-            </a:avLst>
-          </a:prstGeom>
-          <a:solidFill>
-            <a:srgbClr val="FFFFFF"/>
-          </a:solidFill>
-          <a:ln/>
-          <a:effectLst>
-            <a:outerShdw sx="100000" sy="100000" kx="0" ky="0" algn="bl" rotWithShape="0" blurRad="101600" dist="38100" dir="5400000">
-              <a:srgbClr val="000000">
-                <a:alpha val="35000"/>
-              </a:srgbClr>
-            </a:outerShdw>
-          </a:effectLst>
-        </p:spPr>
-      </p:sp>
       <p:pic>
         <p:nvPicPr>
-          <p:cNvPr id="9" name="Image 1" descr="/Users/pop7/Library/CloudStorage/OneDrive-MonsterConnectCo.,Ltd/Lecture/KOSEN69 - software-security/slides/pptx/assets/logo-small.png">    </p:cNvPr>
+          <p:cNvPr id="8" name="Image 1" descr="/Users/pop7/Library/CloudStorage/OneDrive-MonsterConnectCo.,Ltd/Lecture/KOSEN69 - software-security/slides/pptx/assets/logo-small.png">    </p:cNvPr>
           <p:cNvPicPr>
             <a:picLocks noChangeAspect="1"/>
           </p:cNvPicPr>
@@ -2813,7 +2755,7 @@
         </p:blipFill>
         <p:spPr>
           <a:xfrm>
-            <a:off x="7872984" y="4681728"/>
+            <a:off x="7882128" y="4700016"/>
             <a:ext cx="768096" cy="356616"/>
           </a:xfrm>
           <a:prstGeom prst="rect">
@@ -2835,7 +2777,7 @@
     <p:bg>
       <p:bgPr>
         <a:solidFill>
-          <a:srgbClr val="0E1726"/>
+          <a:srgbClr val="FFFFFF"/>
         </a:solidFill>
       </p:bgPr>
     </p:bg>
@@ -2872,9 +2814,9 @@
           </a:solidFill>
           <a:ln/>
           <a:effectLst>
-            <a:outerShdw sx="100000" sy="100000" kx="0" ky="0" algn="bl" rotWithShape="0" blurRad="101600" dist="38100" dir="5400000">
+            <a:outerShdw sx="100000" sy="100000" kx="0" ky="0" algn="bl" rotWithShape="0" blurRad="76200" dist="25400" dir="5400000">
               <a:srgbClr val="000000">
-                <a:alpha val="35000"/>
+                <a:alpha val="12000"/>
               </a:srgbClr>
             </a:outerShdw>
           </a:effectLst>
@@ -2931,7 +2873,7 @@
             <a:r>
               <a:rPr lang="en-US" sz="2600" b="1" dirty="0">
                 <a:solidFill>
-                  <a:srgbClr val="E6EDF3"/>
+                  <a:srgbClr val="1F2937"/>
                 </a:solidFill>
                 <a:latin typeface="Arial" pitchFamily="34" charset="0"/>
                 <a:ea typeface="Arial" pitchFamily="34" charset="-122"/>
@@ -2960,13 +2902,13 @@
             </a:avLst>
           </a:prstGeom>
           <a:solidFill>
-            <a:srgbClr val="18243A"/>
+            <a:srgbClr val="F1F5F9"/>
           </a:solidFill>
           <a:ln/>
           <a:effectLst>
-            <a:outerShdw sx="100000" sy="100000" kx="0" ky="0" algn="bl" rotWithShape="0" blurRad="101600" dist="38100" dir="5400000">
+            <a:outerShdw sx="100000" sy="100000" kx="0" ky="0" algn="bl" rotWithShape="0" blurRad="76200" dist="25400" dir="5400000">
               <a:srgbClr val="000000">
-                <a:alpha val="35000"/>
+                <a:alpha val="12000"/>
               </a:srgbClr>
             </a:outerShdw>
           </a:effectLst>
@@ -3003,7 +2945,7 @@
             <a:r>
               <a:rPr lang="en-US" sz="1400" dirty="0">
                 <a:solidFill>
-                  <a:srgbClr val="E6EDF3"/>
+                  <a:srgbClr val="1F2937"/>
                 </a:solidFill>
                 <a:latin typeface="Calibri" pitchFamily="34" charset="0"/>
                 <a:ea typeface="Calibri" pitchFamily="34" charset="-122"/>
@@ -3024,7 +2966,7 @@
             <a:r>
               <a:rPr lang="en-US" sz="1400" dirty="0">
                 <a:solidFill>
-                  <a:srgbClr val="E6EDF3"/>
+                  <a:srgbClr val="1F2937"/>
                 </a:solidFill>
                 <a:latin typeface="Calibri" pitchFamily="34" charset="0"/>
                 <a:ea typeface="Calibri" pitchFamily="34" charset="-122"/>
@@ -3045,7 +2987,7 @@
             <a:r>
               <a:rPr lang="en-US" sz="1400" dirty="0">
                 <a:solidFill>
-                  <a:srgbClr val="E6EDF3"/>
+                  <a:srgbClr val="1F2937"/>
                 </a:solidFill>
                 <a:latin typeface="Calibri" pitchFamily="34" charset="0"/>
                 <a:ea typeface="Calibri" pitchFamily="34" charset="-122"/>
@@ -3066,7 +3008,7 @@
             <a:r>
               <a:rPr lang="en-US" sz="1400" dirty="0">
                 <a:solidFill>
-                  <a:srgbClr val="E6EDF3"/>
+                  <a:srgbClr val="1F2937"/>
                 </a:solidFill>
                 <a:latin typeface="Calibri" pitchFamily="34" charset="0"/>
                 <a:ea typeface="Calibri" pitchFamily="34" charset="-122"/>
@@ -3105,7 +3047,7 @@
             <a:r>
               <a:rPr lang="en-US" sz="900" dirty="0">
                 <a:solidFill>
-                  <a:srgbClr val="94A3B8"/>
+                  <a:srgbClr val="64748B"/>
                 </a:solidFill>
                 <a:latin typeface="Calibri" pitchFamily="34" charset="0"/>
                 <a:ea typeface="Calibri" pitchFamily="34" charset="-122"/>
@@ -3117,38 +3059,9 @@
           </a:p>
         </p:txBody>
       </p:sp>
-      <p:sp>
-        <p:nvSpPr>
-          <p:cNvPr id="8" name="Shape 5"/>
-          <p:cNvSpPr/>
-          <p:nvPr/>
-        </p:nvSpPr>
-        <p:spPr>
-          <a:xfrm>
-            <a:off x="7772400" y="4590288"/>
-            <a:ext cx="969264" cy="475488"/>
-          </a:xfrm>
-          <a:prstGeom prst="roundRect">
-            <a:avLst>
-              <a:gd name="adj" fmla="val 11538"/>
-            </a:avLst>
-          </a:prstGeom>
-          <a:solidFill>
-            <a:srgbClr val="FFFFFF"/>
-          </a:solidFill>
-          <a:ln/>
-          <a:effectLst>
-            <a:outerShdw sx="100000" sy="100000" kx="0" ky="0" algn="bl" rotWithShape="0" blurRad="101600" dist="38100" dir="5400000">
-              <a:srgbClr val="000000">
-                <a:alpha val="35000"/>
-              </a:srgbClr>
-            </a:outerShdw>
-          </a:effectLst>
-        </p:spPr>
-      </p:sp>
       <p:pic>
         <p:nvPicPr>
-          <p:cNvPr id="9" name="Image 1" descr="/Users/pop7/Library/CloudStorage/OneDrive-MonsterConnectCo.,Ltd/Lecture/KOSEN69 - software-security/slides/pptx/assets/logo-small.png">    </p:cNvPr>
+          <p:cNvPr id="8" name="Image 1" descr="/Users/pop7/Library/CloudStorage/OneDrive-MonsterConnectCo.,Ltd/Lecture/KOSEN69 - software-security/slides/pptx/assets/logo-small.png">    </p:cNvPr>
           <p:cNvPicPr>
             <a:picLocks noChangeAspect="1"/>
           </p:cNvPicPr>
@@ -3162,7 +3075,7 @@
         </p:blipFill>
         <p:spPr>
           <a:xfrm>
-            <a:off x="7872984" y="4681728"/>
+            <a:off x="7882128" y="4700016"/>
             <a:ext cx="768096" cy="356616"/>
           </a:xfrm>
           <a:prstGeom prst="rect">
@@ -3184,7 +3097,7 @@
     <p:bg>
       <p:bgPr>
         <a:solidFill>
-          <a:srgbClr val="0E1726"/>
+          <a:srgbClr val="FFFFFF"/>
         </a:solidFill>
       </p:bgPr>
     </p:bg>
@@ -3221,9 +3134,9 @@
           </a:solidFill>
           <a:ln/>
           <a:effectLst>
-            <a:outerShdw sx="100000" sy="100000" kx="0" ky="0" algn="bl" rotWithShape="0" blurRad="101600" dist="38100" dir="5400000">
+            <a:outerShdw sx="100000" sy="100000" kx="0" ky="0" algn="bl" rotWithShape="0" blurRad="76200" dist="25400" dir="5400000">
               <a:srgbClr val="000000">
-                <a:alpha val="35000"/>
+                <a:alpha val="12000"/>
               </a:srgbClr>
             </a:outerShdw>
           </a:effectLst>
@@ -3280,7 +3193,7 @@
             <a:r>
               <a:rPr lang="en-US" sz="2600" b="1" dirty="0">
                 <a:solidFill>
-                  <a:srgbClr val="E6EDF3"/>
+                  <a:srgbClr val="1F2937"/>
                 </a:solidFill>
                 <a:latin typeface="Arial" pitchFamily="34" charset="0"/>
                 <a:ea typeface="Arial" pitchFamily="34" charset="-122"/>
@@ -3309,13 +3222,13 @@
             </a:avLst>
           </a:prstGeom>
           <a:solidFill>
-            <a:srgbClr val="18243A"/>
+            <a:srgbClr val="F1F5F9"/>
           </a:solidFill>
           <a:ln/>
           <a:effectLst>
-            <a:outerShdw sx="100000" sy="100000" kx="0" ky="0" algn="bl" rotWithShape="0" blurRad="101600" dist="38100" dir="5400000">
+            <a:outerShdw sx="100000" sy="100000" kx="0" ky="0" algn="bl" rotWithShape="0" blurRad="76200" dist="25400" dir="5400000">
               <a:srgbClr val="000000">
-                <a:alpha val="35000"/>
+                <a:alpha val="12000"/>
               </a:srgbClr>
             </a:outerShdw>
           </a:effectLst>
@@ -3352,7 +3265,7 @@
             <a:r>
               <a:rPr lang="en-US" sz="1400" dirty="0">
                 <a:solidFill>
-                  <a:srgbClr val="E6EDF3"/>
+                  <a:srgbClr val="1F2937"/>
                 </a:solidFill>
                 <a:latin typeface="Calibri" pitchFamily="34" charset="0"/>
                 <a:ea typeface="Calibri" pitchFamily="34" charset="-122"/>
@@ -3373,7 +3286,7 @@
             <a:r>
               <a:rPr lang="en-US" sz="1400" dirty="0">
                 <a:solidFill>
-                  <a:srgbClr val="E6EDF3"/>
+                  <a:srgbClr val="1F2937"/>
                 </a:solidFill>
                 <a:latin typeface="Calibri" pitchFamily="34" charset="0"/>
                 <a:ea typeface="Calibri" pitchFamily="34" charset="-122"/>
@@ -3394,7 +3307,7 @@
             <a:r>
               <a:rPr lang="en-US" sz="1400" dirty="0">
                 <a:solidFill>
-                  <a:srgbClr val="E6EDF3"/>
+                  <a:srgbClr val="1F2937"/>
                 </a:solidFill>
                 <a:latin typeface="Calibri" pitchFamily="34" charset="0"/>
                 <a:ea typeface="Calibri" pitchFamily="34" charset="-122"/>
@@ -3415,7 +3328,7 @@
             <a:r>
               <a:rPr lang="en-US" sz="1400" dirty="0">
                 <a:solidFill>
-                  <a:srgbClr val="E6EDF3"/>
+                  <a:srgbClr val="1F2937"/>
                 </a:solidFill>
                 <a:latin typeface="Calibri" pitchFamily="34" charset="0"/>
                 <a:ea typeface="Calibri" pitchFamily="34" charset="-122"/>
@@ -3454,7 +3367,7 @@
             <a:r>
               <a:rPr lang="en-US" sz="900" dirty="0">
                 <a:solidFill>
-                  <a:srgbClr val="94A3B8"/>
+                  <a:srgbClr val="64748B"/>
                 </a:solidFill>
                 <a:latin typeface="Calibri" pitchFamily="34" charset="0"/>
                 <a:ea typeface="Calibri" pitchFamily="34" charset="-122"/>
@@ -3466,38 +3379,9 @@
           </a:p>
         </p:txBody>
       </p:sp>
-      <p:sp>
-        <p:nvSpPr>
-          <p:cNvPr id="8" name="Shape 5"/>
-          <p:cNvSpPr/>
-          <p:nvPr/>
-        </p:nvSpPr>
-        <p:spPr>
-          <a:xfrm>
-            <a:off x="7772400" y="4590288"/>
-            <a:ext cx="969264" cy="475488"/>
-          </a:xfrm>
-          <a:prstGeom prst="roundRect">
-            <a:avLst>
-              <a:gd name="adj" fmla="val 11538"/>
-            </a:avLst>
-          </a:prstGeom>
-          <a:solidFill>
-            <a:srgbClr val="FFFFFF"/>
-          </a:solidFill>
-          <a:ln/>
-          <a:effectLst>
-            <a:outerShdw sx="100000" sy="100000" kx="0" ky="0" algn="bl" rotWithShape="0" blurRad="101600" dist="38100" dir="5400000">
-              <a:srgbClr val="000000">
-                <a:alpha val="35000"/>
-              </a:srgbClr>
-            </a:outerShdw>
-          </a:effectLst>
-        </p:spPr>
-      </p:sp>
       <p:pic>
         <p:nvPicPr>
-          <p:cNvPr id="9" name="Image 1" descr="/Users/pop7/Library/CloudStorage/OneDrive-MonsterConnectCo.,Ltd/Lecture/KOSEN69 - software-security/slides/pptx/assets/logo-small.png">    </p:cNvPr>
+          <p:cNvPr id="8" name="Image 1" descr="/Users/pop7/Library/CloudStorage/OneDrive-MonsterConnectCo.,Ltd/Lecture/KOSEN69 - software-security/slides/pptx/assets/logo-small.png">    </p:cNvPr>
           <p:cNvPicPr>
             <a:picLocks noChangeAspect="1"/>
           </p:cNvPicPr>
@@ -3511,7 +3395,7 @@
         </p:blipFill>
         <p:spPr>
           <a:xfrm>
-            <a:off x="7872984" y="4681728"/>
+            <a:off x="7882128" y="4700016"/>
             <a:ext cx="768096" cy="356616"/>
           </a:xfrm>
           <a:prstGeom prst="rect">
@@ -3533,7 +3417,7 @@
     <p:bg>
       <p:bgPr>
         <a:solidFill>
-          <a:srgbClr val="0E1726"/>
+          <a:srgbClr val="FFFFFF"/>
         </a:solidFill>
       </p:bgPr>
     </p:bg>
@@ -3570,9 +3454,9 @@
           </a:solidFill>
           <a:ln/>
           <a:effectLst>
-            <a:outerShdw sx="100000" sy="100000" kx="0" ky="0" algn="bl" rotWithShape="0" blurRad="101600" dist="38100" dir="5400000">
+            <a:outerShdw sx="100000" sy="100000" kx="0" ky="0" algn="bl" rotWithShape="0" blurRad="76200" dist="25400" dir="5400000">
               <a:srgbClr val="000000">
-                <a:alpha val="35000"/>
+                <a:alpha val="12000"/>
               </a:srgbClr>
             </a:outerShdw>
           </a:effectLst>
@@ -3629,7 +3513,7 @@
             <a:r>
               <a:rPr lang="en-US" sz="2600" b="1" dirty="0">
                 <a:solidFill>
-                  <a:srgbClr val="E6EDF3"/>
+                  <a:srgbClr val="1F2937"/>
                 </a:solidFill>
                 <a:latin typeface="Arial" pitchFamily="34" charset="0"/>
                 <a:ea typeface="Arial" pitchFamily="34" charset="-122"/>
@@ -3727,7 +3611,7 @@
             <a:r>
               <a:rPr lang="en-US" sz="1350" dirty="0">
                 <a:solidFill>
-                  <a:srgbClr val="E6EDF3"/>
+                  <a:srgbClr val="1F2937"/>
                 </a:solidFill>
                 <a:latin typeface="Calibri" pitchFamily="34" charset="0"/>
                 <a:ea typeface="Calibri" pitchFamily="34" charset="-122"/>
@@ -3825,7 +3709,7 @@
             <a:r>
               <a:rPr lang="en-US" sz="1350" dirty="0">
                 <a:solidFill>
-                  <a:srgbClr val="E6EDF3"/>
+                  <a:srgbClr val="1F2937"/>
                 </a:solidFill>
                 <a:latin typeface="Calibri" pitchFamily="34" charset="0"/>
                 <a:ea typeface="Calibri" pitchFamily="34" charset="-122"/>
@@ -3923,7 +3807,7 @@
             <a:r>
               <a:rPr lang="en-US" sz="1350" dirty="0">
                 <a:solidFill>
-                  <a:srgbClr val="E6EDF3"/>
+                  <a:srgbClr val="1F2937"/>
                 </a:solidFill>
                 <a:latin typeface="Calibri" pitchFamily="34" charset="0"/>
                 <a:ea typeface="Calibri" pitchFamily="34" charset="-122"/>
@@ -4021,7 +3905,7 @@
             <a:r>
               <a:rPr lang="en-US" sz="1350" dirty="0">
                 <a:solidFill>
-                  <a:srgbClr val="E6EDF3"/>
+                  <a:srgbClr val="1F2937"/>
                 </a:solidFill>
                 <a:latin typeface="Calibri" pitchFamily="34" charset="0"/>
                 <a:ea typeface="Calibri" pitchFamily="34" charset="-122"/>
@@ -4060,7 +3944,7 @@
             <a:r>
               <a:rPr lang="en-US" sz="900" dirty="0">
                 <a:solidFill>
-                  <a:srgbClr val="94A3B8"/>
+                  <a:srgbClr val="64748B"/>
                 </a:solidFill>
                 <a:latin typeface="Calibri" pitchFamily="34" charset="0"/>
                 <a:ea typeface="Calibri" pitchFamily="34" charset="-122"/>
@@ -4072,38 +3956,9 @@
           </a:p>
         </p:txBody>
       </p:sp>
-      <p:sp>
-        <p:nvSpPr>
-          <p:cNvPr id="18" name="Shape 15"/>
-          <p:cNvSpPr/>
-          <p:nvPr/>
-        </p:nvSpPr>
-        <p:spPr>
-          <a:xfrm>
-            <a:off x="7772400" y="4590288"/>
-            <a:ext cx="969264" cy="475488"/>
-          </a:xfrm>
-          <a:prstGeom prst="roundRect">
-            <a:avLst>
-              <a:gd name="adj" fmla="val 11538"/>
-            </a:avLst>
-          </a:prstGeom>
-          <a:solidFill>
-            <a:srgbClr val="FFFFFF"/>
-          </a:solidFill>
-          <a:ln/>
-          <a:effectLst>
-            <a:outerShdw sx="100000" sy="100000" kx="0" ky="0" algn="bl" rotWithShape="0" blurRad="101600" dist="38100" dir="5400000">
-              <a:srgbClr val="000000">
-                <a:alpha val="35000"/>
-              </a:srgbClr>
-            </a:outerShdw>
-          </a:effectLst>
-        </p:spPr>
-      </p:sp>
       <p:pic>
         <p:nvPicPr>
-          <p:cNvPr id="19" name="Image 1" descr="/Users/pop7/Library/CloudStorage/OneDrive-MonsterConnectCo.,Ltd/Lecture/KOSEN69 - software-security/slides/pptx/assets/logo-small.png">    </p:cNvPr>
+          <p:cNvPr id="18" name="Image 1" descr="/Users/pop7/Library/CloudStorage/OneDrive-MonsterConnectCo.,Ltd/Lecture/KOSEN69 - software-security/slides/pptx/assets/logo-small.png">    </p:cNvPr>
           <p:cNvPicPr>
             <a:picLocks noChangeAspect="1"/>
           </p:cNvPicPr>
@@ -4117,7 +3972,7 @@
         </p:blipFill>
         <p:spPr>
           <a:xfrm>
-            <a:off x="7872984" y="4681728"/>
+            <a:off x="7882128" y="4700016"/>
             <a:ext cx="768096" cy="356616"/>
           </a:xfrm>
           <a:prstGeom prst="rect">
@@ -4139,7 +3994,7 @@
     <p:bg>
       <p:bgPr>
         <a:solidFill>
-          <a:srgbClr val="0E1726"/>
+          <a:srgbClr val="FFFFFF"/>
         </a:solidFill>
       </p:bgPr>
     </p:bg>
@@ -4176,9 +4031,9 @@
           </a:solidFill>
           <a:ln/>
           <a:effectLst>
-            <a:outerShdw sx="100000" sy="100000" kx="0" ky="0" algn="bl" rotWithShape="0" blurRad="101600" dist="38100" dir="5400000">
+            <a:outerShdw sx="100000" sy="100000" kx="0" ky="0" algn="bl" rotWithShape="0" blurRad="76200" dist="25400" dir="5400000">
               <a:srgbClr val="000000">
-                <a:alpha val="35000"/>
+                <a:alpha val="12000"/>
               </a:srgbClr>
             </a:outerShdw>
           </a:effectLst>
@@ -4235,7 +4090,7 @@
             <a:r>
               <a:rPr lang="en-US" sz="2600" b="1" dirty="0">
                 <a:solidFill>
-                  <a:srgbClr val="E6EDF3"/>
+                  <a:srgbClr val="1F2937"/>
                 </a:solidFill>
                 <a:latin typeface="Arial" pitchFamily="34" charset="0"/>
                 <a:ea typeface="Arial" pitchFamily="34" charset="-122"/>
@@ -4333,7 +4188,7 @@
             <a:r>
               <a:rPr lang="en-US" sz="1350" dirty="0">
                 <a:solidFill>
-                  <a:srgbClr val="E6EDF3"/>
+                  <a:srgbClr val="1F2937"/>
                 </a:solidFill>
                 <a:latin typeface="Calibri" pitchFamily="34" charset="0"/>
                 <a:ea typeface="Calibri" pitchFamily="34" charset="-122"/>
@@ -4431,7 +4286,7 @@
             <a:r>
               <a:rPr lang="en-US" sz="1350" dirty="0">
                 <a:solidFill>
-                  <a:srgbClr val="E6EDF3"/>
+                  <a:srgbClr val="1F2937"/>
                 </a:solidFill>
                 <a:latin typeface="Calibri" pitchFamily="34" charset="0"/>
                 <a:ea typeface="Calibri" pitchFamily="34" charset="-122"/>
@@ -4529,7 +4384,7 @@
             <a:r>
               <a:rPr lang="en-US" sz="1350" dirty="0">
                 <a:solidFill>
-                  <a:srgbClr val="E6EDF3"/>
+                  <a:srgbClr val="1F2937"/>
                 </a:solidFill>
                 <a:latin typeface="Calibri" pitchFamily="34" charset="0"/>
                 <a:ea typeface="Calibri" pitchFamily="34" charset="-122"/>
@@ -4627,7 +4482,7 @@
             <a:r>
               <a:rPr lang="en-US" sz="1350" dirty="0">
                 <a:solidFill>
-                  <a:srgbClr val="E6EDF3"/>
+                  <a:srgbClr val="1F2937"/>
                 </a:solidFill>
                 <a:latin typeface="Calibri" pitchFamily="34" charset="0"/>
                 <a:ea typeface="Calibri" pitchFamily="34" charset="-122"/>
@@ -4666,7 +4521,7 @@
             <a:r>
               <a:rPr lang="en-US" sz="1400" dirty="0">
                 <a:solidFill>
-                  <a:srgbClr val="E6EDF3"/>
+                  <a:srgbClr val="1F2937"/>
                 </a:solidFill>
                 <a:latin typeface="Calibri" pitchFamily="34" charset="0"/>
                 <a:ea typeface="Calibri" pitchFamily="34" charset="-122"/>
@@ -4705,7 +4560,7 @@
             <a:r>
               <a:rPr lang="en-US" sz="900" dirty="0">
                 <a:solidFill>
-                  <a:srgbClr val="94A3B8"/>
+                  <a:srgbClr val="64748B"/>
                 </a:solidFill>
                 <a:latin typeface="Calibri" pitchFamily="34" charset="0"/>
                 <a:ea typeface="Calibri" pitchFamily="34" charset="-122"/>
@@ -4717,38 +4572,9 @@
           </a:p>
         </p:txBody>
       </p:sp>
-      <p:sp>
-        <p:nvSpPr>
-          <p:cNvPr id="19" name="Shape 16"/>
-          <p:cNvSpPr/>
-          <p:nvPr/>
-        </p:nvSpPr>
-        <p:spPr>
-          <a:xfrm>
-            <a:off x="7772400" y="4590288"/>
-            <a:ext cx="969264" cy="475488"/>
-          </a:xfrm>
-          <a:prstGeom prst="roundRect">
-            <a:avLst>
-              <a:gd name="adj" fmla="val 11538"/>
-            </a:avLst>
-          </a:prstGeom>
-          <a:solidFill>
-            <a:srgbClr val="FFFFFF"/>
-          </a:solidFill>
-          <a:ln/>
-          <a:effectLst>
-            <a:outerShdw sx="100000" sy="100000" kx="0" ky="0" algn="bl" rotWithShape="0" blurRad="101600" dist="38100" dir="5400000">
-              <a:srgbClr val="000000">
-                <a:alpha val="35000"/>
-              </a:srgbClr>
-            </a:outerShdw>
-          </a:effectLst>
-        </p:spPr>
-      </p:sp>
       <p:pic>
         <p:nvPicPr>
-          <p:cNvPr id="20" name="Image 1" descr="/Users/pop7/Library/CloudStorage/OneDrive-MonsterConnectCo.,Ltd/Lecture/KOSEN69 - software-security/slides/pptx/assets/logo-small.png">    </p:cNvPr>
+          <p:cNvPr id="19" name="Image 1" descr="/Users/pop7/Library/CloudStorage/OneDrive-MonsterConnectCo.,Ltd/Lecture/KOSEN69 - software-security/slides/pptx/assets/logo-small.png">    </p:cNvPr>
           <p:cNvPicPr>
             <a:picLocks noChangeAspect="1"/>
           </p:cNvPicPr>
@@ -4762,7 +4588,7 @@
         </p:blipFill>
         <p:spPr>
           <a:xfrm>
-            <a:off x="7872984" y="4681728"/>
+            <a:off x="7882128" y="4700016"/>
             <a:ext cx="768096" cy="356616"/>
           </a:xfrm>
           <a:prstGeom prst="rect">
@@ -4784,7 +4610,7 @@
     <p:bg>
       <p:bgPr>
         <a:solidFill>
-          <a:srgbClr val="0E1726"/>
+          <a:srgbClr val="FFFFFF"/>
         </a:solidFill>
       </p:bgPr>
     </p:bg>
@@ -4821,9 +4647,9 @@
           </a:solidFill>
           <a:ln/>
           <a:effectLst>
-            <a:outerShdw sx="100000" sy="100000" kx="0" ky="0" algn="bl" rotWithShape="0" blurRad="101600" dist="38100" dir="5400000">
+            <a:outerShdw sx="100000" sy="100000" kx="0" ky="0" algn="bl" rotWithShape="0" blurRad="76200" dist="25400" dir="5400000">
               <a:srgbClr val="000000">
-                <a:alpha val="35000"/>
+                <a:alpha val="12000"/>
               </a:srgbClr>
             </a:outerShdw>
           </a:effectLst>
@@ -4880,7 +4706,7 @@
             <a:r>
               <a:rPr lang="en-US" sz="2600" b="1" dirty="0">
                 <a:solidFill>
-                  <a:srgbClr val="E6EDF3"/>
+                  <a:srgbClr val="1F2937"/>
                 </a:solidFill>
                 <a:latin typeface="Arial" pitchFamily="34" charset="0"/>
                 <a:ea typeface="Arial" pitchFamily="34" charset="-122"/>
@@ -4909,13 +4735,13 @@
             </a:avLst>
           </a:prstGeom>
           <a:solidFill>
-            <a:srgbClr val="18243A"/>
+            <a:srgbClr val="F1F5F9"/>
           </a:solidFill>
           <a:ln/>
           <a:effectLst>
-            <a:outerShdw sx="100000" sy="100000" kx="0" ky="0" algn="bl" rotWithShape="0" blurRad="101600" dist="38100" dir="5400000">
+            <a:outerShdw sx="100000" sy="100000" kx="0" ky="0" algn="bl" rotWithShape="0" blurRad="76200" dist="25400" dir="5400000">
               <a:srgbClr val="000000">
-                <a:alpha val="35000"/>
+                <a:alpha val="12000"/>
               </a:srgbClr>
             </a:outerShdw>
           </a:effectLst>
@@ -4952,7 +4778,7 @@
             <a:r>
               <a:rPr lang="en-US" sz="1400" dirty="0">
                 <a:solidFill>
-                  <a:srgbClr val="E6EDF3"/>
+                  <a:srgbClr val="1F2937"/>
                 </a:solidFill>
                 <a:latin typeface="Calibri" pitchFamily="34" charset="0"/>
                 <a:ea typeface="Calibri" pitchFamily="34" charset="-122"/>
@@ -4973,7 +4799,7 @@
             <a:r>
               <a:rPr lang="en-US" sz="1400" dirty="0">
                 <a:solidFill>
-                  <a:srgbClr val="E6EDF3"/>
+                  <a:srgbClr val="1F2937"/>
                 </a:solidFill>
                 <a:latin typeface="Calibri" pitchFamily="34" charset="0"/>
                 <a:ea typeface="Calibri" pitchFamily="34" charset="-122"/>
@@ -4994,7 +4820,7 @@
             <a:r>
               <a:rPr lang="en-US" sz="1400" dirty="0">
                 <a:solidFill>
-                  <a:srgbClr val="E6EDF3"/>
+                  <a:srgbClr val="1F2937"/>
                 </a:solidFill>
                 <a:latin typeface="Calibri" pitchFamily="34" charset="0"/>
                 <a:ea typeface="Calibri" pitchFamily="34" charset="-122"/>
@@ -5015,7 +4841,7 @@
             <a:r>
               <a:rPr lang="en-US" sz="1400" dirty="0">
                 <a:solidFill>
-                  <a:srgbClr val="E6EDF3"/>
+                  <a:srgbClr val="1F2937"/>
                 </a:solidFill>
                 <a:latin typeface="Calibri" pitchFamily="34" charset="0"/>
                 <a:ea typeface="Calibri" pitchFamily="34" charset="-122"/>
@@ -5036,7 +4862,7 @@
             <a:r>
               <a:rPr lang="en-US" sz="1400" dirty="0">
                 <a:solidFill>
-                  <a:srgbClr val="E6EDF3"/>
+                  <a:srgbClr val="1F2937"/>
                 </a:solidFill>
                 <a:latin typeface="Calibri" pitchFamily="34" charset="0"/>
                 <a:ea typeface="Calibri" pitchFamily="34" charset="-122"/>
@@ -5057,7 +4883,7 @@
             <a:r>
               <a:rPr lang="en-US" sz="1400" dirty="0">
                 <a:solidFill>
-                  <a:srgbClr val="E6EDF3"/>
+                  <a:srgbClr val="1F2937"/>
                 </a:solidFill>
                 <a:latin typeface="Calibri" pitchFamily="34" charset="0"/>
                 <a:ea typeface="Calibri" pitchFamily="34" charset="-122"/>
@@ -5078,7 +4904,7 @@
             <a:r>
               <a:rPr lang="en-US" sz="1400" dirty="0">
                 <a:solidFill>
-                  <a:srgbClr val="E6EDF3"/>
+                  <a:srgbClr val="1F2937"/>
                 </a:solidFill>
                 <a:latin typeface="Calibri" pitchFamily="34" charset="0"/>
                 <a:ea typeface="Calibri" pitchFamily="34" charset="-122"/>
@@ -5117,7 +4943,7 @@
             <a:r>
               <a:rPr lang="en-US" sz="900" dirty="0">
                 <a:solidFill>
-                  <a:srgbClr val="94A3B8"/>
+                  <a:srgbClr val="64748B"/>
                 </a:solidFill>
                 <a:latin typeface="Calibri" pitchFamily="34" charset="0"/>
                 <a:ea typeface="Calibri" pitchFamily="34" charset="-122"/>
@@ -5129,38 +4955,9 @@
           </a:p>
         </p:txBody>
       </p:sp>
-      <p:sp>
-        <p:nvSpPr>
-          <p:cNvPr id="8" name="Shape 5"/>
-          <p:cNvSpPr/>
-          <p:nvPr/>
-        </p:nvSpPr>
-        <p:spPr>
-          <a:xfrm>
-            <a:off x="7772400" y="4590288"/>
-            <a:ext cx="969264" cy="475488"/>
-          </a:xfrm>
-          <a:prstGeom prst="roundRect">
-            <a:avLst>
-              <a:gd name="adj" fmla="val 11538"/>
-            </a:avLst>
-          </a:prstGeom>
-          <a:solidFill>
-            <a:srgbClr val="FFFFFF"/>
-          </a:solidFill>
-          <a:ln/>
-          <a:effectLst>
-            <a:outerShdw sx="100000" sy="100000" kx="0" ky="0" algn="bl" rotWithShape="0" blurRad="101600" dist="38100" dir="5400000">
-              <a:srgbClr val="000000">
-                <a:alpha val="35000"/>
-              </a:srgbClr>
-            </a:outerShdw>
-          </a:effectLst>
-        </p:spPr>
-      </p:sp>
       <p:pic>
         <p:nvPicPr>
-          <p:cNvPr id="9" name="Image 1" descr="/Users/pop7/Library/CloudStorage/OneDrive-MonsterConnectCo.,Ltd/Lecture/KOSEN69 - software-security/slides/pptx/assets/logo-small.png">    </p:cNvPr>
+          <p:cNvPr id="8" name="Image 1" descr="/Users/pop7/Library/CloudStorage/OneDrive-MonsterConnectCo.,Ltd/Lecture/KOSEN69 - software-security/slides/pptx/assets/logo-small.png">    </p:cNvPr>
           <p:cNvPicPr>
             <a:picLocks noChangeAspect="1"/>
           </p:cNvPicPr>
@@ -5174,7 +4971,7 @@
         </p:blipFill>
         <p:spPr>
           <a:xfrm>
-            <a:off x="7872984" y="4681728"/>
+            <a:off x="7882128" y="4700016"/>
             <a:ext cx="768096" cy="356616"/>
           </a:xfrm>
           <a:prstGeom prst="rect">
@@ -5196,7 +4993,7 @@
     <p:bg>
       <p:bgPr>
         <a:solidFill>
-          <a:srgbClr val="0E1726"/>
+          <a:srgbClr val="FFFFFF"/>
         </a:solidFill>
       </p:bgPr>
     </p:bg>
@@ -5233,9 +5030,9 @@
           </a:solidFill>
           <a:ln/>
           <a:effectLst>
-            <a:outerShdw sx="100000" sy="100000" kx="0" ky="0" algn="bl" rotWithShape="0" blurRad="101600" dist="38100" dir="5400000">
+            <a:outerShdw sx="100000" sy="100000" kx="0" ky="0" algn="bl" rotWithShape="0" blurRad="76200" dist="25400" dir="5400000">
               <a:srgbClr val="000000">
-                <a:alpha val="35000"/>
+                <a:alpha val="12000"/>
               </a:srgbClr>
             </a:outerShdw>
           </a:effectLst>
@@ -5292,7 +5089,7 @@
             <a:r>
               <a:rPr lang="en-US" sz="2600" b="1" dirty="0">
                 <a:solidFill>
-                  <a:srgbClr val="E6EDF3"/>
+                  <a:srgbClr val="1F2937"/>
                 </a:solidFill>
                 <a:latin typeface="Arial" pitchFamily="34" charset="0"/>
                 <a:ea typeface="Arial" pitchFamily="34" charset="-122"/>
@@ -5321,13 +5118,13 @@
             </a:avLst>
           </a:prstGeom>
           <a:solidFill>
-            <a:srgbClr val="18243A"/>
+            <a:srgbClr val="F1F5F9"/>
           </a:solidFill>
           <a:ln/>
           <a:effectLst>
-            <a:outerShdw sx="100000" sy="100000" kx="0" ky="0" algn="bl" rotWithShape="0" blurRad="101600" dist="38100" dir="5400000">
+            <a:outerShdw sx="100000" sy="100000" kx="0" ky="0" algn="bl" rotWithShape="0" blurRad="76200" dist="25400" dir="5400000">
               <a:srgbClr val="000000">
-                <a:alpha val="35000"/>
+                <a:alpha val="12000"/>
               </a:srgbClr>
             </a:outerShdw>
           </a:effectLst>
@@ -5364,7 +5161,7 @@
             <a:r>
               <a:rPr lang="en-US" sz="1400" dirty="0">
                 <a:solidFill>
-                  <a:srgbClr val="E6EDF3"/>
+                  <a:srgbClr val="1F2937"/>
                 </a:solidFill>
                 <a:latin typeface="Calibri" pitchFamily="34" charset="0"/>
                 <a:ea typeface="Calibri" pitchFamily="34" charset="-122"/>
@@ -5385,7 +5182,7 @@
             <a:r>
               <a:rPr lang="en-US" sz="1400" dirty="0">
                 <a:solidFill>
-                  <a:srgbClr val="E6EDF3"/>
+                  <a:srgbClr val="1F2937"/>
                 </a:solidFill>
                 <a:latin typeface="Calibri" pitchFamily="34" charset="0"/>
                 <a:ea typeface="Calibri" pitchFamily="34" charset="-122"/>
@@ -5406,7 +5203,7 @@
             <a:r>
               <a:rPr lang="en-US" sz="1400" dirty="0">
                 <a:solidFill>
-                  <a:srgbClr val="E6EDF3"/>
+                  <a:srgbClr val="1F2937"/>
                 </a:solidFill>
                 <a:latin typeface="Calibri" pitchFamily="34" charset="0"/>
                 <a:ea typeface="Calibri" pitchFamily="34" charset="-122"/>
@@ -5445,7 +5242,7 @@
             <a:r>
               <a:rPr lang="en-US" sz="900" dirty="0">
                 <a:solidFill>
-                  <a:srgbClr val="94A3B8"/>
+                  <a:srgbClr val="64748B"/>
                 </a:solidFill>
                 <a:latin typeface="Calibri" pitchFamily="34" charset="0"/>
                 <a:ea typeface="Calibri" pitchFamily="34" charset="-122"/>
@@ -5457,38 +5254,9 @@
           </a:p>
         </p:txBody>
       </p:sp>
-      <p:sp>
-        <p:nvSpPr>
-          <p:cNvPr id="8" name="Shape 5"/>
-          <p:cNvSpPr/>
-          <p:nvPr/>
-        </p:nvSpPr>
-        <p:spPr>
-          <a:xfrm>
-            <a:off x="7772400" y="4590288"/>
-            <a:ext cx="969264" cy="475488"/>
-          </a:xfrm>
-          <a:prstGeom prst="roundRect">
-            <a:avLst>
-              <a:gd name="adj" fmla="val 11538"/>
-            </a:avLst>
-          </a:prstGeom>
-          <a:solidFill>
-            <a:srgbClr val="FFFFFF"/>
-          </a:solidFill>
-          <a:ln/>
-          <a:effectLst>
-            <a:outerShdw sx="100000" sy="100000" kx="0" ky="0" algn="bl" rotWithShape="0" blurRad="101600" dist="38100" dir="5400000">
-              <a:srgbClr val="000000">
-                <a:alpha val="35000"/>
-              </a:srgbClr>
-            </a:outerShdw>
-          </a:effectLst>
-        </p:spPr>
-      </p:sp>
       <p:pic>
         <p:nvPicPr>
-          <p:cNvPr id="9" name="Image 1" descr="/Users/pop7/Library/CloudStorage/OneDrive-MonsterConnectCo.,Ltd/Lecture/KOSEN69 - software-security/slides/pptx/assets/logo-small.png">    </p:cNvPr>
+          <p:cNvPr id="8" name="Image 1" descr="/Users/pop7/Library/CloudStorage/OneDrive-MonsterConnectCo.,Ltd/Lecture/KOSEN69 - software-security/slides/pptx/assets/logo-small.png">    </p:cNvPr>
           <p:cNvPicPr>
             <a:picLocks noChangeAspect="1"/>
           </p:cNvPicPr>
@@ -5502,7 +5270,7 @@
         </p:blipFill>
         <p:spPr>
           <a:xfrm>
-            <a:off x="7872984" y="4681728"/>
+            <a:off x="7882128" y="4700016"/>
             <a:ext cx="768096" cy="356616"/>
           </a:xfrm>
           <a:prstGeom prst="rect">
@@ -5524,7 +5292,7 @@
     <p:bg>
       <p:bgPr>
         <a:solidFill>
-          <a:srgbClr val="0E1726"/>
+          <a:srgbClr val="FFFFFF"/>
         </a:solidFill>
       </p:bgPr>
     </p:bg>
@@ -5569,7 +5337,7 @@
             <a:r>
               <a:rPr lang="en-US" sz="4600" b="1" dirty="0">
                 <a:solidFill>
-                  <a:srgbClr val="E6EDF3"/>
+                  <a:srgbClr val="1F2937"/>
                 </a:solidFill>
                 <a:latin typeface="Arial" pitchFamily="34" charset="0"/>
                 <a:ea typeface="Arial" pitchFamily="34" charset="-122"/>
@@ -5620,38 +5388,9 @@
           </a:p>
         </p:txBody>
       </p:sp>
-      <p:sp>
-        <p:nvSpPr>
-          <p:cNvPr id="4" name="Shape 2"/>
-          <p:cNvSpPr/>
-          <p:nvPr/>
-        </p:nvSpPr>
-        <p:spPr>
-          <a:xfrm>
-            <a:off x="7772400" y="4590288"/>
-            <a:ext cx="969264" cy="475488"/>
-          </a:xfrm>
-          <a:prstGeom prst="roundRect">
-            <a:avLst>
-              <a:gd name="adj" fmla="val 11538"/>
-            </a:avLst>
-          </a:prstGeom>
-          <a:solidFill>
-            <a:srgbClr val="FFFFFF"/>
-          </a:solidFill>
-          <a:ln/>
-          <a:effectLst>
-            <a:outerShdw sx="100000" sy="100000" kx="0" ky="0" algn="bl" rotWithShape="0" blurRad="101600" dist="38100" dir="5400000">
-              <a:srgbClr val="000000">
-                <a:alpha val="35000"/>
-              </a:srgbClr>
-            </a:outerShdw>
-          </a:effectLst>
-        </p:spPr>
-      </p:sp>
       <p:pic>
         <p:nvPicPr>
-          <p:cNvPr id="5" name="Image 0" descr="/Users/pop7/Library/CloudStorage/OneDrive-MonsterConnectCo.,Ltd/Lecture/KOSEN69 - software-security/slides/pptx/assets/logo-small.png">    </p:cNvPr>
+          <p:cNvPr id="4" name="Image 0" descr="/Users/pop7/Library/CloudStorage/OneDrive-MonsterConnectCo.,Ltd/Lecture/KOSEN69 - software-security/slides/pptx/assets/logo-small.png">    </p:cNvPr>
           <p:cNvPicPr>
             <a:picLocks noChangeAspect="1"/>
           </p:cNvPicPr>
@@ -5665,7 +5404,7 @@
         </p:blipFill>
         <p:spPr>
           <a:xfrm>
-            <a:off x="7872984" y="4681728"/>
+            <a:off x="7882128" y="4700016"/>
             <a:ext cx="768096" cy="356616"/>
           </a:xfrm>
           <a:prstGeom prst="rect">
@@ -5687,7 +5426,7 @@
     <p:bg>
       <p:bgPr>
         <a:solidFill>
-          <a:srgbClr val="0E1726"/>
+          <a:srgbClr val="FFFFFF"/>
         </a:solidFill>
       </p:bgPr>
     </p:bg>
@@ -5724,9 +5463,9 @@
           </a:solidFill>
           <a:ln/>
           <a:effectLst>
-            <a:outerShdw sx="100000" sy="100000" kx="0" ky="0" algn="bl" rotWithShape="0" blurRad="101600" dist="38100" dir="5400000">
+            <a:outerShdw sx="100000" sy="100000" kx="0" ky="0" algn="bl" rotWithShape="0" blurRad="76200" dist="25400" dir="5400000">
               <a:srgbClr val="000000">
-                <a:alpha val="35000"/>
+                <a:alpha val="12000"/>
               </a:srgbClr>
             </a:outerShdw>
           </a:effectLst>
@@ -5783,7 +5522,7 @@
             <a:r>
               <a:rPr lang="en-US" sz="2600" b="1" dirty="0">
                 <a:solidFill>
-                  <a:srgbClr val="E6EDF3"/>
+                  <a:srgbClr val="1F2937"/>
                 </a:solidFill>
                 <a:latin typeface="Arial" pitchFamily="34" charset="0"/>
                 <a:ea typeface="Arial" pitchFamily="34" charset="-122"/>
@@ -5812,13 +5551,13 @@
             </a:avLst>
           </a:prstGeom>
           <a:solidFill>
-            <a:srgbClr val="18243A"/>
+            <a:srgbClr val="F1F5F9"/>
           </a:solidFill>
           <a:ln/>
           <a:effectLst>
-            <a:outerShdw sx="100000" sy="100000" kx="0" ky="0" algn="bl" rotWithShape="0" blurRad="101600" dist="38100" dir="5400000">
+            <a:outerShdw sx="100000" sy="100000" kx="0" ky="0" algn="bl" rotWithShape="0" blurRad="76200" dist="25400" dir="5400000">
               <a:srgbClr val="000000">
-                <a:alpha val="35000"/>
+                <a:alpha val="12000"/>
               </a:srgbClr>
             </a:outerShdw>
           </a:effectLst>
@@ -5855,7 +5594,7 @@
             <a:r>
               <a:rPr lang="en-US" sz="1400" dirty="0">
                 <a:solidFill>
-                  <a:srgbClr val="E6EDF3"/>
+                  <a:srgbClr val="1F2937"/>
                 </a:solidFill>
                 <a:latin typeface="Calibri" pitchFamily="34" charset="0"/>
                 <a:ea typeface="Calibri" pitchFamily="34" charset="-122"/>
@@ -5876,7 +5615,7 @@
             <a:r>
               <a:rPr lang="en-US" sz="1400" dirty="0">
                 <a:solidFill>
-                  <a:srgbClr val="E6EDF3"/>
+                  <a:srgbClr val="1F2937"/>
                 </a:solidFill>
                 <a:latin typeface="Calibri" pitchFamily="34" charset="0"/>
                 <a:ea typeface="Calibri" pitchFamily="34" charset="-122"/>
@@ -5897,7 +5636,7 @@
             <a:r>
               <a:rPr lang="en-US" sz="1400" dirty="0">
                 <a:solidFill>
-                  <a:srgbClr val="E6EDF3"/>
+                  <a:srgbClr val="1F2937"/>
                 </a:solidFill>
                 <a:latin typeface="Calibri" pitchFamily="34" charset="0"/>
                 <a:ea typeface="Calibri" pitchFamily="34" charset="-122"/>
@@ -5918,7 +5657,7 @@
             <a:r>
               <a:rPr lang="en-US" sz="1400" dirty="0">
                 <a:solidFill>
-                  <a:srgbClr val="E6EDF3"/>
+                  <a:srgbClr val="1F2937"/>
                 </a:solidFill>
                 <a:latin typeface="Calibri" pitchFamily="34" charset="0"/>
                 <a:ea typeface="Calibri" pitchFamily="34" charset="-122"/>
@@ -5939,7 +5678,7 @@
             <a:r>
               <a:rPr lang="en-US" sz="1400" dirty="0">
                 <a:solidFill>
-                  <a:srgbClr val="E6EDF3"/>
+                  <a:srgbClr val="1F2937"/>
                 </a:solidFill>
                 <a:latin typeface="Calibri" pitchFamily="34" charset="0"/>
                 <a:ea typeface="Calibri" pitchFamily="34" charset="-122"/>
@@ -5960,7 +5699,7 @@
             <a:r>
               <a:rPr lang="en-US" sz="1400" dirty="0">
                 <a:solidFill>
-                  <a:srgbClr val="E6EDF3"/>
+                  <a:srgbClr val="1F2937"/>
                 </a:solidFill>
                 <a:latin typeface="Calibri" pitchFamily="34" charset="0"/>
                 <a:ea typeface="Calibri" pitchFamily="34" charset="-122"/>
@@ -5999,7 +5738,7 @@
             <a:r>
               <a:rPr lang="en-US" sz="900" dirty="0">
                 <a:solidFill>
-                  <a:srgbClr val="94A3B8"/>
+                  <a:srgbClr val="64748B"/>
                 </a:solidFill>
                 <a:latin typeface="Calibri" pitchFamily="34" charset="0"/>
                 <a:ea typeface="Calibri" pitchFamily="34" charset="-122"/>
@@ -6011,38 +5750,9 @@
           </a:p>
         </p:txBody>
       </p:sp>
-      <p:sp>
-        <p:nvSpPr>
-          <p:cNvPr id="8" name="Shape 5"/>
-          <p:cNvSpPr/>
-          <p:nvPr/>
-        </p:nvSpPr>
-        <p:spPr>
-          <a:xfrm>
-            <a:off x="7772400" y="4590288"/>
-            <a:ext cx="969264" cy="475488"/>
-          </a:xfrm>
-          <a:prstGeom prst="roundRect">
-            <a:avLst>
-              <a:gd name="adj" fmla="val 11538"/>
-            </a:avLst>
-          </a:prstGeom>
-          <a:solidFill>
-            <a:srgbClr val="FFFFFF"/>
-          </a:solidFill>
-          <a:ln/>
-          <a:effectLst>
-            <a:outerShdw sx="100000" sy="100000" kx="0" ky="0" algn="bl" rotWithShape="0" blurRad="101600" dist="38100" dir="5400000">
-              <a:srgbClr val="000000">
-                <a:alpha val="35000"/>
-              </a:srgbClr>
-            </a:outerShdw>
-          </a:effectLst>
-        </p:spPr>
-      </p:sp>
       <p:pic>
         <p:nvPicPr>
-          <p:cNvPr id="9" name="Image 1" descr="/Users/pop7/Library/CloudStorage/OneDrive-MonsterConnectCo.,Ltd/Lecture/KOSEN69 - software-security/slides/pptx/assets/logo-small.png">    </p:cNvPr>
+          <p:cNvPr id="8" name="Image 1" descr="/Users/pop7/Library/CloudStorage/OneDrive-MonsterConnectCo.,Ltd/Lecture/KOSEN69 - software-security/slides/pptx/assets/logo-small.png">    </p:cNvPr>
           <p:cNvPicPr>
             <a:picLocks noChangeAspect="1"/>
           </p:cNvPicPr>
@@ -6056,7 +5766,7 @@
         </p:blipFill>
         <p:spPr>
           <a:xfrm>
-            <a:off x="7872984" y="4681728"/>
+            <a:off x="7882128" y="4700016"/>
             <a:ext cx="768096" cy="356616"/>
           </a:xfrm>
           <a:prstGeom prst="rect">
@@ -6078,7 +5788,7 @@
     <p:bg>
       <p:bgPr>
         <a:solidFill>
-          <a:srgbClr val="0E1726"/>
+          <a:srgbClr val="FFFFFF"/>
         </a:solidFill>
       </p:bgPr>
     </p:bg>
@@ -6115,9 +5825,9 @@
           </a:solidFill>
           <a:ln/>
           <a:effectLst>
-            <a:outerShdw sx="100000" sy="100000" kx="0" ky="0" algn="bl" rotWithShape="0" blurRad="101600" dist="38100" dir="5400000">
+            <a:outerShdw sx="100000" sy="100000" kx="0" ky="0" algn="bl" rotWithShape="0" blurRad="76200" dist="25400" dir="5400000">
               <a:srgbClr val="000000">
-                <a:alpha val="35000"/>
+                <a:alpha val="12000"/>
               </a:srgbClr>
             </a:outerShdw>
           </a:effectLst>
@@ -6174,7 +5884,7 @@
             <a:r>
               <a:rPr lang="en-US" sz="2600" b="1" dirty="0">
                 <a:solidFill>
-                  <a:srgbClr val="E6EDF3"/>
+                  <a:srgbClr val="1F2937"/>
                 </a:solidFill>
                 <a:latin typeface="Arial" pitchFamily="34" charset="0"/>
                 <a:ea typeface="Arial" pitchFamily="34" charset="-122"/>
@@ -6203,13 +5913,13 @@
             </a:avLst>
           </a:prstGeom>
           <a:solidFill>
-            <a:srgbClr val="18243A"/>
+            <a:srgbClr val="F1F5F9"/>
           </a:solidFill>
           <a:ln/>
           <a:effectLst>
-            <a:outerShdw sx="100000" sy="100000" kx="0" ky="0" algn="bl" rotWithShape="0" blurRad="101600" dist="38100" dir="5400000">
+            <a:outerShdw sx="100000" sy="100000" kx="0" ky="0" algn="bl" rotWithShape="0" blurRad="76200" dist="25400" dir="5400000">
               <a:srgbClr val="000000">
-                <a:alpha val="35000"/>
+                <a:alpha val="12000"/>
               </a:srgbClr>
             </a:outerShdw>
           </a:effectLst>
@@ -6246,7 +5956,7 @@
             <a:r>
               <a:rPr lang="en-US" sz="1400" dirty="0">
                 <a:solidFill>
-                  <a:srgbClr val="E6EDF3"/>
+                  <a:srgbClr val="1F2937"/>
                 </a:solidFill>
                 <a:latin typeface="Calibri" pitchFamily="34" charset="0"/>
                 <a:ea typeface="Calibri" pitchFamily="34" charset="-122"/>
@@ -6267,7 +5977,7 @@
             <a:r>
               <a:rPr lang="en-US" sz="1400" dirty="0">
                 <a:solidFill>
-                  <a:srgbClr val="E6EDF3"/>
+                  <a:srgbClr val="1F2937"/>
                 </a:solidFill>
                 <a:latin typeface="Calibri" pitchFamily="34" charset="0"/>
                 <a:ea typeface="Calibri" pitchFamily="34" charset="-122"/>
@@ -6288,7 +5998,7 @@
             <a:r>
               <a:rPr lang="en-US" sz="1400" dirty="0">
                 <a:solidFill>
-                  <a:srgbClr val="E6EDF3"/>
+                  <a:srgbClr val="1F2937"/>
                 </a:solidFill>
                 <a:latin typeface="Calibri" pitchFamily="34" charset="0"/>
                 <a:ea typeface="Calibri" pitchFamily="34" charset="-122"/>
@@ -6309,7 +6019,7 @@
             <a:r>
               <a:rPr lang="en-US" sz="1400" dirty="0">
                 <a:solidFill>
-                  <a:srgbClr val="E6EDF3"/>
+                  <a:srgbClr val="1F2937"/>
                 </a:solidFill>
                 <a:latin typeface="Calibri" pitchFamily="34" charset="0"/>
                 <a:ea typeface="Calibri" pitchFamily="34" charset="-122"/>
@@ -6348,7 +6058,7 @@
             <a:r>
               <a:rPr lang="en-US" sz="900" dirty="0">
                 <a:solidFill>
-                  <a:srgbClr val="94A3B8"/>
+                  <a:srgbClr val="64748B"/>
                 </a:solidFill>
                 <a:latin typeface="Calibri" pitchFamily="34" charset="0"/>
                 <a:ea typeface="Calibri" pitchFamily="34" charset="-122"/>
@@ -6360,38 +6070,9 @@
           </a:p>
         </p:txBody>
       </p:sp>
-      <p:sp>
-        <p:nvSpPr>
-          <p:cNvPr id="8" name="Shape 5"/>
-          <p:cNvSpPr/>
-          <p:nvPr/>
-        </p:nvSpPr>
-        <p:spPr>
-          <a:xfrm>
-            <a:off x="7772400" y="4590288"/>
-            <a:ext cx="969264" cy="475488"/>
-          </a:xfrm>
-          <a:prstGeom prst="roundRect">
-            <a:avLst>
-              <a:gd name="adj" fmla="val 11538"/>
-            </a:avLst>
-          </a:prstGeom>
-          <a:solidFill>
-            <a:srgbClr val="FFFFFF"/>
-          </a:solidFill>
-          <a:ln/>
-          <a:effectLst>
-            <a:outerShdw sx="100000" sy="100000" kx="0" ky="0" algn="bl" rotWithShape="0" blurRad="101600" dist="38100" dir="5400000">
-              <a:srgbClr val="000000">
-                <a:alpha val="35000"/>
-              </a:srgbClr>
-            </a:outerShdw>
-          </a:effectLst>
-        </p:spPr>
-      </p:sp>
       <p:pic>
         <p:nvPicPr>
-          <p:cNvPr id="9" name="Image 1" descr="/Users/pop7/Library/CloudStorage/OneDrive-MonsterConnectCo.,Ltd/Lecture/KOSEN69 - software-security/slides/pptx/assets/logo-small.png">    </p:cNvPr>
+          <p:cNvPr id="8" name="Image 1" descr="/Users/pop7/Library/CloudStorage/OneDrive-MonsterConnectCo.,Ltd/Lecture/KOSEN69 - software-security/slides/pptx/assets/logo-small.png">    </p:cNvPr>
           <p:cNvPicPr>
             <a:picLocks noChangeAspect="1"/>
           </p:cNvPicPr>
@@ -6405,7 +6086,7 @@
         </p:blipFill>
         <p:spPr>
           <a:xfrm>
-            <a:off x="7872984" y="4681728"/>
+            <a:off x="7882128" y="4700016"/>
             <a:ext cx="768096" cy="356616"/>
           </a:xfrm>
           <a:prstGeom prst="rect">
@@ -6427,7 +6108,7 @@
     <p:bg>
       <p:bgPr>
         <a:solidFill>
-          <a:srgbClr val="0E1726"/>
+          <a:srgbClr val="FFFFFF"/>
         </a:solidFill>
       </p:bgPr>
     </p:bg>
@@ -6464,9 +6145,9 @@
           </a:solidFill>
           <a:ln/>
           <a:effectLst>
-            <a:outerShdw sx="100000" sy="100000" kx="0" ky="0" algn="bl" rotWithShape="0" blurRad="101600" dist="38100" dir="5400000">
+            <a:outerShdw sx="100000" sy="100000" kx="0" ky="0" algn="bl" rotWithShape="0" blurRad="76200" dist="25400" dir="5400000">
               <a:srgbClr val="000000">
-                <a:alpha val="35000"/>
+                <a:alpha val="12000"/>
               </a:srgbClr>
             </a:outerShdw>
           </a:effectLst>
@@ -6523,7 +6204,7 @@
             <a:r>
               <a:rPr lang="en-US" sz="2600" b="1" dirty="0">
                 <a:solidFill>
-                  <a:srgbClr val="E6EDF3"/>
+                  <a:srgbClr val="1F2937"/>
                 </a:solidFill>
                 <a:latin typeface="Arial" pitchFamily="34" charset="0"/>
                 <a:ea typeface="Arial" pitchFamily="34" charset="-122"/>
@@ -6552,13 +6233,13 @@
             </a:avLst>
           </a:prstGeom>
           <a:solidFill>
-            <a:srgbClr val="18243A"/>
+            <a:srgbClr val="F1F5F9"/>
           </a:solidFill>
           <a:ln/>
           <a:effectLst>
-            <a:outerShdw sx="100000" sy="100000" kx="0" ky="0" algn="bl" rotWithShape="0" blurRad="101600" dist="38100" dir="5400000">
+            <a:outerShdw sx="100000" sy="100000" kx="0" ky="0" algn="bl" rotWithShape="0" blurRad="76200" dist="25400" dir="5400000">
               <a:srgbClr val="000000">
-                <a:alpha val="35000"/>
+                <a:alpha val="12000"/>
               </a:srgbClr>
             </a:outerShdw>
           </a:effectLst>
@@ -6595,7 +6276,7 @@
             <a:r>
               <a:rPr lang="en-US" sz="1400" dirty="0">
                 <a:solidFill>
-                  <a:srgbClr val="E6EDF3"/>
+                  <a:srgbClr val="1F2937"/>
                 </a:solidFill>
                 <a:latin typeface="Calibri" pitchFamily="34" charset="0"/>
                 <a:ea typeface="Calibri" pitchFamily="34" charset="-122"/>
@@ -6616,7 +6297,7 @@
             <a:r>
               <a:rPr lang="en-US" sz="1400" dirty="0">
                 <a:solidFill>
-                  <a:srgbClr val="E6EDF3"/>
+                  <a:srgbClr val="1F2937"/>
                 </a:solidFill>
                 <a:latin typeface="Calibri" pitchFamily="34" charset="0"/>
                 <a:ea typeface="Calibri" pitchFamily="34" charset="-122"/>
@@ -6637,7 +6318,7 @@
             <a:r>
               <a:rPr lang="en-US" sz="1400" dirty="0">
                 <a:solidFill>
-                  <a:srgbClr val="E6EDF3"/>
+                  <a:srgbClr val="1F2937"/>
                 </a:solidFill>
                 <a:latin typeface="Calibri" pitchFamily="34" charset="0"/>
                 <a:ea typeface="Calibri" pitchFamily="34" charset="-122"/>
@@ -6666,7 +6347,7 @@
             </a:avLst>
           </a:prstGeom>
           <a:solidFill>
-            <a:srgbClr val="1E2B45"/>
+            <a:srgbClr val="E8EDF3"/>
           </a:solidFill>
           <a:ln/>
         </p:spPr>
@@ -6737,7 +6418,7 @@
             <a:r>
               <a:rPr lang="en-US" sz="900" dirty="0">
                 <a:solidFill>
-                  <a:srgbClr val="94A3B8"/>
+                  <a:srgbClr val="64748B"/>
                 </a:solidFill>
                 <a:latin typeface="Calibri" pitchFamily="34" charset="0"/>
                 <a:ea typeface="Calibri" pitchFamily="34" charset="-122"/>
@@ -6749,38 +6430,9 @@
           </a:p>
         </p:txBody>
       </p:sp>
-      <p:sp>
-        <p:nvSpPr>
-          <p:cNvPr id="10" name="Shape 7"/>
-          <p:cNvSpPr/>
-          <p:nvPr/>
-        </p:nvSpPr>
-        <p:spPr>
-          <a:xfrm>
-            <a:off x="7772400" y="4590288"/>
-            <a:ext cx="969264" cy="475488"/>
-          </a:xfrm>
-          <a:prstGeom prst="roundRect">
-            <a:avLst>
-              <a:gd name="adj" fmla="val 11538"/>
-            </a:avLst>
-          </a:prstGeom>
-          <a:solidFill>
-            <a:srgbClr val="FFFFFF"/>
-          </a:solidFill>
-          <a:ln/>
-          <a:effectLst>
-            <a:outerShdw sx="100000" sy="100000" kx="0" ky="0" algn="bl" rotWithShape="0" blurRad="101600" dist="38100" dir="5400000">
-              <a:srgbClr val="000000">
-                <a:alpha val="35000"/>
-              </a:srgbClr>
-            </a:outerShdw>
-          </a:effectLst>
-        </p:spPr>
-      </p:sp>
       <p:pic>
         <p:nvPicPr>
-          <p:cNvPr id="11" name="Image 1" descr="/Users/pop7/Library/CloudStorage/OneDrive-MonsterConnectCo.,Ltd/Lecture/KOSEN69 - software-security/slides/pptx/assets/logo-small.png">    </p:cNvPr>
+          <p:cNvPr id="10" name="Image 1" descr="/Users/pop7/Library/CloudStorage/OneDrive-MonsterConnectCo.,Ltd/Lecture/KOSEN69 - software-security/slides/pptx/assets/logo-small.png">    </p:cNvPr>
           <p:cNvPicPr>
             <a:picLocks noChangeAspect="1"/>
           </p:cNvPicPr>
@@ -6794,7 +6446,7 @@
         </p:blipFill>
         <p:spPr>
           <a:xfrm>
-            <a:off x="7872984" y="4681728"/>
+            <a:off x="7882128" y="4700016"/>
             <a:ext cx="768096" cy="356616"/>
           </a:xfrm>
           <a:prstGeom prst="rect">
@@ -6816,7 +6468,7 @@
     <p:bg>
       <p:bgPr>
         <a:solidFill>
-          <a:srgbClr val="0E1726"/>
+          <a:srgbClr val="FFFFFF"/>
         </a:solidFill>
       </p:bgPr>
     </p:bg>
@@ -6853,9 +6505,9 @@
           </a:solidFill>
           <a:ln/>
           <a:effectLst>
-            <a:outerShdw sx="100000" sy="100000" kx="0" ky="0" algn="bl" rotWithShape="0" blurRad="101600" dist="38100" dir="5400000">
+            <a:outerShdw sx="100000" sy="100000" kx="0" ky="0" algn="bl" rotWithShape="0" blurRad="76200" dist="25400" dir="5400000">
               <a:srgbClr val="000000">
-                <a:alpha val="35000"/>
+                <a:alpha val="12000"/>
               </a:srgbClr>
             </a:outerShdw>
           </a:effectLst>
@@ -6912,7 +6564,7 @@
             <a:r>
               <a:rPr lang="en-US" sz="2600" b="1" dirty="0">
                 <a:solidFill>
-                  <a:srgbClr val="E6EDF3"/>
+                  <a:srgbClr val="1F2937"/>
                 </a:solidFill>
                 <a:latin typeface="Arial" pitchFamily="34" charset="0"/>
                 <a:ea typeface="Arial" pitchFamily="34" charset="-122"/>
@@ -6941,13 +6593,13 @@
             </a:avLst>
           </a:prstGeom>
           <a:solidFill>
-            <a:srgbClr val="18243A"/>
+            <a:srgbClr val="F1F5F9"/>
           </a:solidFill>
           <a:ln/>
           <a:effectLst>
-            <a:outerShdw sx="100000" sy="100000" kx="0" ky="0" algn="bl" rotWithShape="0" blurRad="101600" dist="38100" dir="5400000">
+            <a:outerShdw sx="100000" sy="100000" kx="0" ky="0" algn="bl" rotWithShape="0" blurRad="76200" dist="25400" dir="5400000">
               <a:srgbClr val="000000">
-                <a:alpha val="35000"/>
+                <a:alpha val="12000"/>
               </a:srgbClr>
             </a:outerShdw>
           </a:effectLst>
@@ -6984,7 +6636,7 @@
             <a:r>
               <a:rPr lang="en-US" sz="1400" dirty="0">
                 <a:solidFill>
-                  <a:srgbClr val="E6EDF3"/>
+                  <a:srgbClr val="1F2937"/>
                 </a:solidFill>
                 <a:latin typeface="Calibri" pitchFamily="34" charset="0"/>
                 <a:ea typeface="Calibri" pitchFamily="34" charset="-122"/>
@@ -7005,7 +6657,7 @@
             <a:r>
               <a:rPr lang="en-US" sz="1400" dirty="0">
                 <a:solidFill>
-                  <a:srgbClr val="E6EDF3"/>
+                  <a:srgbClr val="1F2937"/>
                 </a:solidFill>
                 <a:latin typeface="Calibri" pitchFamily="34" charset="0"/>
                 <a:ea typeface="Calibri" pitchFamily="34" charset="-122"/>
@@ -7026,7 +6678,7 @@
             <a:r>
               <a:rPr lang="en-US" sz="1400" dirty="0">
                 <a:solidFill>
-                  <a:srgbClr val="E6EDF3"/>
+                  <a:srgbClr val="1F2937"/>
                 </a:solidFill>
                 <a:latin typeface="Calibri" pitchFamily="34" charset="0"/>
                 <a:ea typeface="Calibri" pitchFamily="34" charset="-122"/>
@@ -7047,7 +6699,7 @@
             <a:r>
               <a:rPr lang="en-US" sz="1400" dirty="0">
                 <a:solidFill>
-                  <a:srgbClr val="E6EDF3"/>
+                  <a:srgbClr val="1F2937"/>
                 </a:solidFill>
                 <a:latin typeface="Calibri" pitchFamily="34" charset="0"/>
                 <a:ea typeface="Calibri" pitchFamily="34" charset="-122"/>
@@ -7086,7 +6738,7 @@
             <a:r>
               <a:rPr lang="en-US" sz="900" dirty="0">
                 <a:solidFill>
-                  <a:srgbClr val="94A3B8"/>
+                  <a:srgbClr val="64748B"/>
                 </a:solidFill>
                 <a:latin typeface="Calibri" pitchFamily="34" charset="0"/>
                 <a:ea typeface="Calibri" pitchFamily="34" charset="-122"/>
@@ -7098,38 +6750,9 @@
           </a:p>
         </p:txBody>
       </p:sp>
-      <p:sp>
-        <p:nvSpPr>
-          <p:cNvPr id="8" name="Shape 5"/>
-          <p:cNvSpPr/>
-          <p:nvPr/>
-        </p:nvSpPr>
-        <p:spPr>
-          <a:xfrm>
-            <a:off x="7772400" y="4590288"/>
-            <a:ext cx="969264" cy="475488"/>
-          </a:xfrm>
-          <a:prstGeom prst="roundRect">
-            <a:avLst>
-              <a:gd name="adj" fmla="val 11538"/>
-            </a:avLst>
-          </a:prstGeom>
-          <a:solidFill>
-            <a:srgbClr val="FFFFFF"/>
-          </a:solidFill>
-          <a:ln/>
-          <a:effectLst>
-            <a:outerShdw sx="100000" sy="100000" kx="0" ky="0" algn="bl" rotWithShape="0" blurRad="101600" dist="38100" dir="5400000">
-              <a:srgbClr val="000000">
-                <a:alpha val="35000"/>
-              </a:srgbClr>
-            </a:outerShdw>
-          </a:effectLst>
-        </p:spPr>
-      </p:sp>
       <p:pic>
         <p:nvPicPr>
-          <p:cNvPr id="9" name="Image 1" descr="/Users/pop7/Library/CloudStorage/OneDrive-MonsterConnectCo.,Ltd/Lecture/KOSEN69 - software-security/slides/pptx/assets/logo-small.png">    </p:cNvPr>
+          <p:cNvPr id="8" name="Image 1" descr="/Users/pop7/Library/CloudStorage/OneDrive-MonsterConnectCo.,Ltd/Lecture/KOSEN69 - software-security/slides/pptx/assets/logo-small.png">    </p:cNvPr>
           <p:cNvPicPr>
             <a:picLocks noChangeAspect="1"/>
           </p:cNvPicPr>
@@ -7143,7 +6766,7 @@
         </p:blipFill>
         <p:spPr>
           <a:xfrm>
-            <a:off x="7872984" y="4681728"/>
+            <a:off x="7882128" y="4700016"/>
             <a:ext cx="768096" cy="356616"/>
           </a:xfrm>
           <a:prstGeom prst="rect">
@@ -7165,7 +6788,7 @@
     <p:bg>
       <p:bgPr>
         <a:solidFill>
-          <a:srgbClr val="0E1726"/>
+          <a:srgbClr val="FFFFFF"/>
         </a:solidFill>
       </p:bgPr>
     </p:bg>
@@ -7202,9 +6825,9 @@
           </a:solidFill>
           <a:ln/>
           <a:effectLst>
-            <a:outerShdw sx="100000" sy="100000" kx="0" ky="0" algn="bl" rotWithShape="0" blurRad="101600" dist="38100" dir="5400000">
+            <a:outerShdw sx="100000" sy="100000" kx="0" ky="0" algn="bl" rotWithShape="0" blurRad="76200" dist="25400" dir="5400000">
               <a:srgbClr val="000000">
-                <a:alpha val="35000"/>
+                <a:alpha val="12000"/>
               </a:srgbClr>
             </a:outerShdw>
           </a:effectLst>
@@ -7261,7 +6884,7 @@
             <a:r>
               <a:rPr lang="en-US" sz="2600" b="1" dirty="0">
                 <a:solidFill>
-                  <a:srgbClr val="E6EDF3"/>
+                  <a:srgbClr val="1F2937"/>
                 </a:solidFill>
                 <a:latin typeface="Arial" pitchFamily="34" charset="0"/>
                 <a:ea typeface="Arial" pitchFamily="34" charset="-122"/>
@@ -7290,13 +6913,13 @@
             </a:avLst>
           </a:prstGeom>
           <a:solidFill>
-            <a:srgbClr val="18243A"/>
+            <a:srgbClr val="F1F5F9"/>
           </a:solidFill>
           <a:ln/>
           <a:effectLst>
-            <a:outerShdw sx="100000" sy="100000" kx="0" ky="0" algn="bl" rotWithShape="0" blurRad="101600" dist="38100" dir="5400000">
+            <a:outerShdw sx="100000" sy="100000" kx="0" ky="0" algn="bl" rotWithShape="0" blurRad="76200" dist="25400" dir="5400000">
               <a:srgbClr val="000000">
-                <a:alpha val="35000"/>
+                <a:alpha val="12000"/>
               </a:srgbClr>
             </a:outerShdw>
           </a:effectLst>
@@ -7333,7 +6956,7 @@
             <a:r>
               <a:rPr lang="en-US" sz="1400" dirty="0">
                 <a:solidFill>
-                  <a:srgbClr val="E6EDF3"/>
+                  <a:srgbClr val="1F2937"/>
                 </a:solidFill>
                 <a:latin typeface="Calibri" pitchFamily="34" charset="0"/>
                 <a:ea typeface="Calibri" pitchFamily="34" charset="-122"/>
@@ -7354,7 +6977,7 @@
             <a:r>
               <a:rPr lang="en-US" sz="1400" dirty="0">
                 <a:solidFill>
-                  <a:srgbClr val="E6EDF3"/>
+                  <a:srgbClr val="1F2937"/>
                 </a:solidFill>
                 <a:latin typeface="Calibri" pitchFamily="34" charset="0"/>
                 <a:ea typeface="Calibri" pitchFamily="34" charset="-122"/>
@@ -7375,7 +6998,7 @@
             <a:r>
               <a:rPr lang="en-US" sz="1400" dirty="0">
                 <a:solidFill>
-                  <a:srgbClr val="E6EDF3"/>
+                  <a:srgbClr val="1F2937"/>
                 </a:solidFill>
                 <a:latin typeface="Calibri" pitchFamily="34" charset="0"/>
                 <a:ea typeface="Calibri" pitchFamily="34" charset="-122"/>
@@ -7414,7 +7037,7 @@
             <a:r>
               <a:rPr lang="en-US" sz="900" dirty="0">
                 <a:solidFill>
-                  <a:srgbClr val="94A3B8"/>
+                  <a:srgbClr val="64748B"/>
                 </a:solidFill>
                 <a:latin typeface="Calibri" pitchFamily="34" charset="0"/>
                 <a:ea typeface="Calibri" pitchFamily="34" charset="-122"/>
@@ -7426,38 +7049,9 @@
           </a:p>
         </p:txBody>
       </p:sp>
-      <p:sp>
-        <p:nvSpPr>
-          <p:cNvPr id="8" name="Shape 5"/>
-          <p:cNvSpPr/>
-          <p:nvPr/>
-        </p:nvSpPr>
-        <p:spPr>
-          <a:xfrm>
-            <a:off x="7772400" y="4590288"/>
-            <a:ext cx="969264" cy="475488"/>
-          </a:xfrm>
-          <a:prstGeom prst="roundRect">
-            <a:avLst>
-              <a:gd name="adj" fmla="val 11538"/>
-            </a:avLst>
-          </a:prstGeom>
-          <a:solidFill>
-            <a:srgbClr val="FFFFFF"/>
-          </a:solidFill>
-          <a:ln/>
-          <a:effectLst>
-            <a:outerShdw sx="100000" sy="100000" kx="0" ky="0" algn="bl" rotWithShape="0" blurRad="101600" dist="38100" dir="5400000">
-              <a:srgbClr val="000000">
-                <a:alpha val="35000"/>
-              </a:srgbClr>
-            </a:outerShdw>
-          </a:effectLst>
-        </p:spPr>
-      </p:sp>
       <p:pic>
         <p:nvPicPr>
-          <p:cNvPr id="9" name="Image 1" descr="/Users/pop7/Library/CloudStorage/OneDrive-MonsterConnectCo.,Ltd/Lecture/KOSEN69 - software-security/slides/pptx/assets/logo-small.png">    </p:cNvPr>
+          <p:cNvPr id="8" name="Image 1" descr="/Users/pop7/Library/CloudStorage/OneDrive-MonsterConnectCo.,Ltd/Lecture/KOSEN69 - software-security/slides/pptx/assets/logo-small.png">    </p:cNvPr>
           <p:cNvPicPr>
             <a:picLocks noChangeAspect="1"/>
           </p:cNvPicPr>
@@ -7471,7 +7065,7 @@
         </p:blipFill>
         <p:spPr>
           <a:xfrm>
-            <a:off x="7872984" y="4681728"/>
+            <a:off x="7882128" y="4700016"/>
             <a:ext cx="768096" cy="356616"/>
           </a:xfrm>
           <a:prstGeom prst="rect">
@@ -7493,7 +7087,7 @@
     <p:bg>
       <p:bgPr>
         <a:solidFill>
-          <a:srgbClr val="0E1726"/>
+          <a:srgbClr val="FFFFFF"/>
         </a:solidFill>
       </p:bgPr>
     </p:bg>
@@ -7530,9 +7124,9 @@
           </a:solidFill>
           <a:ln/>
           <a:effectLst>
-            <a:outerShdw sx="100000" sy="100000" kx="0" ky="0" algn="bl" rotWithShape="0" blurRad="101600" dist="38100" dir="5400000">
+            <a:outerShdw sx="100000" sy="100000" kx="0" ky="0" algn="bl" rotWithShape="0" blurRad="76200" dist="25400" dir="5400000">
               <a:srgbClr val="000000">
-                <a:alpha val="35000"/>
+                <a:alpha val="12000"/>
               </a:srgbClr>
             </a:outerShdw>
           </a:effectLst>
@@ -7589,7 +7183,7 @@
             <a:r>
               <a:rPr lang="en-US" sz="2600" b="1" dirty="0">
                 <a:solidFill>
-                  <a:srgbClr val="E6EDF3"/>
+                  <a:srgbClr val="1F2937"/>
                 </a:solidFill>
                 <a:latin typeface="Arial" pitchFamily="34" charset="0"/>
                 <a:ea typeface="Arial" pitchFamily="34" charset="-122"/>
@@ -7622,7 +7216,7 @@
           </a:solidFill>
           <a:ln w="12700">
             <a:solidFill>
-              <a:srgbClr val="1E2B45"/>
+              <a:srgbClr val="E8EDF3"/>
             </a:solidFill>
             <a:prstDash val="solid"/>
           </a:ln>
@@ -7718,13 +7312,13 @@
             </a:avLst>
           </a:prstGeom>
           <a:solidFill>
-            <a:srgbClr val="18243A"/>
+            <a:srgbClr val="F1F5F9"/>
           </a:solidFill>
           <a:ln/>
           <a:effectLst>
-            <a:outerShdw sx="100000" sy="100000" kx="0" ky="0" algn="bl" rotWithShape="0" blurRad="101600" dist="38100" dir="5400000">
+            <a:outerShdw sx="100000" sy="100000" kx="0" ky="0" algn="bl" rotWithShape="0" blurRad="76200" dist="25400" dir="5400000">
               <a:srgbClr val="000000">
-                <a:alpha val="35000"/>
+                <a:alpha val="12000"/>
               </a:srgbClr>
             </a:outerShdw>
           </a:effectLst>
@@ -7761,7 +7355,7 @@
             <a:r>
               <a:rPr lang="en-US" sz="1400" dirty="0">
                 <a:solidFill>
-                  <a:srgbClr val="E6EDF3"/>
+                  <a:srgbClr val="1F2937"/>
                 </a:solidFill>
                 <a:latin typeface="Calibri" pitchFamily="34" charset="0"/>
                 <a:ea typeface="Calibri" pitchFamily="34" charset="-122"/>
@@ -7782,7 +7376,7 @@
             <a:r>
               <a:rPr lang="en-US" sz="1400" dirty="0">
                 <a:solidFill>
-                  <a:srgbClr val="E6EDF3"/>
+                  <a:srgbClr val="1F2937"/>
                 </a:solidFill>
                 <a:latin typeface="Calibri" pitchFamily="34" charset="0"/>
                 <a:ea typeface="Calibri" pitchFamily="34" charset="-122"/>
@@ -7803,7 +7397,7 @@
             <a:r>
               <a:rPr lang="en-US" sz="1400" dirty="0">
                 <a:solidFill>
-                  <a:srgbClr val="E6EDF3"/>
+                  <a:srgbClr val="1F2937"/>
                 </a:solidFill>
                 <a:latin typeface="Calibri" pitchFamily="34" charset="0"/>
                 <a:ea typeface="Calibri" pitchFamily="34" charset="-122"/>
@@ -7842,7 +7436,7 @@
             <a:r>
               <a:rPr lang="en-US" sz="900" dirty="0">
                 <a:solidFill>
-                  <a:srgbClr val="94A3B8"/>
+                  <a:srgbClr val="64748B"/>
                 </a:solidFill>
                 <a:latin typeface="Calibri" pitchFamily="34" charset="0"/>
                 <a:ea typeface="Calibri" pitchFamily="34" charset="-122"/>
@@ -7854,38 +7448,9 @@
           </a:p>
         </p:txBody>
       </p:sp>
-      <p:sp>
-        <p:nvSpPr>
-          <p:cNvPr id="10" name="Shape 7"/>
-          <p:cNvSpPr/>
-          <p:nvPr/>
-        </p:nvSpPr>
-        <p:spPr>
-          <a:xfrm>
-            <a:off x="7772400" y="4590288"/>
-            <a:ext cx="969264" cy="475488"/>
-          </a:xfrm>
-          <a:prstGeom prst="roundRect">
-            <a:avLst>
-              <a:gd name="adj" fmla="val 11538"/>
-            </a:avLst>
-          </a:prstGeom>
-          <a:solidFill>
-            <a:srgbClr val="FFFFFF"/>
-          </a:solidFill>
-          <a:ln/>
-          <a:effectLst>
-            <a:outerShdw sx="100000" sy="100000" kx="0" ky="0" algn="bl" rotWithShape="0" blurRad="101600" dist="38100" dir="5400000">
-              <a:srgbClr val="000000">
-                <a:alpha val="35000"/>
-              </a:srgbClr>
-            </a:outerShdw>
-          </a:effectLst>
-        </p:spPr>
-      </p:sp>
       <p:pic>
         <p:nvPicPr>
-          <p:cNvPr id="11" name="Image 1" descr="/Users/pop7/Library/CloudStorage/OneDrive-MonsterConnectCo.,Ltd/Lecture/KOSEN69 - software-security/slides/pptx/assets/logo-small.png">    </p:cNvPr>
+          <p:cNvPr id="10" name="Image 1" descr="/Users/pop7/Library/CloudStorage/OneDrive-MonsterConnectCo.,Ltd/Lecture/KOSEN69 - software-security/slides/pptx/assets/logo-small.png">    </p:cNvPr>
           <p:cNvPicPr>
             <a:picLocks noChangeAspect="1"/>
           </p:cNvPicPr>
@@ -7899,7 +7464,7 @@
         </p:blipFill>
         <p:spPr>
           <a:xfrm>
-            <a:off x="7872984" y="4681728"/>
+            <a:off x="7882128" y="4700016"/>
             <a:ext cx="768096" cy="356616"/>
           </a:xfrm>
           <a:prstGeom prst="rect">
@@ -7921,7 +7486,7 @@
     <p:bg>
       <p:bgPr>
         <a:solidFill>
-          <a:srgbClr val="0E1726"/>
+          <a:srgbClr val="FFFFFF"/>
         </a:solidFill>
       </p:bgPr>
     </p:bg>
@@ -7958,9 +7523,9 @@
           </a:solidFill>
           <a:ln/>
           <a:effectLst>
-            <a:outerShdw sx="100000" sy="100000" kx="0" ky="0" algn="bl" rotWithShape="0" blurRad="101600" dist="38100" dir="5400000">
+            <a:outerShdw sx="100000" sy="100000" kx="0" ky="0" algn="bl" rotWithShape="0" blurRad="76200" dist="25400" dir="5400000">
               <a:srgbClr val="000000">
-                <a:alpha val="35000"/>
+                <a:alpha val="12000"/>
               </a:srgbClr>
             </a:outerShdw>
           </a:effectLst>
@@ -8017,7 +7582,7 @@
             <a:r>
               <a:rPr lang="en-US" sz="2600" b="1" dirty="0">
                 <a:solidFill>
-                  <a:srgbClr val="E6EDF3"/>
+                  <a:srgbClr val="1F2937"/>
                 </a:solidFill>
                 <a:latin typeface="Arial" pitchFamily="34" charset="0"/>
                 <a:ea typeface="Arial" pitchFamily="34" charset="-122"/>
@@ -8079,7 +7644,7 @@
                   <a:tcPr marL="76200" marR="76200" marT="38100" marB="38100" anchor="ctr">
                     <a:lnL w="12700" cap="flat" cmpd="sng" algn="ctr">
                       <a:solidFill>
-                        <a:srgbClr val="0E1726"/>
+                        <a:srgbClr val="FFFFFF"/>
                       </a:solidFill>
                       <a:prstDash val="solid"/>
                       <a:round/>
@@ -8088,7 +7653,7 @@
                     </a:lnL>
                     <a:lnR w="12700" cap="flat" cmpd="sng" algn="ctr">
                       <a:solidFill>
-                        <a:srgbClr val="0E1726"/>
+                        <a:srgbClr val="FFFFFF"/>
                       </a:solidFill>
                       <a:prstDash val="solid"/>
                       <a:round/>
@@ -8097,7 +7662,7 @@
                     </a:lnR>
                     <a:lnT w="12700" cap="flat" cmpd="sng" algn="ctr">
                       <a:solidFill>
-                        <a:srgbClr val="0E1726"/>
+                        <a:srgbClr val="FFFFFF"/>
                       </a:solidFill>
                       <a:prstDash val="solid"/>
                       <a:round/>
@@ -8106,7 +7671,7 @@
                     </a:lnT>
                     <a:lnB w="12700" cap="flat" cmpd="sng" algn="ctr">
                       <a:solidFill>
-                        <a:srgbClr val="0E1726"/>
+                        <a:srgbClr val="FFFFFF"/>
                       </a:solidFill>
                       <a:prstDash val="solid"/>
                       <a:round/>
@@ -8140,7 +7705,7 @@
                   <a:tcPr marL="76200" marR="76200" marT="38100" marB="38100" anchor="ctr">
                     <a:lnL w="12700" cap="flat" cmpd="sng" algn="ctr">
                       <a:solidFill>
-                        <a:srgbClr val="0E1726"/>
+                        <a:srgbClr val="FFFFFF"/>
                       </a:solidFill>
                       <a:prstDash val="solid"/>
                       <a:round/>
@@ -8149,7 +7714,7 @@
                     </a:lnL>
                     <a:lnR w="12700" cap="flat" cmpd="sng" algn="ctr">
                       <a:solidFill>
-                        <a:srgbClr val="0E1726"/>
+                        <a:srgbClr val="FFFFFF"/>
                       </a:solidFill>
                       <a:prstDash val="solid"/>
                       <a:round/>
@@ -8158,7 +7723,7 @@
                     </a:lnR>
                     <a:lnT w="12700" cap="flat" cmpd="sng" algn="ctr">
                       <a:solidFill>
-                        <a:srgbClr val="0E1726"/>
+                        <a:srgbClr val="FFFFFF"/>
                       </a:solidFill>
                       <a:prstDash val="solid"/>
                       <a:round/>
@@ -8167,7 +7732,7 @@
                     </a:lnT>
                     <a:lnB w="12700" cap="flat" cmpd="sng" algn="ctr">
                       <a:solidFill>
-                        <a:srgbClr val="0E1726"/>
+                        <a:srgbClr val="FFFFFF"/>
                       </a:solidFill>
                       <a:prstDash val="solid"/>
                       <a:round/>
@@ -8201,7 +7766,7 @@
                   <a:tcPr marL="76200" marR="76200" marT="38100" marB="38100" anchor="ctr">
                     <a:lnL w="12700" cap="flat" cmpd="sng" algn="ctr">
                       <a:solidFill>
-                        <a:srgbClr val="0E1726"/>
+                        <a:srgbClr val="FFFFFF"/>
                       </a:solidFill>
                       <a:prstDash val="solid"/>
                       <a:round/>
@@ -8210,7 +7775,7 @@
                     </a:lnL>
                     <a:lnR w="12700" cap="flat" cmpd="sng" algn="ctr">
                       <a:solidFill>
-                        <a:srgbClr val="0E1726"/>
+                        <a:srgbClr val="FFFFFF"/>
                       </a:solidFill>
                       <a:prstDash val="solid"/>
                       <a:round/>
@@ -8219,7 +7784,7 @@
                     </a:lnR>
                     <a:lnT w="12700" cap="flat" cmpd="sng" algn="ctr">
                       <a:solidFill>
-                        <a:srgbClr val="0E1726"/>
+                        <a:srgbClr val="FFFFFF"/>
                       </a:solidFill>
                       <a:prstDash val="solid"/>
                       <a:round/>
@@ -8228,7 +7793,7 @@
                     </a:lnT>
                     <a:lnB w="12700" cap="flat" cmpd="sng" algn="ctr">
                       <a:solidFill>
-                        <a:srgbClr val="0E1726"/>
+                        <a:srgbClr val="FFFFFF"/>
                       </a:solidFill>
                       <a:prstDash val="solid"/>
                       <a:round/>
@@ -8253,7 +7818,7 @@
                       <a:r>
                         <a:rPr lang="en-US" sz="1200" dirty="0">
                           <a:solidFill>
-                            <a:srgbClr val="E6EDF3"/>
+                            <a:srgbClr val="1F2937"/>
                           </a:solidFill>
                         </a:rPr>
                         <a:t>S</a:t>
@@ -8264,7 +7829,7 @@
                   <a:tcPr marL="76200" marR="76200" marT="38100" marB="38100" anchor="ctr">
                     <a:lnL w="12700" cap="flat" cmpd="sng" algn="ctr">
                       <a:solidFill>
-                        <a:srgbClr val="0E1726"/>
+                        <a:srgbClr val="FFFFFF"/>
                       </a:solidFill>
                       <a:prstDash val="solid"/>
                       <a:round/>
@@ -8273,7 +7838,7 @@
                     </a:lnL>
                     <a:lnR w="12700" cap="flat" cmpd="sng" algn="ctr">
                       <a:solidFill>
-                        <a:srgbClr val="0E1726"/>
+                        <a:srgbClr val="FFFFFF"/>
                       </a:solidFill>
                       <a:prstDash val="solid"/>
                       <a:round/>
@@ -8282,7 +7847,7 @@
                     </a:lnR>
                     <a:lnT w="12700" cap="flat" cmpd="sng" algn="ctr">
                       <a:solidFill>
-                        <a:srgbClr val="0E1726"/>
+                        <a:srgbClr val="FFFFFF"/>
                       </a:solidFill>
                       <a:prstDash val="solid"/>
                       <a:round/>
@@ -8291,7 +7856,7 @@
                     </a:lnT>
                     <a:lnB w="12700" cap="flat" cmpd="sng" algn="ctr">
                       <a:solidFill>
-                        <a:srgbClr val="0E1726"/>
+                        <a:srgbClr val="FFFFFF"/>
                       </a:solidFill>
                       <a:prstDash val="solid"/>
                       <a:round/>
@@ -8299,7 +7864,7 @@
                       <a:tailEnd type="none" w="med" len="med"/>
                     </a:lnB>
                     <a:solidFill>
-                      <a:srgbClr val="18243A"/>
+                      <a:srgbClr val="F1F5F9"/>
                     </a:solidFill>
                   </a:tcPr>
                 </a:tc>
@@ -8314,7 +7879,7 @@
                       <a:r>
                         <a:rPr lang="en-US" sz="1200" dirty="0">
                           <a:solidFill>
-                            <a:srgbClr val="E6EDF3"/>
+                            <a:srgbClr val="1F2937"/>
                           </a:solidFill>
                         </a:rPr>
                         <a:t>Spoofing</a:t>
@@ -8325,7 +7890,7 @@
                   <a:tcPr marL="76200" marR="76200" marT="38100" marB="38100" anchor="ctr">
                     <a:lnL w="12700" cap="flat" cmpd="sng" algn="ctr">
                       <a:solidFill>
-                        <a:srgbClr val="0E1726"/>
+                        <a:srgbClr val="FFFFFF"/>
                       </a:solidFill>
                       <a:prstDash val="solid"/>
                       <a:round/>
@@ -8334,7 +7899,7 @@
                     </a:lnL>
                     <a:lnR w="12700" cap="flat" cmpd="sng" algn="ctr">
                       <a:solidFill>
-                        <a:srgbClr val="0E1726"/>
+                        <a:srgbClr val="FFFFFF"/>
                       </a:solidFill>
                       <a:prstDash val="solid"/>
                       <a:round/>
@@ -8343,7 +7908,7 @@
                     </a:lnR>
                     <a:lnT w="12700" cap="flat" cmpd="sng" algn="ctr">
                       <a:solidFill>
-                        <a:srgbClr val="0E1726"/>
+                        <a:srgbClr val="FFFFFF"/>
                       </a:solidFill>
                       <a:prstDash val="solid"/>
                       <a:round/>
@@ -8352,7 +7917,7 @@
                     </a:lnT>
                     <a:lnB w="12700" cap="flat" cmpd="sng" algn="ctr">
                       <a:solidFill>
-                        <a:srgbClr val="0E1726"/>
+                        <a:srgbClr val="FFFFFF"/>
                       </a:solidFill>
                       <a:prstDash val="solid"/>
                       <a:round/>
@@ -8360,7 +7925,7 @@
                       <a:tailEnd type="none" w="med" len="med"/>
                     </a:lnB>
                     <a:solidFill>
-                      <a:srgbClr val="18243A"/>
+                      <a:srgbClr val="F1F5F9"/>
                     </a:solidFill>
                   </a:tcPr>
                 </a:tc>
@@ -8375,7 +7940,7 @@
                       <a:r>
                         <a:rPr lang="en-US" sz="1200" dirty="0">
                           <a:solidFill>
-                            <a:srgbClr val="E6EDF3"/>
+                            <a:srgbClr val="1F2937"/>
                           </a:solidFill>
                         </a:rPr>
                         <a:t>Authentication</a:t>
@@ -8386,7 +7951,7 @@
                   <a:tcPr marL="76200" marR="76200" marT="38100" marB="38100" anchor="ctr">
                     <a:lnL w="12700" cap="flat" cmpd="sng" algn="ctr">
                       <a:solidFill>
-                        <a:srgbClr val="0E1726"/>
+                        <a:srgbClr val="FFFFFF"/>
                       </a:solidFill>
                       <a:prstDash val="solid"/>
                       <a:round/>
@@ -8395,7 +7960,7 @@
                     </a:lnL>
                     <a:lnR w="12700" cap="flat" cmpd="sng" algn="ctr">
                       <a:solidFill>
-                        <a:srgbClr val="0E1726"/>
+                        <a:srgbClr val="FFFFFF"/>
                       </a:solidFill>
                       <a:prstDash val="solid"/>
                       <a:round/>
@@ -8404,7 +7969,7 @@
                     </a:lnR>
                     <a:lnT w="12700" cap="flat" cmpd="sng" algn="ctr">
                       <a:solidFill>
-                        <a:srgbClr val="0E1726"/>
+                        <a:srgbClr val="FFFFFF"/>
                       </a:solidFill>
                       <a:prstDash val="solid"/>
                       <a:round/>
@@ -8413,7 +7978,7 @@
                     </a:lnT>
                     <a:lnB w="12700" cap="flat" cmpd="sng" algn="ctr">
                       <a:solidFill>
-                        <a:srgbClr val="0E1726"/>
+                        <a:srgbClr val="FFFFFF"/>
                       </a:solidFill>
                       <a:prstDash val="solid"/>
                       <a:round/>
@@ -8421,7 +7986,7 @@
                       <a:tailEnd type="none" w="med" len="med"/>
                     </a:lnB>
                     <a:solidFill>
-                      <a:srgbClr val="18243A"/>
+                      <a:srgbClr val="F1F5F9"/>
                     </a:solidFill>
                   </a:tcPr>
                 </a:tc>
@@ -8438,7 +8003,7 @@
                       <a:r>
                         <a:rPr lang="en-US" sz="1200" dirty="0">
                           <a:solidFill>
-                            <a:srgbClr val="E6EDF3"/>
+                            <a:srgbClr val="1F2937"/>
                           </a:solidFill>
                         </a:rPr>
                         <a:t>T</a:t>
@@ -8449,7 +8014,7 @@
                   <a:tcPr marL="76200" marR="76200" marT="38100" marB="38100" anchor="ctr">
                     <a:lnL w="12700" cap="flat" cmpd="sng" algn="ctr">
                       <a:solidFill>
-                        <a:srgbClr val="0E1726"/>
+                        <a:srgbClr val="FFFFFF"/>
                       </a:solidFill>
                       <a:prstDash val="solid"/>
                       <a:round/>
@@ -8458,7 +8023,7 @@
                     </a:lnL>
                     <a:lnR w="12700" cap="flat" cmpd="sng" algn="ctr">
                       <a:solidFill>
-                        <a:srgbClr val="0E1726"/>
+                        <a:srgbClr val="FFFFFF"/>
                       </a:solidFill>
                       <a:prstDash val="solid"/>
                       <a:round/>
@@ -8467,7 +8032,7 @@
                     </a:lnR>
                     <a:lnT w="12700" cap="flat" cmpd="sng" algn="ctr">
                       <a:solidFill>
-                        <a:srgbClr val="0E1726"/>
+                        <a:srgbClr val="FFFFFF"/>
                       </a:solidFill>
                       <a:prstDash val="solid"/>
                       <a:round/>
@@ -8476,7 +8041,7 @@
                     </a:lnT>
                     <a:lnB w="12700" cap="flat" cmpd="sng" algn="ctr">
                       <a:solidFill>
-                        <a:srgbClr val="0E1726"/>
+                        <a:srgbClr val="FFFFFF"/>
                       </a:solidFill>
                       <a:prstDash val="solid"/>
                       <a:round/>
@@ -8484,7 +8049,7 @@
                       <a:tailEnd type="none" w="med" len="med"/>
                     </a:lnB>
                     <a:solidFill>
-                      <a:srgbClr val="1E2B45"/>
+                      <a:srgbClr val="E8EDF3"/>
                     </a:solidFill>
                   </a:tcPr>
                 </a:tc>
@@ -8499,7 +8064,7 @@
                       <a:r>
                         <a:rPr lang="en-US" sz="1200" dirty="0">
                           <a:solidFill>
-                            <a:srgbClr val="E6EDF3"/>
+                            <a:srgbClr val="1F2937"/>
                           </a:solidFill>
                         </a:rPr>
                         <a:t>Tampering</a:t>
@@ -8510,7 +8075,7 @@
                   <a:tcPr marL="76200" marR="76200" marT="38100" marB="38100" anchor="ctr">
                     <a:lnL w="12700" cap="flat" cmpd="sng" algn="ctr">
                       <a:solidFill>
-                        <a:srgbClr val="0E1726"/>
+                        <a:srgbClr val="FFFFFF"/>
                       </a:solidFill>
                       <a:prstDash val="solid"/>
                       <a:round/>
@@ -8519,7 +8084,7 @@
                     </a:lnL>
                     <a:lnR w="12700" cap="flat" cmpd="sng" algn="ctr">
                       <a:solidFill>
-                        <a:srgbClr val="0E1726"/>
+                        <a:srgbClr val="FFFFFF"/>
                       </a:solidFill>
                       <a:prstDash val="solid"/>
                       <a:round/>
@@ -8528,7 +8093,7 @@
                     </a:lnR>
                     <a:lnT w="12700" cap="flat" cmpd="sng" algn="ctr">
                       <a:solidFill>
-                        <a:srgbClr val="0E1726"/>
+                        <a:srgbClr val="FFFFFF"/>
                       </a:solidFill>
                       <a:prstDash val="solid"/>
                       <a:round/>
@@ -8537,7 +8102,7 @@
                     </a:lnT>
                     <a:lnB w="12700" cap="flat" cmpd="sng" algn="ctr">
                       <a:solidFill>
-                        <a:srgbClr val="0E1726"/>
+                        <a:srgbClr val="FFFFFF"/>
                       </a:solidFill>
                       <a:prstDash val="solid"/>
                       <a:round/>
@@ -8545,7 +8110,7 @@
                       <a:tailEnd type="none" w="med" len="med"/>
                     </a:lnB>
                     <a:solidFill>
-                      <a:srgbClr val="1E2B45"/>
+                      <a:srgbClr val="E8EDF3"/>
                     </a:solidFill>
                   </a:tcPr>
                 </a:tc>
@@ -8560,7 +8125,7 @@
                       <a:r>
                         <a:rPr lang="en-US" sz="1200" dirty="0">
                           <a:solidFill>
-                            <a:srgbClr val="E6EDF3"/>
+                            <a:srgbClr val="1F2937"/>
                           </a:solidFill>
                         </a:rPr>
                         <a:t>Integrity</a:t>
@@ -8571,7 +8136,7 @@
                   <a:tcPr marL="76200" marR="76200" marT="38100" marB="38100" anchor="ctr">
                     <a:lnL w="12700" cap="flat" cmpd="sng" algn="ctr">
                       <a:solidFill>
-                        <a:srgbClr val="0E1726"/>
+                        <a:srgbClr val="FFFFFF"/>
                       </a:solidFill>
                       <a:prstDash val="solid"/>
                       <a:round/>
@@ -8580,7 +8145,7 @@
                     </a:lnL>
                     <a:lnR w="12700" cap="flat" cmpd="sng" algn="ctr">
                       <a:solidFill>
-                        <a:srgbClr val="0E1726"/>
+                        <a:srgbClr val="FFFFFF"/>
                       </a:solidFill>
                       <a:prstDash val="solid"/>
                       <a:round/>
@@ -8589,7 +8154,7 @@
                     </a:lnR>
                     <a:lnT w="12700" cap="flat" cmpd="sng" algn="ctr">
                       <a:solidFill>
-                        <a:srgbClr val="0E1726"/>
+                        <a:srgbClr val="FFFFFF"/>
                       </a:solidFill>
                       <a:prstDash val="solid"/>
                       <a:round/>
@@ -8598,7 +8163,7 @@
                     </a:lnT>
                     <a:lnB w="12700" cap="flat" cmpd="sng" algn="ctr">
                       <a:solidFill>
-                        <a:srgbClr val="0E1726"/>
+                        <a:srgbClr val="FFFFFF"/>
                       </a:solidFill>
                       <a:prstDash val="solid"/>
                       <a:round/>
@@ -8606,7 +8171,7 @@
                       <a:tailEnd type="none" w="med" len="med"/>
                     </a:lnB>
                     <a:solidFill>
-                      <a:srgbClr val="1E2B45"/>
+                      <a:srgbClr val="E8EDF3"/>
                     </a:solidFill>
                   </a:tcPr>
                 </a:tc>
@@ -8623,7 +8188,7 @@
                       <a:r>
                         <a:rPr lang="en-US" sz="1200" dirty="0">
                           <a:solidFill>
-                            <a:srgbClr val="E6EDF3"/>
+                            <a:srgbClr val="1F2937"/>
                           </a:solidFill>
                         </a:rPr>
                         <a:t>R</a:t>
@@ -8634,7 +8199,7 @@
                   <a:tcPr marL="76200" marR="76200" marT="38100" marB="38100" anchor="ctr">
                     <a:lnL w="12700" cap="flat" cmpd="sng" algn="ctr">
                       <a:solidFill>
-                        <a:srgbClr val="0E1726"/>
+                        <a:srgbClr val="FFFFFF"/>
                       </a:solidFill>
                       <a:prstDash val="solid"/>
                       <a:round/>
@@ -8643,7 +8208,7 @@
                     </a:lnL>
                     <a:lnR w="12700" cap="flat" cmpd="sng" algn="ctr">
                       <a:solidFill>
-                        <a:srgbClr val="0E1726"/>
+                        <a:srgbClr val="FFFFFF"/>
                       </a:solidFill>
                       <a:prstDash val="solid"/>
                       <a:round/>
@@ -8652,7 +8217,7 @@
                     </a:lnR>
                     <a:lnT w="12700" cap="flat" cmpd="sng" algn="ctr">
                       <a:solidFill>
-                        <a:srgbClr val="0E1726"/>
+                        <a:srgbClr val="FFFFFF"/>
                       </a:solidFill>
                       <a:prstDash val="solid"/>
                       <a:round/>
@@ -8661,7 +8226,7 @@
                     </a:lnT>
                     <a:lnB w="12700" cap="flat" cmpd="sng" algn="ctr">
                       <a:solidFill>
-                        <a:srgbClr val="0E1726"/>
+                        <a:srgbClr val="FFFFFF"/>
                       </a:solidFill>
                       <a:prstDash val="solid"/>
                       <a:round/>
@@ -8669,7 +8234,7 @@
                       <a:tailEnd type="none" w="med" len="med"/>
                     </a:lnB>
                     <a:solidFill>
-                      <a:srgbClr val="18243A"/>
+                      <a:srgbClr val="F1F5F9"/>
                     </a:solidFill>
                   </a:tcPr>
                 </a:tc>
@@ -8684,7 +8249,7 @@
                       <a:r>
                         <a:rPr lang="en-US" sz="1200" dirty="0">
                           <a:solidFill>
-                            <a:srgbClr val="E6EDF3"/>
+                            <a:srgbClr val="1F2937"/>
                           </a:solidFill>
                         </a:rPr>
                         <a:t>Repudiation</a:t>
@@ -8695,7 +8260,7 @@
                   <a:tcPr marL="76200" marR="76200" marT="38100" marB="38100" anchor="ctr">
                     <a:lnL w="12700" cap="flat" cmpd="sng" algn="ctr">
                       <a:solidFill>
-                        <a:srgbClr val="0E1726"/>
+                        <a:srgbClr val="FFFFFF"/>
                       </a:solidFill>
                       <a:prstDash val="solid"/>
                       <a:round/>
@@ -8704,7 +8269,7 @@
                     </a:lnL>
                     <a:lnR w="12700" cap="flat" cmpd="sng" algn="ctr">
                       <a:solidFill>
-                        <a:srgbClr val="0E1726"/>
+                        <a:srgbClr val="FFFFFF"/>
                       </a:solidFill>
                       <a:prstDash val="solid"/>
                       <a:round/>
@@ -8713,7 +8278,7 @@
                     </a:lnR>
                     <a:lnT w="12700" cap="flat" cmpd="sng" algn="ctr">
                       <a:solidFill>
-                        <a:srgbClr val="0E1726"/>
+                        <a:srgbClr val="FFFFFF"/>
                       </a:solidFill>
                       <a:prstDash val="solid"/>
                       <a:round/>
@@ -8722,7 +8287,7 @@
                     </a:lnT>
                     <a:lnB w="12700" cap="flat" cmpd="sng" algn="ctr">
                       <a:solidFill>
-                        <a:srgbClr val="0E1726"/>
+                        <a:srgbClr val="FFFFFF"/>
                       </a:solidFill>
                       <a:prstDash val="solid"/>
                       <a:round/>
@@ -8730,7 +8295,7 @@
                       <a:tailEnd type="none" w="med" len="med"/>
                     </a:lnB>
                     <a:solidFill>
-                      <a:srgbClr val="18243A"/>
+                      <a:srgbClr val="F1F5F9"/>
                     </a:solidFill>
                   </a:tcPr>
                 </a:tc>
@@ -8745,7 +8310,7 @@
                       <a:r>
                         <a:rPr lang="en-US" sz="1200" dirty="0">
                           <a:solidFill>
-                            <a:srgbClr val="E6EDF3"/>
+                            <a:srgbClr val="1F2937"/>
                           </a:solidFill>
                         </a:rPr>
                         <a:t>Non-repudiation</a:t>
@@ -8756,7 +8321,7 @@
                   <a:tcPr marL="76200" marR="76200" marT="38100" marB="38100" anchor="ctr">
                     <a:lnL w="12700" cap="flat" cmpd="sng" algn="ctr">
                       <a:solidFill>
-                        <a:srgbClr val="0E1726"/>
+                        <a:srgbClr val="FFFFFF"/>
                       </a:solidFill>
                       <a:prstDash val="solid"/>
                       <a:round/>
@@ -8765,7 +8330,7 @@
                     </a:lnL>
                     <a:lnR w="12700" cap="flat" cmpd="sng" algn="ctr">
                       <a:solidFill>
-                        <a:srgbClr val="0E1726"/>
+                        <a:srgbClr val="FFFFFF"/>
                       </a:solidFill>
                       <a:prstDash val="solid"/>
                       <a:round/>
@@ -8774,7 +8339,7 @@
                     </a:lnR>
                     <a:lnT w="12700" cap="flat" cmpd="sng" algn="ctr">
                       <a:solidFill>
-                        <a:srgbClr val="0E1726"/>
+                        <a:srgbClr val="FFFFFF"/>
                       </a:solidFill>
                       <a:prstDash val="solid"/>
                       <a:round/>
@@ -8783,7 +8348,7 @@
                     </a:lnT>
                     <a:lnB w="12700" cap="flat" cmpd="sng" algn="ctr">
                       <a:solidFill>
-                        <a:srgbClr val="0E1726"/>
+                        <a:srgbClr val="FFFFFF"/>
                       </a:solidFill>
                       <a:prstDash val="solid"/>
                       <a:round/>
@@ -8791,7 +8356,7 @@
                       <a:tailEnd type="none" w="med" len="med"/>
                     </a:lnB>
                     <a:solidFill>
-                      <a:srgbClr val="18243A"/>
+                      <a:srgbClr val="F1F5F9"/>
                     </a:solidFill>
                   </a:tcPr>
                 </a:tc>
@@ -8808,7 +8373,7 @@
                       <a:r>
                         <a:rPr lang="en-US" sz="1200" dirty="0">
                           <a:solidFill>
-                            <a:srgbClr val="E6EDF3"/>
+                            <a:srgbClr val="1F2937"/>
                           </a:solidFill>
                         </a:rPr>
                         <a:t>I</a:t>
@@ -8819,7 +8384,7 @@
                   <a:tcPr marL="76200" marR="76200" marT="38100" marB="38100" anchor="ctr">
                     <a:lnL w="12700" cap="flat" cmpd="sng" algn="ctr">
                       <a:solidFill>
-                        <a:srgbClr val="0E1726"/>
+                        <a:srgbClr val="FFFFFF"/>
                       </a:solidFill>
                       <a:prstDash val="solid"/>
                       <a:round/>
@@ -8828,7 +8393,7 @@
                     </a:lnL>
                     <a:lnR w="12700" cap="flat" cmpd="sng" algn="ctr">
                       <a:solidFill>
-                        <a:srgbClr val="0E1726"/>
+                        <a:srgbClr val="FFFFFF"/>
                       </a:solidFill>
                       <a:prstDash val="solid"/>
                       <a:round/>
@@ -8837,7 +8402,7 @@
                     </a:lnR>
                     <a:lnT w="12700" cap="flat" cmpd="sng" algn="ctr">
                       <a:solidFill>
-                        <a:srgbClr val="0E1726"/>
+                        <a:srgbClr val="FFFFFF"/>
                       </a:solidFill>
                       <a:prstDash val="solid"/>
                       <a:round/>
@@ -8846,7 +8411,7 @@
                     </a:lnT>
                     <a:lnB w="12700" cap="flat" cmpd="sng" algn="ctr">
                       <a:solidFill>
-                        <a:srgbClr val="0E1726"/>
+                        <a:srgbClr val="FFFFFF"/>
                       </a:solidFill>
                       <a:prstDash val="solid"/>
                       <a:round/>
@@ -8854,7 +8419,7 @@
                       <a:tailEnd type="none" w="med" len="med"/>
                     </a:lnB>
                     <a:solidFill>
-                      <a:srgbClr val="1E2B45"/>
+                      <a:srgbClr val="E8EDF3"/>
                     </a:solidFill>
                   </a:tcPr>
                 </a:tc>
@@ -8869,7 +8434,7 @@
                       <a:r>
                         <a:rPr lang="en-US" sz="1200" dirty="0">
                           <a:solidFill>
-                            <a:srgbClr val="E6EDF3"/>
+                            <a:srgbClr val="1F2937"/>
                           </a:solidFill>
                         </a:rPr>
                         <a:t>Information disclosure</a:t>
@@ -8880,7 +8445,7 @@
                   <a:tcPr marL="76200" marR="76200" marT="38100" marB="38100" anchor="ctr">
                     <a:lnL w="12700" cap="flat" cmpd="sng" algn="ctr">
                       <a:solidFill>
-                        <a:srgbClr val="0E1726"/>
+                        <a:srgbClr val="FFFFFF"/>
                       </a:solidFill>
                       <a:prstDash val="solid"/>
                       <a:round/>
@@ -8889,7 +8454,7 @@
                     </a:lnL>
                     <a:lnR w="12700" cap="flat" cmpd="sng" algn="ctr">
                       <a:solidFill>
-                        <a:srgbClr val="0E1726"/>
+                        <a:srgbClr val="FFFFFF"/>
                       </a:solidFill>
                       <a:prstDash val="solid"/>
                       <a:round/>
@@ -8898,7 +8463,7 @@
                     </a:lnR>
                     <a:lnT w="12700" cap="flat" cmpd="sng" algn="ctr">
                       <a:solidFill>
-                        <a:srgbClr val="0E1726"/>
+                        <a:srgbClr val="FFFFFF"/>
                       </a:solidFill>
                       <a:prstDash val="solid"/>
                       <a:round/>
@@ -8907,7 +8472,7 @@
                     </a:lnT>
                     <a:lnB w="12700" cap="flat" cmpd="sng" algn="ctr">
                       <a:solidFill>
-                        <a:srgbClr val="0E1726"/>
+                        <a:srgbClr val="FFFFFF"/>
                       </a:solidFill>
                       <a:prstDash val="solid"/>
                       <a:round/>
@@ -8915,7 +8480,7 @@
                       <a:tailEnd type="none" w="med" len="med"/>
                     </a:lnB>
                     <a:solidFill>
-                      <a:srgbClr val="1E2B45"/>
+                      <a:srgbClr val="E8EDF3"/>
                     </a:solidFill>
                   </a:tcPr>
                 </a:tc>
@@ -8930,7 +8495,7 @@
                       <a:r>
                         <a:rPr lang="en-US" sz="1200" dirty="0">
                           <a:solidFill>
-                            <a:srgbClr val="E6EDF3"/>
+                            <a:srgbClr val="1F2937"/>
                           </a:solidFill>
                         </a:rPr>
                         <a:t>Confidentiality</a:t>
@@ -8941,7 +8506,7 @@
                   <a:tcPr marL="76200" marR="76200" marT="38100" marB="38100" anchor="ctr">
                     <a:lnL w="12700" cap="flat" cmpd="sng" algn="ctr">
                       <a:solidFill>
-                        <a:srgbClr val="0E1726"/>
+                        <a:srgbClr val="FFFFFF"/>
                       </a:solidFill>
                       <a:prstDash val="solid"/>
                       <a:round/>
@@ -8950,7 +8515,7 @@
                     </a:lnL>
                     <a:lnR w="12700" cap="flat" cmpd="sng" algn="ctr">
                       <a:solidFill>
-                        <a:srgbClr val="0E1726"/>
+                        <a:srgbClr val="FFFFFF"/>
                       </a:solidFill>
                       <a:prstDash val="solid"/>
                       <a:round/>
@@ -8959,7 +8524,7 @@
                     </a:lnR>
                     <a:lnT w="12700" cap="flat" cmpd="sng" algn="ctr">
                       <a:solidFill>
-                        <a:srgbClr val="0E1726"/>
+                        <a:srgbClr val="FFFFFF"/>
                       </a:solidFill>
                       <a:prstDash val="solid"/>
                       <a:round/>
@@ -8968,7 +8533,7 @@
                     </a:lnT>
                     <a:lnB w="12700" cap="flat" cmpd="sng" algn="ctr">
                       <a:solidFill>
-                        <a:srgbClr val="0E1726"/>
+                        <a:srgbClr val="FFFFFF"/>
                       </a:solidFill>
                       <a:prstDash val="solid"/>
                       <a:round/>
@@ -8976,7 +8541,7 @@
                       <a:tailEnd type="none" w="med" len="med"/>
                     </a:lnB>
                     <a:solidFill>
-                      <a:srgbClr val="1E2B45"/>
+                      <a:srgbClr val="E8EDF3"/>
                     </a:solidFill>
                   </a:tcPr>
                 </a:tc>
@@ -8993,7 +8558,7 @@
                       <a:r>
                         <a:rPr lang="en-US" sz="1200" dirty="0">
                           <a:solidFill>
-                            <a:srgbClr val="E6EDF3"/>
+                            <a:srgbClr val="1F2937"/>
                           </a:solidFill>
                         </a:rPr>
                         <a:t>D</a:t>
@@ -9004,7 +8569,7 @@
                   <a:tcPr marL="76200" marR="76200" marT="38100" marB="38100" anchor="ctr">
                     <a:lnL w="12700" cap="flat" cmpd="sng" algn="ctr">
                       <a:solidFill>
-                        <a:srgbClr val="0E1726"/>
+                        <a:srgbClr val="FFFFFF"/>
                       </a:solidFill>
                       <a:prstDash val="solid"/>
                       <a:round/>
@@ -9013,7 +8578,7 @@
                     </a:lnL>
                     <a:lnR w="12700" cap="flat" cmpd="sng" algn="ctr">
                       <a:solidFill>
-                        <a:srgbClr val="0E1726"/>
+                        <a:srgbClr val="FFFFFF"/>
                       </a:solidFill>
                       <a:prstDash val="solid"/>
                       <a:round/>
@@ -9022,7 +8587,7 @@
                     </a:lnR>
                     <a:lnT w="12700" cap="flat" cmpd="sng" algn="ctr">
                       <a:solidFill>
-                        <a:srgbClr val="0E1726"/>
+                        <a:srgbClr val="FFFFFF"/>
                       </a:solidFill>
                       <a:prstDash val="solid"/>
                       <a:round/>
@@ -9031,7 +8596,7 @@
                     </a:lnT>
                     <a:lnB w="12700" cap="flat" cmpd="sng" algn="ctr">
                       <a:solidFill>
-                        <a:srgbClr val="0E1726"/>
+                        <a:srgbClr val="FFFFFF"/>
                       </a:solidFill>
                       <a:prstDash val="solid"/>
                       <a:round/>
@@ -9039,7 +8604,7 @@
                       <a:tailEnd type="none" w="med" len="med"/>
                     </a:lnB>
                     <a:solidFill>
-                      <a:srgbClr val="18243A"/>
+                      <a:srgbClr val="F1F5F9"/>
                     </a:solidFill>
                   </a:tcPr>
                 </a:tc>
@@ -9054,7 +8619,7 @@
                       <a:r>
                         <a:rPr lang="en-US" sz="1200" dirty="0">
                           <a:solidFill>
-                            <a:srgbClr val="E6EDF3"/>
+                            <a:srgbClr val="1F2937"/>
                           </a:solidFill>
                         </a:rPr>
                         <a:t>Denial of service</a:t>
@@ -9065,7 +8630,7 @@
                   <a:tcPr marL="76200" marR="76200" marT="38100" marB="38100" anchor="ctr">
                     <a:lnL w="12700" cap="flat" cmpd="sng" algn="ctr">
                       <a:solidFill>
-                        <a:srgbClr val="0E1726"/>
+                        <a:srgbClr val="FFFFFF"/>
                       </a:solidFill>
                       <a:prstDash val="solid"/>
                       <a:round/>
@@ -9074,7 +8639,7 @@
                     </a:lnL>
                     <a:lnR w="12700" cap="flat" cmpd="sng" algn="ctr">
                       <a:solidFill>
-                        <a:srgbClr val="0E1726"/>
+                        <a:srgbClr val="FFFFFF"/>
                       </a:solidFill>
                       <a:prstDash val="solid"/>
                       <a:round/>
@@ -9083,7 +8648,7 @@
                     </a:lnR>
                     <a:lnT w="12700" cap="flat" cmpd="sng" algn="ctr">
                       <a:solidFill>
-                        <a:srgbClr val="0E1726"/>
+                        <a:srgbClr val="FFFFFF"/>
                       </a:solidFill>
                       <a:prstDash val="solid"/>
                       <a:round/>
@@ -9092,7 +8657,7 @@
                     </a:lnT>
                     <a:lnB w="12700" cap="flat" cmpd="sng" algn="ctr">
                       <a:solidFill>
-                        <a:srgbClr val="0E1726"/>
+                        <a:srgbClr val="FFFFFF"/>
                       </a:solidFill>
                       <a:prstDash val="solid"/>
                       <a:round/>
@@ -9100,7 +8665,7 @@
                       <a:tailEnd type="none" w="med" len="med"/>
                     </a:lnB>
                     <a:solidFill>
-                      <a:srgbClr val="18243A"/>
+                      <a:srgbClr val="F1F5F9"/>
                     </a:solidFill>
                   </a:tcPr>
                 </a:tc>
@@ -9115,7 +8680,7 @@
                       <a:r>
                         <a:rPr lang="en-US" sz="1200" dirty="0">
                           <a:solidFill>
-                            <a:srgbClr val="E6EDF3"/>
+                            <a:srgbClr val="1F2937"/>
                           </a:solidFill>
                         </a:rPr>
                         <a:t>Availability</a:t>
@@ -9126,7 +8691,7 @@
                   <a:tcPr marL="76200" marR="76200" marT="38100" marB="38100" anchor="ctr">
                     <a:lnL w="12700" cap="flat" cmpd="sng" algn="ctr">
                       <a:solidFill>
-                        <a:srgbClr val="0E1726"/>
+                        <a:srgbClr val="FFFFFF"/>
                       </a:solidFill>
                       <a:prstDash val="solid"/>
                       <a:round/>
@@ -9135,7 +8700,7 @@
                     </a:lnL>
                     <a:lnR w="12700" cap="flat" cmpd="sng" algn="ctr">
                       <a:solidFill>
-                        <a:srgbClr val="0E1726"/>
+                        <a:srgbClr val="FFFFFF"/>
                       </a:solidFill>
                       <a:prstDash val="solid"/>
                       <a:round/>
@@ -9144,7 +8709,7 @@
                     </a:lnR>
                     <a:lnT w="12700" cap="flat" cmpd="sng" algn="ctr">
                       <a:solidFill>
-                        <a:srgbClr val="0E1726"/>
+                        <a:srgbClr val="FFFFFF"/>
                       </a:solidFill>
                       <a:prstDash val="solid"/>
                       <a:round/>
@@ -9153,7 +8718,7 @@
                     </a:lnT>
                     <a:lnB w="12700" cap="flat" cmpd="sng" algn="ctr">
                       <a:solidFill>
-                        <a:srgbClr val="0E1726"/>
+                        <a:srgbClr val="FFFFFF"/>
                       </a:solidFill>
                       <a:prstDash val="solid"/>
                       <a:round/>
@@ -9161,7 +8726,7 @@
                       <a:tailEnd type="none" w="med" len="med"/>
                     </a:lnB>
                     <a:solidFill>
-                      <a:srgbClr val="18243A"/>
+                      <a:srgbClr val="F1F5F9"/>
                     </a:solidFill>
                   </a:tcPr>
                 </a:tc>
@@ -9178,7 +8743,7 @@
                       <a:r>
                         <a:rPr lang="en-US" sz="1200" dirty="0">
                           <a:solidFill>
-                            <a:srgbClr val="E6EDF3"/>
+                            <a:srgbClr val="1F2937"/>
                           </a:solidFill>
                         </a:rPr>
                         <a:t>E</a:t>
@@ -9189,7 +8754,7 @@
                   <a:tcPr marL="76200" marR="76200" marT="38100" marB="38100" anchor="ctr">
                     <a:lnL w="12700" cap="flat" cmpd="sng" algn="ctr">
                       <a:solidFill>
-                        <a:srgbClr val="0E1726"/>
+                        <a:srgbClr val="FFFFFF"/>
                       </a:solidFill>
                       <a:prstDash val="solid"/>
                       <a:round/>
@@ -9198,7 +8763,7 @@
                     </a:lnL>
                     <a:lnR w="12700" cap="flat" cmpd="sng" algn="ctr">
                       <a:solidFill>
-                        <a:srgbClr val="0E1726"/>
+                        <a:srgbClr val="FFFFFF"/>
                       </a:solidFill>
                       <a:prstDash val="solid"/>
                       <a:round/>
@@ -9207,7 +8772,7 @@
                     </a:lnR>
                     <a:lnT w="12700" cap="flat" cmpd="sng" algn="ctr">
                       <a:solidFill>
-                        <a:srgbClr val="0E1726"/>
+                        <a:srgbClr val="FFFFFF"/>
                       </a:solidFill>
                       <a:prstDash val="solid"/>
                       <a:round/>
@@ -9216,7 +8781,7 @@
                     </a:lnT>
                     <a:lnB w="12700" cap="flat" cmpd="sng" algn="ctr">
                       <a:solidFill>
-                        <a:srgbClr val="0E1726"/>
+                        <a:srgbClr val="FFFFFF"/>
                       </a:solidFill>
                       <a:prstDash val="solid"/>
                       <a:round/>
@@ -9224,7 +8789,7 @@
                       <a:tailEnd type="none" w="med" len="med"/>
                     </a:lnB>
                     <a:solidFill>
-                      <a:srgbClr val="1E2B45"/>
+                      <a:srgbClr val="E8EDF3"/>
                     </a:solidFill>
                   </a:tcPr>
                 </a:tc>
@@ -9239,7 +8804,7 @@
                       <a:r>
                         <a:rPr lang="en-US" sz="1200" dirty="0">
                           <a:solidFill>
-                            <a:srgbClr val="E6EDF3"/>
+                            <a:srgbClr val="1F2937"/>
                           </a:solidFill>
                         </a:rPr>
                         <a:t>Elevation of privilege</a:t>
@@ -9250,7 +8815,7 @@
                   <a:tcPr marL="76200" marR="76200" marT="38100" marB="38100" anchor="ctr">
                     <a:lnL w="12700" cap="flat" cmpd="sng" algn="ctr">
                       <a:solidFill>
-                        <a:srgbClr val="0E1726"/>
+                        <a:srgbClr val="FFFFFF"/>
                       </a:solidFill>
                       <a:prstDash val="solid"/>
                       <a:round/>
@@ -9259,7 +8824,7 @@
                     </a:lnL>
                     <a:lnR w="12700" cap="flat" cmpd="sng" algn="ctr">
                       <a:solidFill>
-                        <a:srgbClr val="0E1726"/>
+                        <a:srgbClr val="FFFFFF"/>
                       </a:solidFill>
                       <a:prstDash val="solid"/>
                       <a:round/>
@@ -9268,7 +8833,7 @@
                     </a:lnR>
                     <a:lnT w="12700" cap="flat" cmpd="sng" algn="ctr">
                       <a:solidFill>
-                        <a:srgbClr val="0E1726"/>
+                        <a:srgbClr val="FFFFFF"/>
                       </a:solidFill>
                       <a:prstDash val="solid"/>
                       <a:round/>
@@ -9277,7 +8842,7 @@
                     </a:lnT>
                     <a:lnB w="12700" cap="flat" cmpd="sng" algn="ctr">
                       <a:solidFill>
-                        <a:srgbClr val="0E1726"/>
+                        <a:srgbClr val="FFFFFF"/>
                       </a:solidFill>
                       <a:prstDash val="solid"/>
                       <a:round/>
@@ -9285,7 +8850,7 @@
                       <a:tailEnd type="none" w="med" len="med"/>
                     </a:lnB>
                     <a:solidFill>
-                      <a:srgbClr val="1E2B45"/>
+                      <a:srgbClr val="E8EDF3"/>
                     </a:solidFill>
                   </a:tcPr>
                 </a:tc>
@@ -9300,7 +8865,7 @@
                       <a:r>
                         <a:rPr lang="en-US" sz="1200" dirty="0">
                           <a:solidFill>
-                            <a:srgbClr val="E6EDF3"/>
+                            <a:srgbClr val="1F2937"/>
                           </a:solidFill>
                         </a:rPr>
                         <a:t>Authorization</a:t>
@@ -9311,7 +8876,7 @@
                   <a:tcPr marL="76200" marR="76200" marT="38100" marB="38100" anchor="ctr">
                     <a:lnL w="12700" cap="flat" cmpd="sng" algn="ctr">
                       <a:solidFill>
-                        <a:srgbClr val="0E1726"/>
+                        <a:srgbClr val="FFFFFF"/>
                       </a:solidFill>
                       <a:prstDash val="solid"/>
                       <a:round/>
@@ -9320,7 +8885,7 @@
                     </a:lnL>
                     <a:lnR w="12700" cap="flat" cmpd="sng" algn="ctr">
                       <a:solidFill>
-                        <a:srgbClr val="0E1726"/>
+                        <a:srgbClr val="FFFFFF"/>
                       </a:solidFill>
                       <a:prstDash val="solid"/>
                       <a:round/>
@@ -9329,7 +8894,7 @@
                     </a:lnR>
                     <a:lnT w="12700" cap="flat" cmpd="sng" algn="ctr">
                       <a:solidFill>
-                        <a:srgbClr val="0E1726"/>
+                        <a:srgbClr val="FFFFFF"/>
                       </a:solidFill>
                       <a:prstDash val="solid"/>
                       <a:round/>
@@ -9338,7 +8903,7 @@
                     </a:lnT>
                     <a:lnB w="12700" cap="flat" cmpd="sng" algn="ctr">
                       <a:solidFill>
-                        <a:srgbClr val="0E1726"/>
+                        <a:srgbClr val="FFFFFF"/>
                       </a:solidFill>
                       <a:prstDash val="solid"/>
                       <a:round/>
@@ -9346,7 +8911,7 @@
                       <a:tailEnd type="none" w="med" len="med"/>
                     </a:lnB>
                     <a:solidFill>
-                      <a:srgbClr val="1E2B45"/>
+                      <a:srgbClr val="E8EDF3"/>
                     </a:solidFill>
                   </a:tcPr>
                 </a:tc>
@@ -9382,7 +8947,7 @@
             <a:r>
               <a:rPr lang="en-US" sz="900" dirty="0">
                 <a:solidFill>
-                  <a:srgbClr val="94A3B8"/>
+                  <a:srgbClr val="64748B"/>
                 </a:solidFill>
                 <a:latin typeface="Calibri" pitchFamily="34" charset="0"/>
                 <a:ea typeface="Calibri" pitchFamily="34" charset="-122"/>
@@ -9394,38 +8959,9 @@
           </a:p>
         </p:txBody>
       </p:sp>
-      <p:sp>
-        <p:nvSpPr>
-          <p:cNvPr id="7" name="Shape 3"/>
-          <p:cNvSpPr/>
-          <p:nvPr/>
-        </p:nvSpPr>
-        <p:spPr>
-          <a:xfrm>
-            <a:off x="7772400" y="4590288"/>
-            <a:ext cx="969264" cy="475488"/>
-          </a:xfrm>
-          <a:prstGeom prst="roundRect">
-            <a:avLst>
-              <a:gd name="adj" fmla="val 11538"/>
-            </a:avLst>
-          </a:prstGeom>
-          <a:solidFill>
-            <a:srgbClr val="FFFFFF"/>
-          </a:solidFill>
-          <a:ln/>
-          <a:effectLst>
-            <a:outerShdw sx="100000" sy="100000" kx="0" ky="0" algn="bl" rotWithShape="0" blurRad="101600" dist="38100" dir="5400000">
-              <a:srgbClr val="000000">
-                <a:alpha val="35000"/>
-              </a:srgbClr>
-            </a:outerShdw>
-          </a:effectLst>
-        </p:spPr>
-      </p:sp>
       <p:pic>
         <p:nvPicPr>
-          <p:cNvPr id="8" name="Image 1" descr="/Users/pop7/Library/CloudStorage/OneDrive-MonsterConnectCo.,Ltd/Lecture/KOSEN69 - software-security/slides/pptx/assets/logo-small.png">    </p:cNvPr>
+          <p:cNvPr id="7" name="Image 1" descr="/Users/pop7/Library/CloudStorage/OneDrive-MonsterConnectCo.,Ltd/Lecture/KOSEN69 - software-security/slides/pptx/assets/logo-small.png">    </p:cNvPr>
           <p:cNvPicPr>
             <a:picLocks noChangeAspect="1"/>
           </p:cNvPicPr>
@@ -9439,7 +8975,7 @@
         </p:blipFill>
         <p:spPr>
           <a:xfrm>
-            <a:off x="7872984" y="4681728"/>
+            <a:off x="7882128" y="4700016"/>
             <a:ext cx="768096" cy="356616"/>
           </a:xfrm>
           <a:prstGeom prst="rect">
@@ -9461,7 +8997,7 @@
     <p:bg>
       <p:bgPr>
         <a:solidFill>
-          <a:srgbClr val="0E1726"/>
+          <a:srgbClr val="FFFFFF"/>
         </a:solidFill>
       </p:bgPr>
     </p:bg>
@@ -9498,9 +9034,9 @@
           </a:solidFill>
           <a:ln/>
           <a:effectLst>
-            <a:outerShdw sx="100000" sy="100000" kx="0" ky="0" algn="bl" rotWithShape="0" blurRad="101600" dist="38100" dir="5400000">
+            <a:outerShdw sx="100000" sy="100000" kx="0" ky="0" algn="bl" rotWithShape="0" blurRad="76200" dist="25400" dir="5400000">
               <a:srgbClr val="000000">
-                <a:alpha val="35000"/>
+                <a:alpha val="12000"/>
               </a:srgbClr>
             </a:outerShdw>
           </a:effectLst>
@@ -9557,7 +9093,7 @@
             <a:r>
               <a:rPr lang="en-US" sz="2600" b="1" dirty="0">
                 <a:solidFill>
-                  <a:srgbClr val="E6EDF3"/>
+                  <a:srgbClr val="1F2937"/>
                 </a:solidFill>
                 <a:latin typeface="Arial" pitchFamily="34" charset="0"/>
                 <a:ea typeface="Arial" pitchFamily="34" charset="-122"/>
@@ -9586,13 +9122,13 @@
             </a:avLst>
           </a:prstGeom>
           <a:solidFill>
-            <a:srgbClr val="18243A"/>
+            <a:srgbClr val="F1F5F9"/>
           </a:solidFill>
           <a:ln/>
           <a:effectLst>
-            <a:outerShdw sx="100000" sy="100000" kx="0" ky="0" algn="bl" rotWithShape="0" blurRad="101600" dist="38100" dir="5400000">
+            <a:outerShdw sx="100000" sy="100000" kx="0" ky="0" algn="bl" rotWithShape="0" blurRad="76200" dist="25400" dir="5400000">
               <a:srgbClr val="000000">
-                <a:alpha val="35000"/>
+                <a:alpha val="12000"/>
               </a:srgbClr>
             </a:outerShdw>
           </a:effectLst>
@@ -9629,7 +9165,7 @@
             <a:r>
               <a:rPr lang="en-US" sz="1400" dirty="0">
                 <a:solidFill>
-                  <a:srgbClr val="E6EDF3"/>
+                  <a:srgbClr val="1F2937"/>
                 </a:solidFill>
                 <a:latin typeface="Calibri" pitchFamily="34" charset="0"/>
                 <a:ea typeface="Calibri" pitchFamily="34" charset="-122"/>
@@ -9650,7 +9186,7 @@
             <a:r>
               <a:rPr lang="en-US" sz="1400" dirty="0">
                 <a:solidFill>
-                  <a:srgbClr val="E6EDF3"/>
+                  <a:srgbClr val="1F2937"/>
                 </a:solidFill>
                 <a:latin typeface="Calibri" pitchFamily="34" charset="0"/>
                 <a:ea typeface="Calibri" pitchFamily="34" charset="-122"/>
@@ -9671,7 +9207,7 @@
             <a:r>
               <a:rPr lang="en-US" sz="1400" dirty="0">
                 <a:solidFill>
-                  <a:srgbClr val="E6EDF3"/>
+                  <a:srgbClr val="1F2937"/>
                 </a:solidFill>
                 <a:latin typeface="Calibri" pitchFamily="34" charset="0"/>
                 <a:ea typeface="Calibri" pitchFamily="34" charset="-122"/>
@@ -9692,7 +9228,7 @@
             <a:r>
               <a:rPr lang="en-US" sz="1400" dirty="0">
                 <a:solidFill>
-                  <a:srgbClr val="E6EDF3"/>
+                  <a:srgbClr val="1F2937"/>
                 </a:solidFill>
                 <a:latin typeface="Calibri" pitchFamily="34" charset="0"/>
                 <a:ea typeface="Calibri" pitchFamily="34" charset="-122"/>
@@ -9713,7 +9249,7 @@
             <a:r>
               <a:rPr lang="en-US" sz="1400" dirty="0">
                 <a:solidFill>
-                  <a:srgbClr val="E6EDF3"/>
+                  <a:srgbClr val="1F2937"/>
                 </a:solidFill>
                 <a:latin typeface="Calibri" pitchFamily="34" charset="0"/>
                 <a:ea typeface="Calibri" pitchFamily="34" charset="-122"/>
@@ -9734,7 +9270,7 @@
             <a:r>
               <a:rPr lang="en-US" sz="1400" dirty="0">
                 <a:solidFill>
-                  <a:srgbClr val="E6EDF3"/>
+                  <a:srgbClr val="1F2937"/>
                 </a:solidFill>
                 <a:latin typeface="Calibri" pitchFamily="34" charset="0"/>
                 <a:ea typeface="Calibri" pitchFamily="34" charset="-122"/>
@@ -9773,7 +9309,7 @@
             <a:r>
               <a:rPr lang="en-US" sz="900" dirty="0">
                 <a:solidFill>
-                  <a:srgbClr val="94A3B8"/>
+                  <a:srgbClr val="64748B"/>
                 </a:solidFill>
                 <a:latin typeface="Calibri" pitchFamily="34" charset="0"/>
                 <a:ea typeface="Calibri" pitchFamily="34" charset="-122"/>
@@ -9785,38 +9321,9 @@
           </a:p>
         </p:txBody>
       </p:sp>
-      <p:sp>
-        <p:nvSpPr>
-          <p:cNvPr id="8" name="Shape 5"/>
-          <p:cNvSpPr/>
-          <p:nvPr/>
-        </p:nvSpPr>
-        <p:spPr>
-          <a:xfrm>
-            <a:off x="7772400" y="4590288"/>
-            <a:ext cx="969264" cy="475488"/>
-          </a:xfrm>
-          <a:prstGeom prst="roundRect">
-            <a:avLst>
-              <a:gd name="adj" fmla="val 11538"/>
-            </a:avLst>
-          </a:prstGeom>
-          <a:solidFill>
-            <a:srgbClr val="FFFFFF"/>
-          </a:solidFill>
-          <a:ln/>
-          <a:effectLst>
-            <a:outerShdw sx="100000" sy="100000" kx="0" ky="0" algn="bl" rotWithShape="0" blurRad="101600" dist="38100" dir="5400000">
-              <a:srgbClr val="000000">
-                <a:alpha val="35000"/>
-              </a:srgbClr>
-            </a:outerShdw>
-          </a:effectLst>
-        </p:spPr>
-      </p:sp>
       <p:pic>
         <p:nvPicPr>
-          <p:cNvPr id="9" name="Image 1" descr="/Users/pop7/Library/CloudStorage/OneDrive-MonsterConnectCo.,Ltd/Lecture/KOSEN69 - software-security/slides/pptx/assets/logo-small.png">    </p:cNvPr>
+          <p:cNvPr id="8" name="Image 1" descr="/Users/pop7/Library/CloudStorage/OneDrive-MonsterConnectCo.,Ltd/Lecture/KOSEN69 - software-security/slides/pptx/assets/logo-small.png">    </p:cNvPr>
           <p:cNvPicPr>
             <a:picLocks noChangeAspect="1"/>
           </p:cNvPicPr>
@@ -9830,7 +9337,7 @@
         </p:blipFill>
         <p:spPr>
           <a:xfrm>
-            <a:off x="7872984" y="4681728"/>
+            <a:off x="7882128" y="4700016"/>
             <a:ext cx="768096" cy="356616"/>
           </a:xfrm>
           <a:prstGeom prst="rect">

</xml_diff>

<commit_message>
Add worksheet pointer (name + number + kickoff) to each deck's lab slide
Slides now point to the worksheet as the source of truth instead of duplicating the
full lab guide (which had drifted — e.g. W4's slide showed DVWA while the worksheet
uses docker compose). Each teaching deck's lab/deliverable slide gets one callout with
the correct worksheet file, "Worksheet N", and the lab's actual kickoff command:

- W1-6,10: docker compose up (+ correct ports); W2: bash scan.sh; W3: docker compose up;
  W11: clang -fsanitize=fuzzer …; W12: bash sca_scan.sh; W13: bash scan.sh;
  W14: compose :6000/:6001; W15: push security-ci.yml.
- W4 lab-steps DVWA block relabelled "optional extra target" to match the worksheet.

Rebuilt all 12 decks; callout renders as a clean highlighted line, no overflow.

Co-Authored-By: Claude Opus 4.8 <noreply@anthropic.com>
</commit_message>
<xml_diff>
--- a/slides/pptx/week01.pptx
+++ b/slides/pptx/week01.pptx
@@ -4110,7 +4110,68 @@
         </p:nvSpPr>
         <p:spPr>
           <a:xfrm>
-            <a:off x="502920" y="1325880"/>
+            <a:off x="457200" y="1325880"/>
+            <a:ext cx="8229600" cy="822960"/>
+          </a:xfrm>
+          <a:prstGeom prst="roundRect">
+            <a:avLst>
+              <a:gd name="adj" fmla="val 8889"/>
+            </a:avLst>
+          </a:prstGeom>
+          <a:solidFill>
+            <a:srgbClr val="E8EDF3"/>
+          </a:solidFill>
+          <a:ln/>
+        </p:spPr>
+      </p:sp>
+      <p:sp>
+        <p:nvSpPr>
+          <p:cNvPr id="6" name="Text 3"/>
+          <p:cNvSpPr/>
+          <p:nvPr/>
+        </p:nvSpPr>
+        <p:spPr>
+          <a:xfrm>
+            <a:off x="731520" y="1325880"/>
+            <a:ext cx="7680960" cy="822960"/>
+          </a:xfrm>
+          <a:prstGeom prst="rect">
+            <a:avLst/>
+          </a:prstGeom>
+          <a:noFill/>
+          <a:ln/>
+        </p:spPr>
+        <p:txBody>
+          <a:bodyPr wrap="square" lIns="0" tIns="0" rIns="0" bIns="0" rtlCol="0" anchor="ctr"/>
+          <a:lstStyle/>
+          <a:p>
+            <a:pPr indent="0" marL="0">
+              <a:buNone/>
+            </a:pPr>
+            <a:r>
+              <a:rPr lang="en-US" sz="1400" i="1" dirty="0">
+                <a:solidFill>
+                  <a:srgbClr val="E35205"/>
+                </a:solidFill>
+                <a:latin typeface="Calibri" pitchFamily="34" charset="0"/>
+                <a:ea typeface="Calibri" pitchFamily="34" charset="-122"/>
+                <a:cs typeface="Calibri" pitchFamily="34" charset="-120"/>
+              </a:rPr>
+              <a:t>📋 Worksheet 1 — labs/week01-threat-modeling/worksheet.md (Part 3) · kickoff: docker compose up → http://localhost:5000</a:t>
+            </a:r>
+            <a:endParaRPr lang="en-US" sz="1400" dirty="0"/>
+          </a:p>
+        </p:txBody>
+      </p:sp>
+      <p:sp>
+        <p:nvSpPr>
+          <p:cNvPr id="7" name="Shape 4"/>
+          <p:cNvSpPr/>
+          <p:nvPr/>
+        </p:nvSpPr>
+        <p:spPr>
+          <a:xfrm>
+            <a:off x="502920" y="2313432"/>
             <a:ext cx="384048" cy="384048"/>
           </a:xfrm>
           <a:prstGeom prst="ellipse">
@@ -4124,13 +4185,13 @@
       </p:sp>
       <p:sp>
         <p:nvSpPr>
-          <p:cNvPr id="6" name="Text 3"/>
-          <p:cNvSpPr/>
-          <p:nvPr/>
-        </p:nvSpPr>
-        <p:spPr>
-          <a:xfrm>
-            <a:off x="502920" y="1325880"/>
+          <p:cNvPr id="8" name="Text 5"/>
+          <p:cNvSpPr/>
+          <p:nvPr/>
+        </p:nvSpPr>
+        <p:spPr>
+          <a:xfrm>
+            <a:off x="502920" y="2313432"/>
             <a:ext cx="384048" cy="384048"/>
           </a:xfrm>
           <a:prstGeom prst="rect">
@@ -4163,13 +4224,13 @@
       </p:sp>
       <p:sp>
         <p:nvSpPr>
-          <p:cNvPr id="7" name="Text 4"/>
-          <p:cNvSpPr/>
-          <p:nvPr/>
-        </p:nvSpPr>
-        <p:spPr>
-          <a:xfrm>
-            <a:off x="1051560" y="1325880"/>
+          <p:cNvPr id="9" name="Text 6"/>
+          <p:cNvSpPr/>
+          <p:nvPr/>
+        </p:nvSpPr>
+        <p:spPr>
+          <a:xfrm>
+            <a:off x="1051560" y="2313432"/>
             <a:ext cx="7589520" cy="384048"/>
           </a:xfrm>
           <a:prstGeom prst="rect">
@@ -4202,13 +4263,13 @@
       </p:sp>
       <p:sp>
         <p:nvSpPr>
-          <p:cNvPr id="8" name="Shape 5"/>
-          <p:cNvSpPr/>
-          <p:nvPr/>
-        </p:nvSpPr>
-        <p:spPr>
-          <a:xfrm>
-            <a:off x="502920" y="1783080"/>
+          <p:cNvPr id="10" name="Shape 7"/>
+          <p:cNvSpPr/>
+          <p:nvPr/>
+        </p:nvSpPr>
+        <p:spPr>
+          <a:xfrm>
+            <a:off x="502920" y="2770632"/>
             <a:ext cx="384048" cy="384048"/>
           </a:xfrm>
           <a:prstGeom prst="ellipse">
@@ -4222,13 +4283,13 @@
       </p:sp>
       <p:sp>
         <p:nvSpPr>
-          <p:cNvPr id="9" name="Text 6"/>
-          <p:cNvSpPr/>
-          <p:nvPr/>
-        </p:nvSpPr>
-        <p:spPr>
-          <a:xfrm>
-            <a:off x="502920" y="1783080"/>
+          <p:cNvPr id="11" name="Text 8"/>
+          <p:cNvSpPr/>
+          <p:nvPr/>
+        </p:nvSpPr>
+        <p:spPr>
+          <a:xfrm>
+            <a:off x="502920" y="2770632"/>
             <a:ext cx="384048" cy="384048"/>
           </a:xfrm>
           <a:prstGeom prst="rect">
@@ -4261,13 +4322,13 @@
       </p:sp>
       <p:sp>
         <p:nvSpPr>
-          <p:cNvPr id="10" name="Text 7"/>
-          <p:cNvSpPr/>
-          <p:nvPr/>
-        </p:nvSpPr>
-        <p:spPr>
-          <a:xfrm>
-            <a:off x="1051560" y="1783080"/>
+          <p:cNvPr id="12" name="Text 9"/>
+          <p:cNvSpPr/>
+          <p:nvPr/>
+        </p:nvSpPr>
+        <p:spPr>
+          <a:xfrm>
+            <a:off x="1051560" y="2770632"/>
             <a:ext cx="7589520" cy="384048"/>
           </a:xfrm>
           <a:prstGeom prst="rect">
@@ -4300,13 +4361,13 @@
       </p:sp>
       <p:sp>
         <p:nvSpPr>
-          <p:cNvPr id="11" name="Shape 8"/>
-          <p:cNvSpPr/>
-          <p:nvPr/>
-        </p:nvSpPr>
-        <p:spPr>
-          <a:xfrm>
-            <a:off x="502920" y="2240280"/>
+          <p:cNvPr id="13" name="Shape 10"/>
+          <p:cNvSpPr/>
+          <p:nvPr/>
+        </p:nvSpPr>
+        <p:spPr>
+          <a:xfrm>
+            <a:off x="502920" y="3227832"/>
             <a:ext cx="384048" cy="384048"/>
           </a:xfrm>
           <a:prstGeom prst="ellipse">
@@ -4320,13 +4381,13 @@
       </p:sp>
       <p:sp>
         <p:nvSpPr>
-          <p:cNvPr id="12" name="Text 9"/>
-          <p:cNvSpPr/>
-          <p:nvPr/>
-        </p:nvSpPr>
-        <p:spPr>
-          <a:xfrm>
-            <a:off x="502920" y="2240280"/>
+          <p:cNvPr id="14" name="Text 11"/>
+          <p:cNvSpPr/>
+          <p:nvPr/>
+        </p:nvSpPr>
+        <p:spPr>
+          <a:xfrm>
+            <a:off x="502920" y="3227832"/>
             <a:ext cx="384048" cy="384048"/>
           </a:xfrm>
           <a:prstGeom prst="rect">
@@ -4359,13 +4420,13 @@
       </p:sp>
       <p:sp>
         <p:nvSpPr>
-          <p:cNvPr id="13" name="Text 10"/>
-          <p:cNvSpPr/>
-          <p:nvPr/>
-        </p:nvSpPr>
-        <p:spPr>
-          <a:xfrm>
-            <a:off x="1051560" y="2240280"/>
+          <p:cNvPr id="15" name="Text 12"/>
+          <p:cNvSpPr/>
+          <p:nvPr/>
+        </p:nvSpPr>
+        <p:spPr>
+          <a:xfrm>
+            <a:off x="1051560" y="3227832"/>
             <a:ext cx="7589520" cy="384048"/>
           </a:xfrm>
           <a:prstGeom prst="rect">
@@ -4398,13 +4459,13 @@
       </p:sp>
       <p:sp>
         <p:nvSpPr>
-          <p:cNvPr id="14" name="Shape 11"/>
-          <p:cNvSpPr/>
-          <p:nvPr/>
-        </p:nvSpPr>
-        <p:spPr>
-          <a:xfrm>
-            <a:off x="502920" y="2697480"/>
+          <p:cNvPr id="16" name="Shape 13"/>
+          <p:cNvSpPr/>
+          <p:nvPr/>
+        </p:nvSpPr>
+        <p:spPr>
+          <a:xfrm>
+            <a:off x="502920" y="3685032"/>
             <a:ext cx="384048" cy="384048"/>
           </a:xfrm>
           <a:prstGeom prst="ellipse">
@@ -4418,13 +4479,13 @@
       </p:sp>
       <p:sp>
         <p:nvSpPr>
-          <p:cNvPr id="15" name="Text 12"/>
-          <p:cNvSpPr/>
-          <p:nvPr/>
-        </p:nvSpPr>
-        <p:spPr>
-          <a:xfrm>
-            <a:off x="502920" y="2697480"/>
+          <p:cNvPr id="17" name="Text 14"/>
+          <p:cNvSpPr/>
+          <p:nvPr/>
+        </p:nvSpPr>
+        <p:spPr>
+          <a:xfrm>
+            <a:off x="502920" y="3685032"/>
             <a:ext cx="384048" cy="384048"/>
           </a:xfrm>
           <a:prstGeom prst="rect">
@@ -4457,13 +4518,13 @@
       </p:sp>
       <p:sp>
         <p:nvSpPr>
-          <p:cNvPr id="16" name="Text 13"/>
-          <p:cNvSpPr/>
-          <p:nvPr/>
-        </p:nvSpPr>
-        <p:spPr>
-          <a:xfrm>
-            <a:off x="1051560" y="2697480"/>
+          <p:cNvPr id="18" name="Text 15"/>
+          <p:cNvSpPr/>
+          <p:nvPr/>
+        </p:nvSpPr>
+        <p:spPr>
+          <a:xfrm>
+            <a:off x="1051560" y="3685032"/>
             <a:ext cx="7589520" cy="384048"/>
           </a:xfrm>
           <a:prstGeom prst="rect">
@@ -4496,14 +4557,14 @@
       </p:sp>
       <p:sp>
         <p:nvSpPr>
-          <p:cNvPr id="17" name="Text 14"/>
-          <p:cNvSpPr/>
-          <p:nvPr/>
-        </p:nvSpPr>
-        <p:spPr>
-          <a:xfrm>
-            <a:off x="548640" y="3246120"/>
-            <a:ext cx="8046720" cy="548640"/>
+          <p:cNvPr id="19" name="Text 16"/>
+          <p:cNvSpPr/>
+          <p:nvPr/>
+        </p:nvSpPr>
+        <p:spPr>
+          <a:xfrm>
+            <a:off x="457200" y="4800600"/>
+            <a:ext cx="6949440" cy="274320"/>
           </a:xfrm>
           <a:prstGeom prst="rect">
             <a:avLst/>
@@ -4512,60 +4573,21 @@
           <a:ln/>
         </p:spPr>
         <p:txBody>
-          <a:bodyPr wrap="square" lIns="0" tIns="0" rIns="0" bIns="0" rtlCol="0" anchor="t"/>
+          <a:bodyPr wrap="square" lIns="0" tIns="0" rIns="0" bIns="0" rtlCol="0" anchor="ctr"/>
           <a:lstStyle/>
           <a:p>
             <a:pPr indent="0" marL="0">
               <a:buNone/>
             </a:pPr>
             <a:r>
-              <a:rPr lang="en-US" sz="1400" dirty="0">
-                <a:solidFill>
-                  <a:srgbClr val="1F2937"/>
+              <a:rPr lang="en-US" sz="900" dirty="0">
+                <a:solidFill>
+                  <a:srgbClr val="64748B"/>
                 </a:solidFill>
                 <a:latin typeface="Calibri" pitchFamily="34" charset="0"/>
                 <a:ea typeface="Calibri" pitchFamily="34" charset="-122"/>
                 <a:cs typeface="Calibri" pitchFamily="34" charset="-120"/>
               </a:rPr>
-              <a:t>Deliverable: 2–3 page threat model</a:t>
-            </a:r>
-            <a:endParaRPr lang="en-US" sz="1400" dirty="0"/>
-          </a:p>
-        </p:txBody>
-      </p:sp>
-      <p:sp>
-        <p:nvSpPr>
-          <p:cNvPr id="18" name="Text 15"/>
-          <p:cNvSpPr/>
-          <p:nvPr/>
-        </p:nvSpPr>
-        <p:spPr>
-          <a:xfrm>
-            <a:off x="457200" y="4800600"/>
-            <a:ext cx="6949440" cy="274320"/>
-          </a:xfrm>
-          <a:prstGeom prst="rect">
-            <a:avLst/>
-          </a:prstGeom>
-          <a:noFill/>
-          <a:ln/>
-        </p:spPr>
-        <p:txBody>
-          <a:bodyPr wrap="square" lIns="0" tIns="0" rIns="0" bIns="0" rtlCol="0" anchor="ctr"/>
-          <a:lstStyle/>
-          <a:p>
-            <a:pPr indent="0" marL="0">
-              <a:buNone/>
-            </a:pPr>
-            <a:r>
-              <a:rPr lang="en-US" sz="900" dirty="0">
-                <a:solidFill>
-                  <a:srgbClr val="64748B"/>
-                </a:solidFill>
-                <a:latin typeface="Calibri" pitchFamily="34" charset="0"/>
-                <a:ea typeface="Calibri" pitchFamily="34" charset="-122"/>
-                <a:cs typeface="Calibri" pitchFamily="34" charset="-120"/>
-              </a:rPr>
               <a:t>Software Security · Week 1</a:t>
             </a:r>
             <a:endParaRPr lang="en-US" sz="900" dirty="0"/>
@@ -4574,7 +4596,7 @@
       </p:sp>
       <p:pic>
         <p:nvPicPr>
-          <p:cNvPr id="19" name="Image 1" descr="/Users/pop7/Library/CloudStorage/OneDrive-MonsterConnectCo.,Ltd/Lecture/KOSEN69 - software-security/slides/pptx/assets/logo-small.png">    </p:cNvPr>
+          <p:cNvPr id="20" name="Image 1" descr="/Users/pop7/Library/CloudStorage/OneDrive-MonsterConnectCo.,Ltd/Lecture/KOSEN69 - software-security/slides/pptx/assets/logo-small.png">    </p:cNvPr>
           <p:cNvPicPr>
             <a:picLocks noChangeAspect="1"/>
           </p:cNvPicPr>

</xml_diff>